<commit_message>
The VaR engine deck corrected: VaR and exposure inputs on Iceberg are not built (only the Delta plugin streams vectors), official publishing to s3:// is not built (local or EFS Delta root); both in the gap list
</commit_message>
<xml_diff>
--- a/docs/publications/Drishti-VaR-Engine.pptx
+++ b/docs/publications/Drishti-VaR-Engine.pptx
@@ -1232,7 +1232,7 @@
           <a:lstStyle/>
           <a:p>
             <a:r>
-              <a:t>Built, designed, proposed. Sources: VAR_GUIDE.md section 15.1 (partitioned by business_date only; 7-year log and file retention, time travel; 'Design differs': the sort by legal entity, desk, book and position, the partition by scenario set, 512 MB files, BYTE_STREAM_SPLIT and ZSTD are designed, not built; open question 7), section 29 (the vector grain, the four layouts compared: list&lt;double&gt; chosen; a fixed-length binary blob rejected for interoperability; deletion vectors avoided; the append-only daily snapshot), section 29.3 (Iceberg --store iceberg with the same list&lt;double&gt; column), section 30 (cubes and rule-portfolio vectors designed, kept in memory; the overnight precomputation not built), section 19 ('No vectors and no trade or position rows are published'; a publish to an s3:// root fails and is recorded as publishError), section 28 (sharding: the mechanism is not in place; each server holds whole dates; the plan: shard map by legal entity and desk with two owners each, POST /api/v1/var/partial, partial float64 vectors added in a fixed order), section 20.3 (only the first 100,000 hierarchy nodes or portfolios are read from a connector that cannot list a date whole), section 8.4 (intraday appends); LAKE_MAINTENANCE.md (compaction, checkpoint, vacuum; never below 7 years for risk domains); DELTA_CONNECTOR.md (file statistics kept on the id, the date and promoted columns via delta.dataSkippingStatsColumns; OPTIMIZE ZORDER or liquid clustering mentioned only as a Databricks option); the AWS deck and AWS_DELTA_LAKE.md (reading Delta in S3 built; lake publish built; AWS scripts dry-run tested, first real run pending); NET.md (Drishti*net: gossip membership, capability digest, replicas and shards for entity reads, view and data forwarding, the console's backend.urls with discovery and failover, one token secret across nodes); LIVE.md and IMPLEMENTATION_PLAN.md known gaps (the workers of one console relay a channel's calls to the worker that holds it; several console processes behind a load balancer need sticky sessions); CONFIGURATION.md (DRISHTI_SESSION_SECRET).</a:t>
+              <a:t>Built, designed, proposed. Sources: VAR_GUIDE.md section 15.1 (partitioned by business_date only; 7-year log and file retention, time travel; 'Design differs': the sort by legal entity, desk, book and position, the partition by scenario set, 512 MB files, BYTE_STREAM_SPLIT and ZSTD are designed, not built; open question 7), section 29 (the vector grain, the four layouts compared: list&lt;double&gt; chosen; a fixed-length binary blob rejected for interoperability; deletion vectors avoided; the append-only daily snapshot), section 29.3 (the lake tools can write the list&lt;double&gt; column to Iceberg, but only the Delta plugin implements SourcePlugin.vectors(), so VaR and exposure cannot read their inputs from Iceberg today: not built, per the Iceberg review of the code), section 30 (cubes and rule-portfolio vectors designed, kept in memory; the overnight precomputation not built), section 19 ('No vectors and no trade or position rows are published'; a publish to an s3:// root fails and is recorded as publishError), section 28 (sharding: the mechanism is not in place; each server holds whole dates; the plan: shard map by legal entity and desk with two owners each, POST /api/v1/var/partial, partial float64 vectors added in a fixed order), section 20.3 (only the first 100,000 hierarchy nodes or portfolios are read from a connector that cannot list a date whole), section 8.4 (intraday appends); LAKE_MAINTENANCE.md (compaction, checkpoint, vacuum; never below 7 years for risk domains); DELTA_CONNECTOR.md (file statistics kept on the id, the date and promoted columns via delta.dataSkippingStatsColumns; OPTIMIZE ZORDER or liquid clustering mentioned only as a Databricks option); the AWS deck and AWS_DELTA_LAKE.md (reading Delta in S3 built; lake publish built; AWS scripts dry-run tested, first real run pending); NET.md (Drishti*net: gossip membership, capability digest, replicas and shards for entity reads, view and data forwarding, the console's backend.urls with discovery and failover, one token secret across nodes); LIVE.md and IMPLEMENTATION_PLAN.md known gaps (the workers of one console relay a channel's calls to the worker that holds it; several console processes behind a load balancer need sticky sessions); CONFIGURATION.md (DRISHTI_SESSION_SECRET).</a:t>
             </a:r>
           </a:p>
           <a:p/>
@@ -1256,7 +1256,7 @@
           <a:p/>
           <a:p>
             <a:r>
-              <a:t>The gap list in full: (1) run the 1M × 50 benchmark (and 1.3M × 60) on a real server, including a cold first touch of a history date; (2) build VaR sharding across Drishti*net; (3) the lake layout at bank scale (sort by hierarchy, partition by scenario set, file and row-group sizes, BYTE_STREAM_SPLIT + ZSTD); (4) a batch that builds every portfolio vector (the designed overnight precomputation), raise the 100,000-row read limit for portfolios and nodes, and size max-parts (5,000) for contribution tables; (5) official results to an s3:// root; (6) several consoles without sticky sessions. Position grain and Kafka micro-batching are built in 2.9.4 and no longer gaps.</a:t>
+              <a:t>The gap list in full: (1) run the 1M × 50 benchmark (and 1.3M × 60) on a real server, including a cold first touch of a history date; (2) build VaR sharding across Drishti*net; (3) the lake layout at bank scale (sort by hierarchy, partition by scenario set, file and row-group sizes, BYTE_STREAM_SPLIT + ZSTD); (4) a batch that builds every portfolio vector (the designed overnight precomputation), raise the 100,000-row read limit for portfolios and nodes, and size max-parts (5,000) for contribution tables; (5) Iceberg for VaR and exposure inputs (SourcePlugin.vectors() in the Iceberg plugin); (6) official results published to an s3:// root (today a local or EFS Delta root only; an s3:// root fails and is recorded as publishError); (7) several consoles without sticky sessions. Position grain and Kafka micro-batching are built in 2.9.4 and no longer gaps.</a:t>
             </a:r>
           </a:p>
         </p:txBody>
@@ -9535,7 +9535,7 @@
                   <a:srgbClr val="FFFFFF"/>
                 </a:solidFill>
               </a:rPr>
-              <a:t>Lake · Delta or Iceberg</a:t>
+              <a:t>Lake · Delta</a:t>
             </a:r>
           </a:p>
           <a:p>
@@ -10290,7 +10290,7 @@
                   <a:srgbClr val="4A5058"/>
                 </a:solidFill>
               </a:rPr>
-              <a:t>Drishti*net replicas; VaR sharding designed; Delta, Iceberg, S3</a:t>
+              <a:t>Drishti*net replicas; VaR sharding designed; Delta history</a:t>
             </a:r>
           </a:p>
         </p:txBody>
@@ -14513,7 +14513,7 @@
         <p:spPr>
           <a:xfrm>
             <a:off x="777240" y="1417320"/>
-            <a:ext cx="5989320" cy="379476"/>
+            <a:ext cx="5989320" cy="342900"/>
           </a:xfrm>
           <a:prstGeom prst="rect">
             <a:avLst/>
@@ -14559,7 +14559,7 @@
         <p:spPr>
           <a:xfrm>
             <a:off x="868680" y="1417320"/>
-            <a:ext cx="4800600" cy="379476"/>
+            <a:ext cx="4800600" cy="342900"/>
           </a:xfrm>
           <a:prstGeom prst="rect">
             <a:avLst/>
@@ -14579,7 +14579,7 @@
                   <a:srgbClr val="8A1626"/>
                 </a:solidFill>
               </a:rPr>
-              <a:t>Partition by business_date</a:t>
+              <a:t>Partition by business_date; 7 years of time travel</a:t>
             </a:r>
           </a:p>
           <a:p>
@@ -14590,7 +14590,7 @@
                   <a:srgbClr val="4A5058"/>
                 </a:solidFill>
               </a:rPr>
-              <a:t>a full run replaces its date; intraday batches append</a:t>
+              <a:t>full run replaces a date; restatement = new commit</a:t>
             </a:r>
           </a:p>
         </p:txBody>
@@ -14603,7 +14603,7 @@
         </p:nvSpPr>
         <p:spPr>
           <a:xfrm>
-            <a:off x="6213348" y="1506474"/>
+            <a:off x="6213348" y="1488186"/>
             <a:ext cx="461772" cy="201168"/>
           </a:xfrm>
           <a:prstGeom prst="roundRect">
@@ -14659,8 +14659,8 @@
         </p:nvSpPr>
         <p:spPr>
           <a:xfrm>
-            <a:off x="777240" y="1828800"/>
-            <a:ext cx="5989320" cy="379476"/>
+            <a:off x="777240" y="1787652"/>
+            <a:ext cx="5989320" cy="342900"/>
           </a:xfrm>
           <a:prstGeom prst="rect">
             <a:avLst/>
@@ -14705,8 +14705,8 @@
         </p:nvSpPr>
         <p:spPr>
           <a:xfrm>
-            <a:off x="868680" y="1828800"/>
-            <a:ext cx="4800600" cy="379476"/>
+            <a:off x="868680" y="1787652"/>
+            <a:ext cx="4800600" cy="342900"/>
           </a:xfrm>
           <a:prstGeom prst="rect">
             <a:avLst/>
@@ -14750,7 +14750,7 @@
         </p:nvSpPr>
         <p:spPr>
           <a:xfrm>
-            <a:off x="6213348" y="1917954"/>
+            <a:off x="6213348" y="1858518"/>
             <a:ext cx="461772" cy="201168"/>
           </a:xfrm>
           <a:prstGeom prst="roundRect">
@@ -14806,8 +14806,8 @@
         </p:nvSpPr>
         <p:spPr>
           <a:xfrm>
-            <a:off x="777240" y="2240280"/>
-            <a:ext cx="5989320" cy="379476"/>
+            <a:off x="777240" y="2157984"/>
+            <a:ext cx="5989320" cy="342900"/>
           </a:xfrm>
           <a:prstGeom prst="rect">
             <a:avLst/>
@@ -14852,8 +14852,8 @@
         </p:nvSpPr>
         <p:spPr>
           <a:xfrm>
-            <a:off x="868680" y="2240280"/>
-            <a:ext cx="4800600" cy="379476"/>
+            <a:off x="868680" y="2157984"/>
+            <a:ext cx="4800600" cy="342900"/>
           </a:xfrm>
           <a:prstGeom prst="rect">
             <a:avLst/>
@@ -14873,7 +14873,7 @@
                   <a:srgbClr val="8A1626"/>
                 </a:solidFill>
               </a:rPr>
-              <a:t>Time travel 7 years; restatement = new commit</a:t>
+              <a:t>Compaction + checkpoints (lake maintain)</a:t>
             </a:r>
           </a:p>
           <a:p>
@@ -14884,7 +14884,7 @@
                   <a:srgbClr val="4A5058"/>
                 </a:solidFill>
               </a:rPr>
-              <a:t>reproduce any official number</a:t>
+              <a:t>many small intraday commits stay fast</a:t>
             </a:r>
           </a:p>
         </p:txBody>
@@ -14897,7 +14897,7 @@
         </p:nvSpPr>
         <p:spPr>
           <a:xfrm>
-            <a:off x="6213348" y="2329434"/>
+            <a:off x="6213348" y="2228850"/>
             <a:ext cx="461772" cy="201168"/>
           </a:xfrm>
           <a:prstGeom prst="roundRect">
@@ -14953,8 +14953,8 @@
         </p:nvSpPr>
         <p:spPr>
           <a:xfrm>
-            <a:off x="777240" y="2651760"/>
-            <a:ext cx="5989320" cy="379476"/>
+            <a:off x="777240" y="2528316"/>
+            <a:ext cx="5989320" cy="342900"/>
           </a:xfrm>
           <a:prstGeom prst="rect">
             <a:avLst/>
@@ -14999,8 +14999,8 @@
         </p:nvSpPr>
         <p:spPr>
           <a:xfrm>
-            <a:off x="868680" y="2651760"/>
-            <a:ext cx="4800600" cy="379476"/>
+            <a:off x="868680" y="2528316"/>
+            <a:ext cx="4800600" cy="342900"/>
           </a:xfrm>
           <a:prstGeom prst="rect">
             <a:avLst/>
@@ -15020,7 +15020,7 @@
                   <a:srgbClr val="8A1626"/>
                 </a:solidFill>
               </a:rPr>
-              <a:t>Compaction + checkpoints (lake maintain)</a:t>
+              <a:t>Sort by LE, desk, book; ZSTD + byte-stream split</a:t>
             </a:r>
           </a:p>
           <a:p>
@@ -15031,7 +15031,7 @@
                   <a:srgbClr val="4A5058"/>
                 </a:solidFill>
               </a:rPr>
-              <a:t>many small intraday commits stay fast</a:t>
+              <a:t>a node is a contiguous run of rows</a:t>
             </a:r>
           </a:p>
         </p:txBody>
@@ -15044,8 +15044,8 @@
         </p:nvSpPr>
         <p:spPr>
           <a:xfrm>
-            <a:off x="6213348" y="2740914"/>
-            <a:ext cx="461772" cy="201168"/>
+            <a:off x="6007608" y="2599182"/>
+            <a:ext cx="667512" cy="201168"/>
           </a:xfrm>
           <a:prstGeom prst="roundRect">
             <a:avLst>
@@ -15053,7 +15053,7 @@
             </a:avLst>
           </a:prstGeom>
           <a:solidFill>
-            <a:srgbClr val="A51C30"/>
+            <a:srgbClr val="FFFFFF"/>
           </a:solidFill>
           <a:ln w="12700">
             <a:solidFill>
@@ -15084,10 +15084,10 @@
             <a:r>
               <a:rPr sz="900" b="1" i="0">
                 <a:solidFill>
-                  <a:srgbClr val="FFFFFF"/>
-                </a:solidFill>
-              </a:rPr>
-              <a:t>BUILT</a:t>
+                  <a:srgbClr val="A51C30"/>
+                </a:solidFill>
+              </a:rPr>
+              <a:t>DESIGNED</a:t>
             </a:r>
           </a:p>
         </p:txBody>
@@ -15100,8 +15100,8 @@
         </p:nvSpPr>
         <p:spPr>
           <a:xfrm>
-            <a:off x="777240" y="3063239"/>
-            <a:ext cx="5989320" cy="379476"/>
+            <a:off x="777240" y="2898648"/>
+            <a:ext cx="5989320" cy="342900"/>
           </a:xfrm>
           <a:prstGeom prst="rect">
             <a:avLst/>
@@ -15146,8 +15146,8 @@
         </p:nvSpPr>
         <p:spPr>
           <a:xfrm>
-            <a:off x="868680" y="3063239"/>
-            <a:ext cx="4800600" cy="379476"/>
+            <a:off x="868680" y="2898648"/>
+            <a:ext cx="4800600" cy="342900"/>
           </a:xfrm>
           <a:prstGeom prst="rect">
             <a:avLst/>
@@ -15167,7 +15167,7 @@
                   <a:srgbClr val="8A1626"/>
                 </a:solidFill>
               </a:rPr>
-              <a:t>Sort by LE, desk, book; ZSTD + byte-stream split</a:t>
+              <a:t>Z-order or liquid clustering by book and portfolio</a:t>
             </a:r>
           </a:p>
           <a:p>
@@ -15178,7 +15178,7 @@
                   <a:srgbClr val="4A5058"/>
                 </a:solidFill>
               </a:rPr>
-              <a:t>a node is a contiguous run of rows</a:t>
+              <a:t>skip files for a desk's or portfolio's read</a:t>
             </a:r>
           </a:p>
         </p:txBody>
@@ -15191,154 +15191,7 @@
         </p:nvSpPr>
         <p:spPr>
           <a:xfrm>
-            <a:off x="6007608" y="3152394"/>
-            <a:ext cx="667512" cy="201168"/>
-          </a:xfrm>
-          <a:prstGeom prst="roundRect">
-            <a:avLst>
-              <a:gd name="adj" fmla="val 50000"/>
-            </a:avLst>
-          </a:prstGeom>
-          <a:solidFill>
-            <a:srgbClr val="FFFFFF"/>
-          </a:solidFill>
-          <a:ln w="12700">
-            <a:solidFill>
-              <a:srgbClr val="A51C30"/>
-            </a:solidFill>
-          </a:ln>
-          <a:effectLst/>
-        </p:spPr>
-        <p:style>
-          <a:lnRef idx="1">
-            <a:schemeClr val="accent1"/>
-          </a:lnRef>
-          <a:fillRef idx="3">
-            <a:schemeClr val="accent1"/>
-          </a:fillRef>
-          <a:effectRef idx="2">
-            <a:schemeClr val="accent1"/>
-          </a:effectRef>
-          <a:fontRef idx="minor">
-            <a:schemeClr val="lt1"/>
-          </a:fontRef>
-        </p:style>
-        <p:txBody>
-          <a:bodyPr rtlCol="0" anchor="ctr" lIns="18288" rIns="18288" tIns="0" bIns="0" wrap="square"/>
-          <a:lstStyle/>
-          <a:p>
-            <a:pPr algn="ctr"/>
-            <a:r>
-              <a:rPr sz="900" b="1" i="0">
-                <a:solidFill>
-                  <a:srgbClr val="A51C30"/>
-                </a:solidFill>
-              </a:rPr>
-              <a:t>DESIGNED</a:t>
-            </a:r>
-          </a:p>
-        </p:txBody>
-      </p:sp>
-      <p:sp>
-        <p:nvSpPr>
-          <p:cNvPr id="41" name="Rectangle 40"/>
-          <p:cNvSpPr/>
-          <p:nvPr/>
-        </p:nvSpPr>
-        <p:spPr>
-          <a:xfrm>
-            <a:off x="777240" y="3474720"/>
-            <a:ext cx="5989320" cy="379476"/>
-          </a:xfrm>
-          <a:prstGeom prst="rect">
-            <a:avLst/>
-          </a:prstGeom>
-          <a:solidFill>
-            <a:srgbClr val="FFFFFF"/>
-          </a:solidFill>
-          <a:ln w="9525">
-            <a:solidFill>
-              <a:srgbClr val="E3DED7"/>
-            </a:solidFill>
-          </a:ln>
-          <a:effectLst/>
-        </p:spPr>
-        <p:style>
-          <a:lnRef idx="1">
-            <a:schemeClr val="accent1"/>
-          </a:lnRef>
-          <a:fillRef idx="3">
-            <a:schemeClr val="accent1"/>
-          </a:fillRef>
-          <a:effectRef idx="2">
-            <a:schemeClr val="accent1"/>
-          </a:effectRef>
-          <a:fontRef idx="minor">
-            <a:schemeClr val="lt1"/>
-          </a:fontRef>
-        </p:style>
-        <p:txBody>
-          <a:bodyPr rtlCol="0" anchor="ctr" lIns="0" rIns="0" tIns="0" bIns="0"/>
-          <a:lstStyle/>
-          <a:p>
-            <a:pPr algn="ctr"/>
-          </a:p>
-        </p:txBody>
-      </p:sp>
-      <p:sp>
-        <p:nvSpPr>
-          <p:cNvPr id="42" name="TextBox 41"/>
-          <p:cNvSpPr txBox="1"/>
-          <p:nvPr/>
-        </p:nvSpPr>
-        <p:spPr>
-          <a:xfrm>
-            <a:off x="868680" y="3474720"/>
-            <a:ext cx="4800600" cy="379476"/>
-          </a:xfrm>
-          <a:prstGeom prst="rect">
-            <a:avLst/>
-          </a:prstGeom>
-          <a:noFill/>
-        </p:spPr>
-        <p:txBody>
-          <a:bodyPr wrap="square" lIns="0" rIns="0" tIns="0" bIns="0" anchor="ctr">
-            <a:spAutoFit/>
-          </a:bodyPr>
-          <a:lstStyle/>
-          <a:p>
-            <a:pPr algn="l"/>
-            <a:r>
-              <a:rPr sz="1150" b="1" i="0">
-                <a:solidFill>
-                  <a:srgbClr val="8A1626"/>
-                </a:solidFill>
-              </a:rPr>
-              <a:t>Z-order or liquid clustering by book and portfolio</a:t>
-            </a:r>
-          </a:p>
-          <a:p>
-            <a:pPr algn="l"/>
-            <a:r>
-              <a:rPr sz="1050" b="0" i="0">
-                <a:solidFill>
-                  <a:srgbClr val="4A5058"/>
-                </a:solidFill>
-              </a:rPr>
-              <a:t>skip files for a desk's or portfolio's read</a:t>
-            </a:r>
-          </a:p>
-        </p:txBody>
-      </p:sp>
-      <p:sp>
-        <p:nvSpPr>
-          <p:cNvPr id="43" name="Rounded Rectangle 42"/>
-          <p:cNvSpPr/>
-          <p:nvPr/>
-        </p:nvSpPr>
-        <p:spPr>
-          <a:xfrm>
-            <a:off x="6007608" y="3563874"/>
+            <a:off x="6007608" y="2969514"/>
             <a:ext cx="667512" cy="201168"/>
           </a:xfrm>
           <a:prstGeom prst="roundRect">
@@ -15389,20 +15242,20 @@
       </p:sp>
       <p:sp>
         <p:nvSpPr>
-          <p:cNvPr id="44" name="Rectangle 43"/>
+          <p:cNvPr id="41" name="Rectangle 40"/>
           <p:cNvSpPr/>
           <p:nvPr/>
         </p:nvSpPr>
         <p:spPr>
           <a:xfrm>
-            <a:off x="777240" y="3886200"/>
-            <a:ext cx="5989320" cy="379476"/>
+            <a:off x="777240" y="3268980"/>
+            <a:ext cx="5989320" cy="342900"/>
           </a:xfrm>
           <a:prstGeom prst="rect">
             <a:avLst/>
           </a:prstGeom>
           <a:solidFill>
-            <a:srgbClr val="F7F5F2"/>
+            <a:srgbClr val="FFFFFF"/>
           </a:solidFill>
           <a:ln w="9525">
             <a:solidFill>
@@ -15435,14 +15288,14 @@
       </p:sp>
       <p:sp>
         <p:nvSpPr>
-          <p:cNvPr id="45" name="TextBox 44"/>
+          <p:cNvPr id="42" name="TextBox 41"/>
           <p:cNvSpPr txBox="1"/>
           <p:nvPr/>
         </p:nvSpPr>
         <p:spPr>
           <a:xfrm>
-            <a:off x="868680" y="3886200"/>
-            <a:ext cx="4800600" cy="379476"/>
+            <a:off x="868680" y="3268980"/>
+            <a:ext cx="4800600" cy="342900"/>
           </a:xfrm>
           <a:prstGeom prst="rect">
             <a:avLst/>
@@ -15480,13 +15333,13 @@
       </p:sp>
       <p:sp>
         <p:nvSpPr>
-          <p:cNvPr id="46" name="Rounded Rectangle 45"/>
+          <p:cNvPr id="43" name="Rounded Rectangle 42"/>
           <p:cNvSpPr/>
           <p:nvPr/>
         </p:nvSpPr>
         <p:spPr>
           <a:xfrm>
-            <a:off x="6007608" y="3975354"/>
+            <a:off x="6007608" y="3339846"/>
             <a:ext cx="667512" cy="201168"/>
           </a:xfrm>
           <a:prstGeom prst="roundRect">
@@ -15537,20 +15390,20 @@
       </p:sp>
       <p:sp>
         <p:nvSpPr>
-          <p:cNvPr id="47" name="Rectangle 46"/>
+          <p:cNvPr id="44" name="Rectangle 43"/>
           <p:cNvSpPr/>
           <p:nvPr/>
         </p:nvSpPr>
         <p:spPr>
           <a:xfrm>
-            <a:off x="777240" y="4297679"/>
-            <a:ext cx="5989320" cy="379476"/>
+            <a:off x="777240" y="3639312"/>
+            <a:ext cx="5989320" cy="342900"/>
           </a:xfrm>
           <a:prstGeom prst="rect">
             <a:avLst/>
           </a:prstGeom>
           <a:solidFill>
-            <a:srgbClr val="FFFFFF"/>
+            <a:srgbClr val="F7F5F2"/>
           </a:solidFill>
           <a:ln w="9525">
             <a:solidFill>
@@ -15583,14 +15436,14 @@
       </p:sp>
       <p:sp>
         <p:nvSpPr>
-          <p:cNvPr id="48" name="TextBox 47"/>
+          <p:cNvPr id="45" name="TextBox 44"/>
           <p:cNvSpPr txBox="1"/>
           <p:nvPr/>
         </p:nvSpPr>
         <p:spPr>
           <a:xfrm>
-            <a:off x="868680" y="4297679"/>
-            <a:ext cx="4800600" cy="379476"/>
+            <a:off x="868680" y="3639312"/>
+            <a:ext cx="4800600" cy="342900"/>
           </a:xfrm>
           <a:prstGeom prst="rect">
             <a:avLst/>
@@ -15628,13 +15481,13 @@
       </p:sp>
       <p:sp>
         <p:nvSpPr>
-          <p:cNvPr id="49" name="Rounded Rectangle 48"/>
+          <p:cNvPr id="46" name="Rounded Rectangle 45"/>
           <p:cNvSpPr/>
           <p:nvPr/>
         </p:nvSpPr>
         <p:spPr>
           <a:xfrm>
-            <a:off x="6007608" y="4386833"/>
+            <a:off x="6007608" y="3710178"/>
             <a:ext cx="667512" cy="201168"/>
           </a:xfrm>
           <a:prstGeom prst="roundRect">
@@ -15685,14 +15538,161 @@
       </p:sp>
       <p:sp>
         <p:nvSpPr>
+          <p:cNvPr id="47" name="Rectangle 46"/>
+          <p:cNvSpPr/>
+          <p:nvPr/>
+        </p:nvSpPr>
+        <p:spPr>
+          <a:xfrm>
+            <a:off x="777240" y="4009644"/>
+            <a:ext cx="5989320" cy="342900"/>
+          </a:xfrm>
+          <a:prstGeom prst="rect">
+            <a:avLst/>
+          </a:prstGeom>
+          <a:solidFill>
+            <a:srgbClr val="FFFFFF"/>
+          </a:solidFill>
+          <a:ln w="9525">
+            <a:solidFill>
+              <a:srgbClr val="E3DED7"/>
+            </a:solidFill>
+          </a:ln>
+          <a:effectLst/>
+        </p:spPr>
+        <p:style>
+          <a:lnRef idx="1">
+            <a:schemeClr val="accent1"/>
+          </a:lnRef>
+          <a:fillRef idx="3">
+            <a:schemeClr val="accent1"/>
+          </a:fillRef>
+          <a:effectRef idx="2">
+            <a:schemeClr val="accent1"/>
+          </a:effectRef>
+          <a:fontRef idx="minor">
+            <a:schemeClr val="lt1"/>
+          </a:fontRef>
+        </p:style>
+        <p:txBody>
+          <a:bodyPr rtlCol="0" anchor="ctr" lIns="0" rIns="0" tIns="0" bIns="0"/>
+          <a:lstStyle/>
+          <a:p>
+            <a:pPr algn="ctr"/>
+          </a:p>
+        </p:txBody>
+      </p:sp>
+      <p:sp>
+        <p:nvSpPr>
+          <p:cNvPr id="48" name="TextBox 47"/>
+          <p:cNvSpPr txBox="1"/>
+          <p:nvPr/>
+        </p:nvSpPr>
+        <p:spPr>
+          <a:xfrm>
+            <a:off x="868680" y="4009644"/>
+            <a:ext cx="4800600" cy="342900"/>
+          </a:xfrm>
+          <a:prstGeom prst="rect">
+            <a:avLst/>
+          </a:prstGeom>
+          <a:noFill/>
+        </p:spPr>
+        <p:txBody>
+          <a:bodyPr wrap="square" lIns="0" rIns="0" tIns="0" bIns="0" anchor="ctr">
+            <a:spAutoFit/>
+          </a:bodyPr>
+          <a:lstStyle/>
+          <a:p>
+            <a:pPr algn="l"/>
+            <a:r>
+              <a:rPr sz="1150" b="1" i="0">
+                <a:solidFill>
+                  <a:srgbClr val="8A1626"/>
+                </a:solidFill>
+              </a:rPr>
+              <a:t>Delta inputs on S3 (reading)</a:t>
+            </a:r>
+          </a:p>
+          <a:p>
+            <a:pPr algn="l"/>
+            <a:r>
+              <a:rPr sz="1050" b="0" i="0">
+                <a:solidFill>
+                  <a:srgbClr val="4A5058"/>
+                </a:solidFill>
+              </a:rPr>
+              <a:t>the Delta plugin reads s3:// tables</a:t>
+            </a:r>
+          </a:p>
+        </p:txBody>
+      </p:sp>
+      <p:sp>
+        <p:nvSpPr>
+          <p:cNvPr id="49" name="Rounded Rectangle 48"/>
+          <p:cNvSpPr/>
+          <p:nvPr/>
+        </p:nvSpPr>
+        <p:spPr>
+          <a:xfrm>
+            <a:off x="6213348" y="4080509"/>
+            <a:ext cx="461772" cy="201168"/>
+          </a:xfrm>
+          <a:prstGeom prst="roundRect">
+            <a:avLst>
+              <a:gd name="adj" fmla="val 50000"/>
+            </a:avLst>
+          </a:prstGeom>
+          <a:solidFill>
+            <a:srgbClr val="A51C30"/>
+          </a:solidFill>
+          <a:ln w="12700">
+            <a:solidFill>
+              <a:srgbClr val="A51C30"/>
+            </a:solidFill>
+          </a:ln>
+          <a:effectLst/>
+        </p:spPr>
+        <p:style>
+          <a:lnRef idx="1">
+            <a:schemeClr val="accent1"/>
+          </a:lnRef>
+          <a:fillRef idx="3">
+            <a:schemeClr val="accent1"/>
+          </a:fillRef>
+          <a:effectRef idx="2">
+            <a:schemeClr val="accent1"/>
+          </a:effectRef>
+          <a:fontRef idx="minor">
+            <a:schemeClr val="lt1"/>
+          </a:fontRef>
+        </p:style>
+        <p:txBody>
+          <a:bodyPr rtlCol="0" anchor="ctr" lIns="18288" rIns="18288" tIns="0" bIns="0" wrap="square"/>
+          <a:lstStyle/>
+          <a:p>
+            <a:pPr algn="ctr"/>
+            <a:r>
+              <a:rPr sz="900" b="1" i="0">
+                <a:solidFill>
+                  <a:srgbClr val="FFFFFF"/>
+                </a:solidFill>
+              </a:rPr>
+              <a:t>BUILT</a:t>
+            </a:r>
+          </a:p>
+        </p:txBody>
+      </p:sp>
+      <p:sp>
+        <p:nvSpPr>
           <p:cNvPr id="50" name="Rectangle 49"/>
           <p:cNvSpPr/>
           <p:nvPr/>
         </p:nvSpPr>
         <p:spPr>
           <a:xfrm>
-            <a:off x="777240" y="4709159"/>
-            <a:ext cx="5989320" cy="379476"/>
+            <a:off x="777240" y="4379976"/>
+            <a:ext cx="5989320" cy="342900"/>
           </a:xfrm>
           <a:prstGeom prst="rect">
             <a:avLst/>
@@ -15737,8 +15737,8 @@
         </p:nvSpPr>
         <p:spPr>
           <a:xfrm>
-            <a:off x="868680" y="4709159"/>
-            <a:ext cx="4800600" cy="379476"/>
+            <a:off x="868680" y="4379976"/>
+            <a:ext cx="4800600" cy="342900"/>
           </a:xfrm>
           <a:prstGeom prst="rect">
             <a:avLst/>
@@ -15758,7 +15758,7 @@
                   <a:srgbClr val="8A1626"/>
                 </a:solidFill>
               </a:rPr>
-              <a:t>Delta on S3; Iceberg with the same column</a:t>
+              <a:t>Iceberg for VaR inputs</a:t>
             </a:r>
           </a:p>
           <a:p>
@@ -15769,7 +15769,7 @@
                   <a:srgbClr val="4A5058"/>
                 </a:solidFill>
               </a:rPr>
-              <a:t>S3 reading built; VaR publish to s3:// not yet</a:t>
+              <a:t>only the Delta plugin streams vectors</a:t>
             </a:r>
           </a:p>
         </p:txBody>
@@ -15782,8 +15782,392 @@
         </p:nvSpPr>
         <p:spPr>
           <a:xfrm>
-            <a:off x="6213348" y="4798314"/>
-            <a:ext cx="461772" cy="201168"/>
+            <a:off x="5939028" y="4450842"/>
+            <a:ext cx="736092" cy="201168"/>
+          </a:xfrm>
+          <a:prstGeom prst="roundRect">
+            <a:avLst>
+              <a:gd name="adj" fmla="val 50000"/>
+            </a:avLst>
+          </a:prstGeom>
+          <a:solidFill>
+            <a:srgbClr val="E9E6E1"/>
+          </a:solidFill>
+          <a:ln w="12700">
+            <a:solidFill>
+              <a:srgbClr val="4A5058"/>
+            </a:solidFill>
+          </a:ln>
+          <a:effectLst/>
+        </p:spPr>
+        <p:style>
+          <a:lnRef idx="1">
+            <a:schemeClr val="accent1"/>
+          </a:lnRef>
+          <a:fillRef idx="3">
+            <a:schemeClr val="accent1"/>
+          </a:fillRef>
+          <a:effectRef idx="2">
+            <a:schemeClr val="accent1"/>
+          </a:effectRef>
+          <a:fontRef idx="minor">
+            <a:schemeClr val="lt1"/>
+          </a:fontRef>
+        </p:style>
+        <p:txBody>
+          <a:bodyPr rtlCol="0" anchor="ctr" lIns="18288" rIns="18288" tIns="0" bIns="0" wrap="square"/>
+          <a:lstStyle/>
+          <a:p>
+            <a:pPr algn="ctr"/>
+            <a:r>
+              <a:rPr sz="900" b="1" i="0">
+                <a:solidFill>
+                  <a:srgbClr val="4A5058"/>
+                </a:solidFill>
+              </a:rPr>
+              <a:t>NOT BUILT</a:t>
+            </a:r>
+          </a:p>
+        </p:txBody>
+      </p:sp>
+      <p:sp>
+        <p:nvSpPr>
+          <p:cNvPr id="53" name="Rectangle 52"/>
+          <p:cNvSpPr/>
+          <p:nvPr/>
+        </p:nvSpPr>
+        <p:spPr>
+          <a:xfrm>
+            <a:off x="777240" y="4750308"/>
+            <a:ext cx="5989320" cy="342900"/>
+          </a:xfrm>
+          <a:prstGeom prst="rect">
+            <a:avLst/>
+          </a:prstGeom>
+          <a:solidFill>
+            <a:srgbClr val="FFFFFF"/>
+          </a:solidFill>
+          <a:ln w="9525">
+            <a:solidFill>
+              <a:srgbClr val="E3DED7"/>
+            </a:solidFill>
+          </a:ln>
+          <a:effectLst/>
+        </p:spPr>
+        <p:style>
+          <a:lnRef idx="1">
+            <a:schemeClr val="accent1"/>
+          </a:lnRef>
+          <a:fillRef idx="3">
+            <a:schemeClr val="accent1"/>
+          </a:fillRef>
+          <a:effectRef idx="2">
+            <a:schemeClr val="accent1"/>
+          </a:effectRef>
+          <a:fontRef idx="minor">
+            <a:schemeClr val="lt1"/>
+          </a:fontRef>
+        </p:style>
+        <p:txBody>
+          <a:bodyPr rtlCol="0" anchor="ctr" lIns="0" rIns="0" tIns="0" bIns="0"/>
+          <a:lstStyle/>
+          <a:p>
+            <a:pPr algn="ctr"/>
+          </a:p>
+        </p:txBody>
+      </p:sp>
+      <p:sp>
+        <p:nvSpPr>
+          <p:cNvPr id="54" name="TextBox 53"/>
+          <p:cNvSpPr txBox="1"/>
+          <p:nvPr/>
+        </p:nvSpPr>
+        <p:spPr>
+          <a:xfrm>
+            <a:off x="868680" y="4750308"/>
+            <a:ext cx="4800600" cy="342900"/>
+          </a:xfrm>
+          <a:prstGeom prst="rect">
+            <a:avLst/>
+          </a:prstGeom>
+          <a:noFill/>
+        </p:spPr>
+        <p:txBody>
+          <a:bodyPr wrap="square" lIns="0" rIns="0" tIns="0" bIns="0" anchor="ctr">
+            <a:spAutoFit/>
+          </a:bodyPr>
+          <a:lstStyle/>
+          <a:p>
+            <a:pPr algn="l"/>
+            <a:r>
+              <a:rPr sz="1150" b="1" i="0">
+                <a:solidFill>
+                  <a:srgbClr val="8A1626"/>
+                </a:solidFill>
+              </a:rPr>
+              <a:t>Official publish to S3</a:t>
+            </a:r>
+          </a:p>
+          <a:p>
+            <a:pPr algn="l"/>
+            <a:r>
+              <a:rPr sz="1050" b="0" i="0">
+                <a:solidFill>
+                  <a:srgbClr val="4A5058"/>
+                </a:solidFill>
+              </a:rPr>
+              <a:t>local or EFS Delta root only; s3:// fails</a:t>
+            </a:r>
+          </a:p>
+        </p:txBody>
+      </p:sp>
+      <p:sp>
+        <p:nvSpPr>
+          <p:cNvPr id="55" name="Rounded Rectangle 54"/>
+          <p:cNvSpPr/>
+          <p:nvPr/>
+        </p:nvSpPr>
+        <p:spPr>
+          <a:xfrm>
+            <a:off x="5939028" y="4821174"/>
+            <a:ext cx="736092" cy="201168"/>
+          </a:xfrm>
+          <a:prstGeom prst="roundRect">
+            <a:avLst>
+              <a:gd name="adj" fmla="val 50000"/>
+            </a:avLst>
+          </a:prstGeom>
+          <a:solidFill>
+            <a:srgbClr val="E9E6E1"/>
+          </a:solidFill>
+          <a:ln w="12700">
+            <a:solidFill>
+              <a:srgbClr val="4A5058"/>
+            </a:solidFill>
+          </a:ln>
+          <a:effectLst/>
+        </p:spPr>
+        <p:style>
+          <a:lnRef idx="1">
+            <a:schemeClr val="accent1"/>
+          </a:lnRef>
+          <a:fillRef idx="3">
+            <a:schemeClr val="accent1"/>
+          </a:fillRef>
+          <a:effectRef idx="2">
+            <a:schemeClr val="accent1"/>
+          </a:effectRef>
+          <a:fontRef idx="minor">
+            <a:schemeClr val="lt1"/>
+          </a:fontRef>
+        </p:style>
+        <p:txBody>
+          <a:bodyPr rtlCol="0" anchor="ctr" lIns="18288" rIns="18288" tIns="0" bIns="0" wrap="square"/>
+          <a:lstStyle/>
+          <a:p>
+            <a:pPr algn="ctr"/>
+            <a:r>
+              <a:rPr sz="900" b="1" i="0">
+                <a:solidFill>
+                  <a:srgbClr val="4A5058"/>
+                </a:solidFill>
+              </a:rPr>
+              <a:t>NOT BUILT</a:t>
+            </a:r>
+          </a:p>
+        </p:txBody>
+      </p:sp>
+      <p:sp>
+        <p:nvSpPr>
+          <p:cNvPr id="56" name="Rectangle 55"/>
+          <p:cNvSpPr/>
+          <p:nvPr/>
+        </p:nvSpPr>
+        <p:spPr>
+          <a:xfrm>
+            <a:off x="8403336" y="1417320"/>
+            <a:ext cx="1645920" cy="310896"/>
+          </a:xfrm>
+          <a:prstGeom prst="rect">
+            <a:avLst/>
+          </a:prstGeom>
+          <a:solidFill>
+            <a:srgbClr val="FFFFFF"/>
+          </a:solidFill>
+          <a:ln w="12700">
+            <a:solidFill>
+              <a:srgbClr val="CFC8BE"/>
+            </a:solidFill>
+          </a:ln>
+          <a:effectLst/>
+        </p:spPr>
+        <p:style>
+          <a:lnRef idx="1">
+            <a:schemeClr val="accent1"/>
+          </a:lnRef>
+          <a:fillRef idx="3">
+            <a:schemeClr val="accent1"/>
+          </a:fillRef>
+          <a:effectRef idx="2">
+            <a:schemeClr val="accent1"/>
+          </a:effectRef>
+          <a:fontRef idx="minor">
+            <a:schemeClr val="lt1"/>
+          </a:fontRef>
+        </p:style>
+        <p:txBody>
+          <a:bodyPr rtlCol="0" anchor="ctr" lIns="73152" rIns="73152" wrap="square"/>
+          <a:lstStyle/>
+          <a:p>
+            <a:pPr algn="ctr"/>
+            <a:r>
+              <a:rPr sz="1100" b="1" i="0">
+                <a:solidFill>
+                  <a:srgbClr val="4A5058"/>
+                </a:solidFill>
+              </a:rPr>
+              <a:t>Load balancer</a:t>
+            </a:r>
+          </a:p>
+        </p:txBody>
+      </p:sp>
+      <p:cxnSp>
+        <p:nvCxnSpPr>
+          <p:cNvPr id="57" name="Connector 56"/>
+          <p:cNvCxnSpPr/>
+          <p:nvPr/>
+        </p:nvCxnSpPr>
+        <p:spPr>
+          <a:xfrm>
+            <a:off x="9226296" y="1728216"/>
+            <a:ext cx="0" cy="137160"/>
+          </a:xfrm>
+          <a:prstGeom prst="line">
+            <a:avLst/>
+          </a:prstGeom>
+          <a:ln w="15875">
+            <a:solidFill>
+              <a:srgbClr val="A51C30"/>
+            </a:solidFill>
+            <a:tailEnd type="triangle" w="med" len="med"/>
+          </a:ln>
+        </p:spPr>
+        <p:style>
+          <a:lnRef idx="2">
+            <a:schemeClr val="accent1"/>
+          </a:lnRef>
+          <a:fillRef idx="0">
+            <a:schemeClr val="accent1"/>
+          </a:fillRef>
+          <a:effectRef idx="1">
+            <a:schemeClr val="accent1"/>
+          </a:effectRef>
+          <a:fontRef idx="minor">
+            <a:schemeClr val="tx1"/>
+          </a:fontRef>
+        </p:style>
+      </p:cxnSp>
+      <p:sp>
+        <p:nvSpPr>
+          <p:cNvPr id="58" name="Rectangle 57"/>
+          <p:cNvSpPr/>
+          <p:nvPr/>
+        </p:nvSpPr>
+        <p:spPr>
+          <a:xfrm>
+            <a:off x="7040879" y="1865376"/>
+            <a:ext cx="4370832" cy="640080"/>
+          </a:xfrm>
+          <a:prstGeom prst="rect">
+            <a:avLst/>
+          </a:prstGeom>
+          <a:solidFill>
+            <a:srgbClr val="FFFFFF"/>
+          </a:solidFill>
+          <a:ln w="12700">
+            <a:solidFill>
+              <a:srgbClr val="A51C30"/>
+            </a:solidFill>
+          </a:ln>
+          <a:effectLst/>
+        </p:spPr>
+        <p:style>
+          <a:lnRef idx="1">
+            <a:schemeClr val="accent1"/>
+          </a:lnRef>
+          <a:fillRef idx="3">
+            <a:schemeClr val="accent1"/>
+          </a:fillRef>
+          <a:effectRef idx="2">
+            <a:schemeClr val="accent1"/>
+          </a:effectRef>
+          <a:fontRef idx="minor">
+            <a:schemeClr val="lt1"/>
+          </a:fontRef>
+        </p:style>
+        <p:txBody>
+          <a:bodyPr rtlCol="0" anchor="ctr" lIns="0" rIns="0" tIns="0" bIns="0"/>
+          <a:lstStyle/>
+          <a:p>
+            <a:pPr algn="ctr"/>
+          </a:p>
+        </p:txBody>
+      </p:sp>
+      <p:sp>
+        <p:nvSpPr>
+          <p:cNvPr id="59" name="TextBox 58"/>
+          <p:cNvSpPr txBox="1"/>
+          <p:nvPr/>
+        </p:nvSpPr>
+        <p:spPr>
+          <a:xfrm>
+            <a:off x="7132319" y="1883664"/>
+            <a:ext cx="3456432" cy="603504"/>
+          </a:xfrm>
+          <a:prstGeom prst="rect">
+            <a:avLst/>
+          </a:prstGeom>
+          <a:noFill/>
+        </p:spPr>
+        <p:txBody>
+          <a:bodyPr wrap="square" lIns="0" rIns="0" tIns="0" bIns="0" anchor="ctr">
+            <a:spAutoFit/>
+          </a:bodyPr>
+          <a:lstStyle/>
+          <a:p>
+            <a:pPr algn="l"/>
+            <a:r>
+              <a:rPr sz="1200" b="1" i="0">
+                <a:solidFill>
+                  <a:srgbClr val="8A1626"/>
+                </a:solidFill>
+              </a:rPr>
+              <a:t>Consoles × N</a:t>
+            </a:r>
+          </a:p>
+          <a:p>
+            <a:pPr algn="l"/>
+            <a:r>
+              <a:rPr sz="1000" b="0" i="0">
+                <a:solidFill>
+                  <a:srgbClr val="4A5058"/>
+                </a:solidFill>
+              </a:rPr>
+              <a:t>worker processes relay a tab's channel; sticky sessions across consoles; one DRISHTI_SESSION_SECRET; servers discovered</a:t>
+            </a:r>
+          </a:p>
+        </p:txBody>
+      </p:sp>
+      <p:sp>
+        <p:nvSpPr>
+          <p:cNvPr id="60" name="Rounded Rectangle 59"/>
+          <p:cNvSpPr/>
+          <p:nvPr/>
+        </p:nvSpPr>
+        <p:spPr>
+          <a:xfrm>
+            <a:off x="10753344" y="1938528"/>
+            <a:ext cx="566928" cy="201168"/>
           </a:xfrm>
           <a:prstGeom prst="roundRect">
             <a:avLst>
@@ -15830,70 +16214,16 @@
           </a:p>
         </p:txBody>
       </p:sp>
-      <p:sp>
-        <p:nvSpPr>
-          <p:cNvPr id="53" name="Rectangle 52"/>
-          <p:cNvSpPr/>
-          <p:nvPr/>
-        </p:nvSpPr>
-        <p:spPr>
-          <a:xfrm>
-            <a:off x="8403336" y="1417320"/>
-            <a:ext cx="1645920" cy="310896"/>
-          </a:xfrm>
-          <a:prstGeom prst="rect">
-            <a:avLst/>
-          </a:prstGeom>
-          <a:solidFill>
-            <a:srgbClr val="FFFFFF"/>
-          </a:solidFill>
-          <a:ln w="12700">
-            <a:solidFill>
-              <a:srgbClr val="CFC8BE"/>
-            </a:solidFill>
-          </a:ln>
-          <a:effectLst/>
-        </p:spPr>
-        <p:style>
-          <a:lnRef idx="1">
-            <a:schemeClr val="accent1"/>
-          </a:lnRef>
-          <a:fillRef idx="3">
-            <a:schemeClr val="accent1"/>
-          </a:fillRef>
-          <a:effectRef idx="2">
-            <a:schemeClr val="accent1"/>
-          </a:effectRef>
-          <a:fontRef idx="minor">
-            <a:schemeClr val="lt1"/>
-          </a:fontRef>
-        </p:style>
-        <p:txBody>
-          <a:bodyPr rtlCol="0" anchor="ctr" lIns="73152" rIns="73152" wrap="square"/>
-          <a:lstStyle/>
-          <a:p>
-            <a:pPr algn="ctr"/>
-            <a:r>
-              <a:rPr sz="1100" b="1" i="0">
-                <a:solidFill>
-                  <a:srgbClr val="4A5058"/>
-                </a:solidFill>
-              </a:rPr>
-              <a:t>Load balancer</a:t>
-            </a:r>
-          </a:p>
-        </p:txBody>
-      </p:sp>
       <p:cxnSp>
         <p:nvCxnSpPr>
-          <p:cNvPr id="54" name="Connector 53"/>
+          <p:cNvPr id="61" name="Connector 60"/>
           <p:cNvCxnSpPr/>
           <p:nvPr/>
         </p:nvCxnSpPr>
         <p:spPr>
           <a:xfrm>
-            <a:off x="9226296" y="1728216"/>
-            <a:ext cx="0" cy="137160"/>
+            <a:off x="9226296" y="2505456"/>
+            <a:ext cx="0" cy="164592"/>
           </a:xfrm>
           <a:prstGeom prst="line">
             <a:avLst/>
@@ -15922,17 +16252,461 @@
       </p:cxnSp>
       <p:sp>
         <p:nvSpPr>
-          <p:cNvPr id="55" name="Rectangle 54"/>
+          <p:cNvPr id="62" name="Rounded Rectangle 61"/>
           <p:cNvSpPr/>
           <p:nvPr/>
         </p:nvSpPr>
         <p:spPr>
           <a:xfrm>
-            <a:off x="7040879" y="1865376"/>
-            <a:ext cx="4370832" cy="640080"/>
-          </a:xfrm>
-          <a:prstGeom prst="rect">
-            <a:avLst/>
+            <a:off x="7040879" y="2670048"/>
+            <a:ext cx="4370832" cy="1938528"/>
+          </a:xfrm>
+          <a:prstGeom prst="roundRect">
+            <a:avLst>
+              <a:gd name="adj" fmla="val 6000"/>
+            </a:avLst>
+          </a:prstGeom>
+          <a:noFill/>
+          <a:ln w="12700">
+            <a:solidFill>
+              <a:srgbClr val="A51C30"/>
+            </a:solidFill>
+            <a:prstDash val="dash"/>
+          </a:ln>
+          <a:effectLst/>
+        </p:spPr>
+        <p:style>
+          <a:lnRef idx="1">
+            <a:schemeClr val="accent1"/>
+          </a:lnRef>
+          <a:fillRef idx="3">
+            <a:schemeClr val="accent1"/>
+          </a:fillRef>
+          <a:effectRef idx="2">
+            <a:schemeClr val="accent1"/>
+          </a:effectRef>
+          <a:fontRef idx="minor">
+            <a:schemeClr val="lt1"/>
+          </a:fontRef>
+        </p:style>
+        <p:txBody>
+          <a:bodyPr rtlCol="0" anchor="ctr" lIns="0" rIns="0" tIns="0" bIns="0"/>
+          <a:lstStyle/>
+          <a:p>
+            <a:pPr algn="ctr"/>
+          </a:p>
+        </p:txBody>
+      </p:sp>
+      <p:sp>
+        <p:nvSpPr>
+          <p:cNvPr id="63" name="TextBox 62"/>
+          <p:cNvSpPr txBox="1"/>
+          <p:nvPr/>
+        </p:nvSpPr>
+        <p:spPr>
+          <a:xfrm>
+            <a:off x="7150607" y="2697480"/>
+            <a:ext cx="2194560" cy="237744"/>
+          </a:xfrm>
+          <a:prstGeom prst="rect">
+            <a:avLst/>
+          </a:prstGeom>
+          <a:noFill/>
+        </p:spPr>
+        <p:txBody>
+          <a:bodyPr wrap="square" lIns="0" rIns="0" tIns="0" bIns="0" anchor="ctr">
+            <a:spAutoFit/>
+          </a:bodyPr>
+          <a:lstStyle/>
+          <a:p>
+            <a:pPr algn="l"/>
+            <a:r>
+              <a:rPr sz="1100" b="1" i="0">
+                <a:solidFill>
+                  <a:srgbClr val="A51C30"/>
+                </a:solidFill>
+              </a:rPr>
+              <a:t>Drishti*net servers</a:t>
+            </a:r>
+          </a:p>
+        </p:txBody>
+      </p:sp>
+      <p:sp>
+        <p:nvSpPr>
+          <p:cNvPr id="64" name="Rectangle 63"/>
+          <p:cNvSpPr/>
+          <p:nvPr/>
+        </p:nvSpPr>
+        <p:spPr>
+          <a:xfrm>
+            <a:off x="7150607" y="3017520"/>
+            <a:ext cx="1325880" cy="914400"/>
+          </a:xfrm>
+          <a:prstGeom prst="rect">
+            <a:avLst/>
+          </a:prstGeom>
+          <a:solidFill>
+            <a:srgbClr val="F6E6E9"/>
+          </a:solidFill>
+          <a:ln w="9525">
+            <a:solidFill>
+              <a:srgbClr val="A51C30"/>
+            </a:solidFill>
+          </a:ln>
+          <a:effectLst/>
+        </p:spPr>
+        <p:style>
+          <a:lnRef idx="1">
+            <a:schemeClr val="accent1"/>
+          </a:lnRef>
+          <a:fillRef idx="3">
+            <a:schemeClr val="accent1"/>
+          </a:fillRef>
+          <a:effectRef idx="2">
+            <a:schemeClr val="accent1"/>
+          </a:effectRef>
+          <a:fontRef idx="minor">
+            <a:schemeClr val="lt1"/>
+          </a:fontRef>
+        </p:style>
+        <p:txBody>
+          <a:bodyPr rtlCol="0" anchor="ctr" lIns="0" rIns="0" tIns="0" bIns="0"/>
+          <a:lstStyle/>
+          <a:p>
+            <a:pPr algn="ctr"/>
+          </a:p>
+        </p:txBody>
+      </p:sp>
+      <p:sp>
+        <p:nvSpPr>
+          <p:cNvPr id="65" name="TextBox 64"/>
+          <p:cNvSpPr txBox="1"/>
+          <p:nvPr/>
+        </p:nvSpPr>
+        <p:spPr>
+          <a:xfrm>
+            <a:off x="7205471" y="3035808"/>
+            <a:ext cx="1234440" cy="877824"/>
+          </a:xfrm>
+          <a:prstGeom prst="rect">
+            <a:avLst/>
+          </a:prstGeom>
+          <a:noFill/>
+        </p:spPr>
+        <p:txBody>
+          <a:bodyPr wrap="square" lIns="0" rIns="0" tIns="0" bIns="0" anchor="ctr">
+            <a:spAutoFit/>
+          </a:bodyPr>
+          <a:lstStyle/>
+          <a:p>
+            <a:pPr algn="l"/>
+            <a:r>
+              <a:rPr sz="1150" b="1" i="0">
+                <a:solidFill>
+                  <a:srgbClr val="8A1626"/>
+                </a:solidFill>
+              </a:rPr>
+              <a:t>Coordinator</a:t>
+            </a:r>
+          </a:p>
+          <a:p>
+            <a:pPr algn="l"/>
+            <a:r>
+              <a:rPr sz="1000" b="0" i="0">
+                <a:solidFill>
+                  <a:srgbClr val="4A5058"/>
+                </a:solidFill>
+              </a:rPr>
+              <a:t>adds partial vectors (4 KB each) in a fixed order</a:t>
+            </a:r>
+          </a:p>
+        </p:txBody>
+      </p:sp>
+      <p:sp>
+        <p:nvSpPr>
+          <p:cNvPr id="66" name="Rectangle 65"/>
+          <p:cNvSpPr/>
+          <p:nvPr/>
+        </p:nvSpPr>
+        <p:spPr>
+          <a:xfrm>
+            <a:off x="8732519" y="2990088"/>
+            <a:ext cx="1481328" cy="283464"/>
+          </a:xfrm>
+          <a:prstGeom prst="rect">
+            <a:avLst/>
+          </a:prstGeom>
+          <a:solidFill>
+            <a:srgbClr val="F7F5F2"/>
+          </a:solidFill>
+          <a:ln w="9525">
+            <a:solidFill>
+              <a:srgbClr val="CFC8BE"/>
+            </a:solidFill>
+          </a:ln>
+          <a:effectLst/>
+        </p:spPr>
+        <p:style>
+          <a:lnRef idx="1">
+            <a:schemeClr val="accent1"/>
+          </a:lnRef>
+          <a:fillRef idx="3">
+            <a:schemeClr val="accent1"/>
+          </a:fillRef>
+          <a:effectRef idx="2">
+            <a:schemeClr val="accent1"/>
+          </a:effectRef>
+          <a:fontRef idx="minor">
+            <a:schemeClr val="lt1"/>
+          </a:fontRef>
+        </p:style>
+        <p:txBody>
+          <a:bodyPr rtlCol="0" anchor="ctr" lIns="54864" rIns="36576" tIns="0" bIns="0" wrap="square"/>
+          <a:lstStyle/>
+          <a:p>
+            <a:pPr algn="l"/>
+            <a:r>
+              <a:rPr sz="1000" b="0" i="0">
+                <a:solidFill>
+                  <a:srgbClr val="1A1A1A"/>
+                </a:solidFill>
+              </a:rPr>
+              <a:t>Shard · LE / desk range A</a:t>
+            </a:r>
+          </a:p>
+        </p:txBody>
+      </p:sp>
+      <p:cxnSp>
+        <p:nvCxnSpPr>
+          <p:cNvPr id="67" name="Connector 66"/>
+          <p:cNvCxnSpPr/>
+          <p:nvPr/>
+        </p:nvCxnSpPr>
+        <p:spPr>
+          <a:xfrm flipV="1">
+            <a:off x="8476488" y="3131820"/>
+            <a:ext cx="256031" cy="342900"/>
+          </a:xfrm>
+          <a:prstGeom prst="line">
+            <a:avLst/>
+          </a:prstGeom>
+          <a:ln w="12700">
+            <a:solidFill>
+              <a:srgbClr val="A51C30"/>
+            </a:solidFill>
+            <a:tailEnd type="triangle" w="med" len="med"/>
+          </a:ln>
+        </p:spPr>
+        <p:style>
+          <a:lnRef idx="2">
+            <a:schemeClr val="accent1"/>
+          </a:lnRef>
+          <a:fillRef idx="0">
+            <a:schemeClr val="accent1"/>
+          </a:fillRef>
+          <a:effectRef idx="1">
+            <a:schemeClr val="accent1"/>
+          </a:effectRef>
+          <a:fontRef idx="minor">
+            <a:schemeClr val="tx1"/>
+          </a:fontRef>
+        </p:style>
+      </p:cxnSp>
+      <p:sp>
+        <p:nvSpPr>
+          <p:cNvPr id="68" name="Rectangle 67"/>
+          <p:cNvSpPr/>
+          <p:nvPr/>
+        </p:nvSpPr>
+        <p:spPr>
+          <a:xfrm>
+            <a:off x="8732519" y="3328416"/>
+            <a:ext cx="1481328" cy="283464"/>
+          </a:xfrm>
+          <a:prstGeom prst="rect">
+            <a:avLst/>
+          </a:prstGeom>
+          <a:solidFill>
+            <a:srgbClr val="F7F5F2"/>
+          </a:solidFill>
+          <a:ln w="9525">
+            <a:solidFill>
+              <a:srgbClr val="CFC8BE"/>
+            </a:solidFill>
+          </a:ln>
+          <a:effectLst/>
+        </p:spPr>
+        <p:style>
+          <a:lnRef idx="1">
+            <a:schemeClr val="accent1"/>
+          </a:lnRef>
+          <a:fillRef idx="3">
+            <a:schemeClr val="accent1"/>
+          </a:fillRef>
+          <a:effectRef idx="2">
+            <a:schemeClr val="accent1"/>
+          </a:effectRef>
+          <a:fontRef idx="minor">
+            <a:schemeClr val="lt1"/>
+          </a:fontRef>
+        </p:style>
+        <p:txBody>
+          <a:bodyPr rtlCol="0" anchor="ctr" lIns="54864" rIns="36576" tIns="0" bIns="0" wrap="square"/>
+          <a:lstStyle/>
+          <a:p>
+            <a:pPr algn="l"/>
+            <a:r>
+              <a:rPr sz="1000" b="0" i="0">
+                <a:solidFill>
+                  <a:srgbClr val="1A1A1A"/>
+                </a:solidFill>
+              </a:rPr>
+              <a:t>Shard · range B</a:t>
+            </a:r>
+          </a:p>
+        </p:txBody>
+      </p:sp>
+      <p:cxnSp>
+        <p:nvCxnSpPr>
+          <p:cNvPr id="69" name="Connector 68"/>
+          <p:cNvCxnSpPr/>
+          <p:nvPr/>
+        </p:nvCxnSpPr>
+        <p:spPr>
+          <a:xfrm flipV="1">
+            <a:off x="8476488" y="3470148"/>
+            <a:ext cx="256031" cy="4572"/>
+          </a:xfrm>
+          <a:prstGeom prst="line">
+            <a:avLst/>
+          </a:prstGeom>
+          <a:ln w="12700">
+            <a:solidFill>
+              <a:srgbClr val="A51C30"/>
+            </a:solidFill>
+            <a:tailEnd type="triangle" w="med" len="med"/>
+          </a:ln>
+        </p:spPr>
+        <p:style>
+          <a:lnRef idx="2">
+            <a:schemeClr val="accent1"/>
+          </a:lnRef>
+          <a:fillRef idx="0">
+            <a:schemeClr val="accent1"/>
+          </a:fillRef>
+          <a:effectRef idx="1">
+            <a:schemeClr val="accent1"/>
+          </a:effectRef>
+          <a:fontRef idx="minor">
+            <a:schemeClr val="tx1"/>
+          </a:fontRef>
+        </p:style>
+      </p:cxnSp>
+      <p:sp>
+        <p:nvSpPr>
+          <p:cNvPr id="70" name="Rectangle 69"/>
+          <p:cNvSpPr/>
+          <p:nvPr/>
+        </p:nvSpPr>
+        <p:spPr>
+          <a:xfrm>
+            <a:off x="8732519" y="3666744"/>
+            <a:ext cx="1481328" cy="283464"/>
+          </a:xfrm>
+          <a:prstGeom prst="rect">
+            <a:avLst/>
+          </a:prstGeom>
+          <a:solidFill>
+            <a:srgbClr val="F7F5F2"/>
+          </a:solidFill>
+          <a:ln w="9525">
+            <a:solidFill>
+              <a:srgbClr val="CFC8BE"/>
+            </a:solidFill>
+          </a:ln>
+          <a:effectLst/>
+        </p:spPr>
+        <p:style>
+          <a:lnRef idx="1">
+            <a:schemeClr val="accent1"/>
+          </a:lnRef>
+          <a:fillRef idx="3">
+            <a:schemeClr val="accent1"/>
+          </a:fillRef>
+          <a:effectRef idx="2">
+            <a:schemeClr val="accent1"/>
+          </a:effectRef>
+          <a:fontRef idx="minor">
+            <a:schemeClr val="lt1"/>
+          </a:fontRef>
+        </p:style>
+        <p:txBody>
+          <a:bodyPr rtlCol="0" anchor="ctr" lIns="54864" rIns="36576" tIns="0" bIns="0" wrap="square"/>
+          <a:lstStyle/>
+          <a:p>
+            <a:pPr algn="l"/>
+            <a:r>
+              <a:rPr sz="1000" b="0" i="0">
+                <a:solidFill>
+                  <a:srgbClr val="1A1A1A"/>
+                </a:solidFill>
+              </a:rPr>
+              <a:t>Shard · range C</a:t>
+            </a:r>
+          </a:p>
+        </p:txBody>
+      </p:sp>
+      <p:cxnSp>
+        <p:nvCxnSpPr>
+          <p:cNvPr id="71" name="Connector 70"/>
+          <p:cNvCxnSpPr/>
+          <p:nvPr/>
+        </p:nvCxnSpPr>
+        <p:spPr>
+          <a:xfrm>
+            <a:off x="8476488" y="3474720"/>
+            <a:ext cx="256031" cy="333756"/>
+          </a:xfrm>
+          <a:prstGeom prst="line">
+            <a:avLst/>
+          </a:prstGeom>
+          <a:ln w="12700">
+            <a:solidFill>
+              <a:srgbClr val="A51C30"/>
+            </a:solidFill>
+            <a:tailEnd type="triangle" w="med" len="med"/>
+          </a:ln>
+        </p:spPr>
+        <p:style>
+          <a:lnRef idx="2">
+            <a:schemeClr val="accent1"/>
+          </a:lnRef>
+          <a:fillRef idx="0">
+            <a:schemeClr val="accent1"/>
+          </a:fillRef>
+          <a:effectRef idx="1">
+            <a:schemeClr val="accent1"/>
+          </a:effectRef>
+          <a:fontRef idx="minor">
+            <a:schemeClr val="tx1"/>
+          </a:fontRef>
+        </p:style>
+      </p:cxnSp>
+      <p:sp>
+        <p:nvSpPr>
+          <p:cNvPr id="72" name="Rounded Rectangle 71"/>
+          <p:cNvSpPr/>
+          <p:nvPr/>
+        </p:nvSpPr>
+        <p:spPr>
+          <a:xfrm>
+            <a:off x="7150607" y="4005072"/>
+            <a:ext cx="667512" cy="201168"/>
+          </a:xfrm>
+          <a:prstGeom prst="roundRect">
+            <a:avLst>
+              <a:gd name="adj" fmla="val 50000"/>
+            </a:avLst>
           </a:prstGeom>
           <a:solidFill>
             <a:srgbClr val="FFFFFF"/>
@@ -15959,23 +16733,31 @@
           </a:fontRef>
         </p:style>
         <p:txBody>
-          <a:bodyPr rtlCol="0" anchor="ctr" lIns="0" rIns="0" tIns="0" bIns="0"/>
+          <a:bodyPr rtlCol="0" anchor="ctr" lIns="18288" rIns="18288" tIns="0" bIns="0" wrap="square"/>
           <a:lstStyle/>
           <a:p>
             <a:pPr algn="ctr"/>
-          </a:p>
-        </p:txBody>
-      </p:sp>
-      <p:sp>
-        <p:nvSpPr>
-          <p:cNvPr id="56" name="TextBox 55"/>
+            <a:r>
+              <a:rPr sz="900" b="1" i="0">
+                <a:solidFill>
+                  <a:srgbClr val="A51C30"/>
+                </a:solidFill>
+              </a:rPr>
+              <a:t>DESIGNED</a:t>
+            </a:r>
+          </a:p>
+        </p:txBody>
+      </p:sp>
+      <p:sp>
+        <p:nvSpPr>
+          <p:cNvPr id="73" name="TextBox 72"/>
           <p:cNvSpPr txBox="1"/>
           <p:nvPr/>
         </p:nvSpPr>
         <p:spPr>
           <a:xfrm>
-            <a:off x="7132319" y="1883664"/>
-            <a:ext cx="3456432" cy="603504"/>
+            <a:off x="8065008" y="3986784"/>
+            <a:ext cx="2194560" cy="237744"/>
           </a:xfrm>
           <a:prstGeom prst="rect">
             <a:avLst/>
@@ -15990,12 +16772,92 @@
           <a:p>
             <a:pPr algn="l"/>
             <a:r>
-              <a:rPr sz="1200" b="1" i="0">
+              <a:rPr sz="1000" b="0" i="1">
+                <a:solidFill>
+                  <a:srgbClr val="4A5058"/>
+                </a:solidFill>
+              </a:rPr>
+              <a:t>map-reduce over vectors</a:t>
+            </a:r>
+          </a:p>
+        </p:txBody>
+      </p:sp>
+      <p:sp>
+        <p:nvSpPr>
+          <p:cNvPr id="74" name="Rectangle 73"/>
+          <p:cNvSpPr/>
+          <p:nvPr/>
+        </p:nvSpPr>
+        <p:spPr>
+          <a:xfrm>
+            <a:off x="10351008" y="2990088"/>
+            <a:ext cx="950976" cy="713232"/>
+          </a:xfrm>
+          <a:prstGeom prst="rect">
+            <a:avLst/>
+          </a:prstGeom>
+          <a:solidFill>
+            <a:srgbClr val="FFFFFF"/>
+          </a:solidFill>
+          <a:ln w="9525">
+            <a:solidFill>
+              <a:srgbClr val="CFC8BE"/>
+            </a:solidFill>
+          </a:ln>
+          <a:effectLst/>
+        </p:spPr>
+        <p:style>
+          <a:lnRef idx="1">
+            <a:schemeClr val="accent1"/>
+          </a:lnRef>
+          <a:fillRef idx="3">
+            <a:schemeClr val="accent1"/>
+          </a:fillRef>
+          <a:effectRef idx="2">
+            <a:schemeClr val="accent1"/>
+          </a:effectRef>
+          <a:fontRef idx="minor">
+            <a:schemeClr val="lt1"/>
+          </a:fontRef>
+        </p:style>
+        <p:txBody>
+          <a:bodyPr rtlCol="0" anchor="ctr" lIns="0" rIns="0" tIns="0" bIns="0"/>
+          <a:lstStyle/>
+          <a:p>
+            <a:pPr algn="ctr"/>
+          </a:p>
+        </p:txBody>
+      </p:sp>
+      <p:sp>
+        <p:nvSpPr>
+          <p:cNvPr id="75" name="TextBox 74"/>
+          <p:cNvSpPr txBox="1"/>
+          <p:nvPr/>
+        </p:nvSpPr>
+        <p:spPr>
+          <a:xfrm>
+            <a:off x="10415016" y="3017520"/>
+            <a:ext cx="859536" cy="457200"/>
+          </a:xfrm>
+          <a:prstGeom prst="rect">
+            <a:avLst/>
+          </a:prstGeom>
+          <a:noFill/>
+        </p:spPr>
+        <p:txBody>
+          <a:bodyPr wrap="square" lIns="0" rIns="0" tIns="0" bIns="0" anchor="t">
+            <a:spAutoFit/>
+          </a:bodyPr>
+          <a:lstStyle/>
+          <a:p>
+            <a:pPr algn="l"/>
+            <a:r>
+              <a:rPr sz="1100" b="1" i="0">
                 <a:solidFill>
                   <a:srgbClr val="8A1626"/>
                 </a:solidFill>
               </a:rPr>
-              <a:t>Consoles × N</a:t>
+              <a:t>Read replicas</a:t>
             </a:r>
           </a:p>
           <a:p>
@@ -16006,20 +16868,20 @@
                   <a:srgbClr val="4A5058"/>
                 </a:solidFill>
               </a:rPr>
-              <a:t>worker processes relay a tab's channel; sticky sessions across consoles; one DRISHTI_SESSION_SECRET; servers discovered</a:t>
-            </a:r>
-          </a:p>
-        </p:txBody>
-      </p:sp>
-      <p:sp>
-        <p:nvSpPr>
-          <p:cNvPr id="57" name="Rounded Rectangle 56"/>
+              <a:t>whole dates</a:t>
+            </a:r>
+          </a:p>
+        </p:txBody>
+      </p:sp>
+      <p:sp>
+        <p:nvSpPr>
+          <p:cNvPr id="76" name="Rounded Rectangle 75"/>
           <p:cNvSpPr/>
           <p:nvPr/>
         </p:nvSpPr>
         <p:spPr>
           <a:xfrm>
-            <a:off x="10753344" y="1938528"/>
+            <a:off x="10415016" y="3474720"/>
             <a:ext cx="566928" cy="201168"/>
           </a:xfrm>
           <a:prstGeom prst="roundRect">
@@ -16067,584 +16929,16 @@
           </a:p>
         </p:txBody>
       </p:sp>
-      <p:cxnSp>
-        <p:nvCxnSpPr>
-          <p:cNvPr id="58" name="Connector 57"/>
-          <p:cNvCxnSpPr/>
-          <p:nvPr/>
-        </p:nvCxnSpPr>
-        <p:spPr>
-          <a:xfrm>
-            <a:off x="9226296" y="2505456"/>
-            <a:ext cx="0" cy="164592"/>
-          </a:xfrm>
-          <a:prstGeom prst="line">
-            <a:avLst/>
-          </a:prstGeom>
-          <a:ln w="15875">
-            <a:solidFill>
-              <a:srgbClr val="A51C30"/>
-            </a:solidFill>
-            <a:tailEnd type="triangle" w="med" len="med"/>
-          </a:ln>
-        </p:spPr>
-        <p:style>
-          <a:lnRef idx="2">
-            <a:schemeClr val="accent1"/>
-          </a:lnRef>
-          <a:fillRef idx="0">
-            <a:schemeClr val="accent1"/>
-          </a:fillRef>
-          <a:effectRef idx="1">
-            <a:schemeClr val="accent1"/>
-          </a:effectRef>
-          <a:fontRef idx="minor">
-            <a:schemeClr val="tx1"/>
-          </a:fontRef>
-        </p:style>
-      </p:cxnSp>
-      <p:sp>
-        <p:nvSpPr>
-          <p:cNvPr id="59" name="Rounded Rectangle 58"/>
+      <p:sp>
+        <p:nvSpPr>
+          <p:cNvPr id="77" name="Rectangle 76"/>
           <p:cNvSpPr/>
           <p:nvPr/>
         </p:nvSpPr>
         <p:spPr>
           <a:xfrm>
-            <a:off x="7040879" y="2670048"/>
-            <a:ext cx="4370832" cy="1938528"/>
-          </a:xfrm>
-          <a:prstGeom prst="roundRect">
-            <a:avLst>
-              <a:gd name="adj" fmla="val 6000"/>
-            </a:avLst>
-          </a:prstGeom>
-          <a:noFill/>
-          <a:ln w="12700">
-            <a:solidFill>
-              <a:srgbClr val="A51C30"/>
-            </a:solidFill>
-            <a:prstDash val="dash"/>
-          </a:ln>
-          <a:effectLst/>
-        </p:spPr>
-        <p:style>
-          <a:lnRef idx="1">
-            <a:schemeClr val="accent1"/>
-          </a:lnRef>
-          <a:fillRef idx="3">
-            <a:schemeClr val="accent1"/>
-          </a:fillRef>
-          <a:effectRef idx="2">
-            <a:schemeClr val="accent1"/>
-          </a:effectRef>
-          <a:fontRef idx="minor">
-            <a:schemeClr val="lt1"/>
-          </a:fontRef>
-        </p:style>
-        <p:txBody>
-          <a:bodyPr rtlCol="0" anchor="ctr" lIns="0" rIns="0" tIns="0" bIns="0"/>
-          <a:lstStyle/>
-          <a:p>
-            <a:pPr algn="ctr"/>
-          </a:p>
-        </p:txBody>
-      </p:sp>
-      <p:sp>
-        <p:nvSpPr>
-          <p:cNvPr id="60" name="TextBox 59"/>
-          <p:cNvSpPr txBox="1"/>
-          <p:nvPr/>
-        </p:nvSpPr>
-        <p:spPr>
-          <a:xfrm>
-            <a:off x="7150607" y="2697480"/>
-            <a:ext cx="2194560" cy="237744"/>
-          </a:xfrm>
-          <a:prstGeom prst="rect">
-            <a:avLst/>
-          </a:prstGeom>
-          <a:noFill/>
-        </p:spPr>
-        <p:txBody>
-          <a:bodyPr wrap="square" lIns="0" rIns="0" tIns="0" bIns="0" anchor="ctr">
-            <a:spAutoFit/>
-          </a:bodyPr>
-          <a:lstStyle/>
-          <a:p>
-            <a:pPr algn="l"/>
-            <a:r>
-              <a:rPr sz="1100" b="1" i="0">
-                <a:solidFill>
-                  <a:srgbClr val="A51C30"/>
-                </a:solidFill>
-              </a:rPr>
-              <a:t>Drishti*net servers</a:t>
-            </a:r>
-          </a:p>
-        </p:txBody>
-      </p:sp>
-      <p:sp>
-        <p:nvSpPr>
-          <p:cNvPr id="61" name="Rectangle 60"/>
-          <p:cNvSpPr/>
-          <p:nvPr/>
-        </p:nvSpPr>
-        <p:spPr>
-          <a:xfrm>
-            <a:off x="7150607" y="3017520"/>
-            <a:ext cx="1325880" cy="914400"/>
-          </a:xfrm>
-          <a:prstGeom prst="rect">
-            <a:avLst/>
-          </a:prstGeom>
-          <a:solidFill>
-            <a:srgbClr val="F6E6E9"/>
-          </a:solidFill>
-          <a:ln w="9525">
-            <a:solidFill>
-              <a:srgbClr val="A51C30"/>
-            </a:solidFill>
-          </a:ln>
-          <a:effectLst/>
-        </p:spPr>
-        <p:style>
-          <a:lnRef idx="1">
-            <a:schemeClr val="accent1"/>
-          </a:lnRef>
-          <a:fillRef idx="3">
-            <a:schemeClr val="accent1"/>
-          </a:fillRef>
-          <a:effectRef idx="2">
-            <a:schemeClr val="accent1"/>
-          </a:effectRef>
-          <a:fontRef idx="minor">
-            <a:schemeClr val="lt1"/>
-          </a:fontRef>
-        </p:style>
-        <p:txBody>
-          <a:bodyPr rtlCol="0" anchor="ctr" lIns="0" rIns="0" tIns="0" bIns="0"/>
-          <a:lstStyle/>
-          <a:p>
-            <a:pPr algn="ctr"/>
-          </a:p>
-        </p:txBody>
-      </p:sp>
-      <p:sp>
-        <p:nvSpPr>
-          <p:cNvPr id="62" name="TextBox 61"/>
-          <p:cNvSpPr txBox="1"/>
-          <p:nvPr/>
-        </p:nvSpPr>
-        <p:spPr>
-          <a:xfrm>
-            <a:off x="7205471" y="3035808"/>
-            <a:ext cx="1234440" cy="877824"/>
-          </a:xfrm>
-          <a:prstGeom prst="rect">
-            <a:avLst/>
-          </a:prstGeom>
-          <a:noFill/>
-        </p:spPr>
-        <p:txBody>
-          <a:bodyPr wrap="square" lIns="0" rIns="0" tIns="0" bIns="0" anchor="ctr">
-            <a:spAutoFit/>
-          </a:bodyPr>
-          <a:lstStyle/>
-          <a:p>
-            <a:pPr algn="l"/>
-            <a:r>
-              <a:rPr sz="1150" b="1" i="0">
-                <a:solidFill>
-                  <a:srgbClr val="8A1626"/>
-                </a:solidFill>
-              </a:rPr>
-              <a:t>Coordinator</a:t>
-            </a:r>
-          </a:p>
-          <a:p>
-            <a:pPr algn="l"/>
-            <a:r>
-              <a:rPr sz="1000" b="0" i="0">
-                <a:solidFill>
-                  <a:srgbClr val="4A5058"/>
-                </a:solidFill>
-              </a:rPr>
-              <a:t>adds partial vectors (4 KB each) in a fixed order</a:t>
-            </a:r>
-          </a:p>
-        </p:txBody>
-      </p:sp>
-      <p:sp>
-        <p:nvSpPr>
-          <p:cNvPr id="63" name="Rectangle 62"/>
-          <p:cNvSpPr/>
-          <p:nvPr/>
-        </p:nvSpPr>
-        <p:spPr>
-          <a:xfrm>
-            <a:off x="8732519" y="2990088"/>
-            <a:ext cx="1481328" cy="283464"/>
-          </a:xfrm>
-          <a:prstGeom prst="rect">
-            <a:avLst/>
-          </a:prstGeom>
-          <a:solidFill>
-            <a:srgbClr val="F7F5F2"/>
-          </a:solidFill>
-          <a:ln w="9525">
-            <a:solidFill>
-              <a:srgbClr val="CFC8BE"/>
-            </a:solidFill>
-          </a:ln>
-          <a:effectLst/>
-        </p:spPr>
-        <p:style>
-          <a:lnRef idx="1">
-            <a:schemeClr val="accent1"/>
-          </a:lnRef>
-          <a:fillRef idx="3">
-            <a:schemeClr val="accent1"/>
-          </a:fillRef>
-          <a:effectRef idx="2">
-            <a:schemeClr val="accent1"/>
-          </a:effectRef>
-          <a:fontRef idx="minor">
-            <a:schemeClr val="lt1"/>
-          </a:fontRef>
-        </p:style>
-        <p:txBody>
-          <a:bodyPr rtlCol="0" anchor="ctr" lIns="54864" rIns="36576" tIns="0" bIns="0" wrap="square"/>
-          <a:lstStyle/>
-          <a:p>
-            <a:pPr algn="l"/>
-            <a:r>
-              <a:rPr sz="1000" b="0" i="0">
-                <a:solidFill>
-                  <a:srgbClr val="1A1A1A"/>
-                </a:solidFill>
-              </a:rPr>
-              <a:t>Shard · LE / desk range A</a:t>
-            </a:r>
-          </a:p>
-        </p:txBody>
-      </p:sp>
-      <p:cxnSp>
-        <p:nvCxnSpPr>
-          <p:cNvPr id="64" name="Connector 63"/>
-          <p:cNvCxnSpPr/>
-          <p:nvPr/>
-        </p:nvCxnSpPr>
-        <p:spPr>
-          <a:xfrm flipV="1">
-            <a:off x="8476488" y="3131820"/>
-            <a:ext cx="256031" cy="342900"/>
-          </a:xfrm>
-          <a:prstGeom prst="line">
-            <a:avLst/>
-          </a:prstGeom>
-          <a:ln w="12700">
-            <a:solidFill>
-              <a:srgbClr val="A51C30"/>
-            </a:solidFill>
-            <a:tailEnd type="triangle" w="med" len="med"/>
-          </a:ln>
-        </p:spPr>
-        <p:style>
-          <a:lnRef idx="2">
-            <a:schemeClr val="accent1"/>
-          </a:lnRef>
-          <a:fillRef idx="0">
-            <a:schemeClr val="accent1"/>
-          </a:fillRef>
-          <a:effectRef idx="1">
-            <a:schemeClr val="accent1"/>
-          </a:effectRef>
-          <a:fontRef idx="minor">
-            <a:schemeClr val="tx1"/>
-          </a:fontRef>
-        </p:style>
-      </p:cxnSp>
-      <p:sp>
-        <p:nvSpPr>
-          <p:cNvPr id="65" name="Rectangle 64"/>
-          <p:cNvSpPr/>
-          <p:nvPr/>
-        </p:nvSpPr>
-        <p:spPr>
-          <a:xfrm>
-            <a:off x="8732519" y="3328416"/>
-            <a:ext cx="1481328" cy="283464"/>
-          </a:xfrm>
-          <a:prstGeom prst="rect">
-            <a:avLst/>
-          </a:prstGeom>
-          <a:solidFill>
-            <a:srgbClr val="F7F5F2"/>
-          </a:solidFill>
-          <a:ln w="9525">
-            <a:solidFill>
-              <a:srgbClr val="CFC8BE"/>
-            </a:solidFill>
-          </a:ln>
-          <a:effectLst/>
-        </p:spPr>
-        <p:style>
-          <a:lnRef idx="1">
-            <a:schemeClr val="accent1"/>
-          </a:lnRef>
-          <a:fillRef idx="3">
-            <a:schemeClr val="accent1"/>
-          </a:fillRef>
-          <a:effectRef idx="2">
-            <a:schemeClr val="accent1"/>
-          </a:effectRef>
-          <a:fontRef idx="minor">
-            <a:schemeClr val="lt1"/>
-          </a:fontRef>
-        </p:style>
-        <p:txBody>
-          <a:bodyPr rtlCol="0" anchor="ctr" lIns="54864" rIns="36576" tIns="0" bIns="0" wrap="square"/>
-          <a:lstStyle/>
-          <a:p>
-            <a:pPr algn="l"/>
-            <a:r>
-              <a:rPr sz="1000" b="0" i="0">
-                <a:solidFill>
-                  <a:srgbClr val="1A1A1A"/>
-                </a:solidFill>
-              </a:rPr>
-              <a:t>Shard · range B</a:t>
-            </a:r>
-          </a:p>
-        </p:txBody>
-      </p:sp>
-      <p:cxnSp>
-        <p:nvCxnSpPr>
-          <p:cNvPr id="66" name="Connector 65"/>
-          <p:cNvCxnSpPr/>
-          <p:nvPr/>
-        </p:nvCxnSpPr>
-        <p:spPr>
-          <a:xfrm flipV="1">
-            <a:off x="8476488" y="3470148"/>
-            <a:ext cx="256031" cy="4572"/>
-          </a:xfrm>
-          <a:prstGeom prst="line">
-            <a:avLst/>
-          </a:prstGeom>
-          <a:ln w="12700">
-            <a:solidFill>
-              <a:srgbClr val="A51C30"/>
-            </a:solidFill>
-            <a:tailEnd type="triangle" w="med" len="med"/>
-          </a:ln>
-        </p:spPr>
-        <p:style>
-          <a:lnRef idx="2">
-            <a:schemeClr val="accent1"/>
-          </a:lnRef>
-          <a:fillRef idx="0">
-            <a:schemeClr val="accent1"/>
-          </a:fillRef>
-          <a:effectRef idx="1">
-            <a:schemeClr val="accent1"/>
-          </a:effectRef>
-          <a:fontRef idx="minor">
-            <a:schemeClr val="tx1"/>
-          </a:fontRef>
-        </p:style>
-      </p:cxnSp>
-      <p:sp>
-        <p:nvSpPr>
-          <p:cNvPr id="67" name="Rectangle 66"/>
-          <p:cNvSpPr/>
-          <p:nvPr/>
-        </p:nvSpPr>
-        <p:spPr>
-          <a:xfrm>
-            <a:off x="8732519" y="3666744"/>
-            <a:ext cx="1481328" cy="283464"/>
-          </a:xfrm>
-          <a:prstGeom prst="rect">
-            <a:avLst/>
-          </a:prstGeom>
-          <a:solidFill>
-            <a:srgbClr val="F7F5F2"/>
-          </a:solidFill>
-          <a:ln w="9525">
-            <a:solidFill>
-              <a:srgbClr val="CFC8BE"/>
-            </a:solidFill>
-          </a:ln>
-          <a:effectLst/>
-        </p:spPr>
-        <p:style>
-          <a:lnRef idx="1">
-            <a:schemeClr val="accent1"/>
-          </a:lnRef>
-          <a:fillRef idx="3">
-            <a:schemeClr val="accent1"/>
-          </a:fillRef>
-          <a:effectRef idx="2">
-            <a:schemeClr val="accent1"/>
-          </a:effectRef>
-          <a:fontRef idx="minor">
-            <a:schemeClr val="lt1"/>
-          </a:fontRef>
-        </p:style>
-        <p:txBody>
-          <a:bodyPr rtlCol="0" anchor="ctr" lIns="54864" rIns="36576" tIns="0" bIns="0" wrap="square"/>
-          <a:lstStyle/>
-          <a:p>
-            <a:pPr algn="l"/>
-            <a:r>
-              <a:rPr sz="1000" b="0" i="0">
-                <a:solidFill>
-                  <a:srgbClr val="1A1A1A"/>
-                </a:solidFill>
-              </a:rPr>
-              <a:t>Shard · range C</a:t>
-            </a:r>
-          </a:p>
-        </p:txBody>
-      </p:sp>
-      <p:cxnSp>
-        <p:nvCxnSpPr>
-          <p:cNvPr id="68" name="Connector 67"/>
-          <p:cNvCxnSpPr/>
-          <p:nvPr/>
-        </p:nvCxnSpPr>
-        <p:spPr>
-          <a:xfrm>
-            <a:off x="8476488" y="3474720"/>
-            <a:ext cx="256031" cy="333756"/>
-          </a:xfrm>
-          <a:prstGeom prst="line">
-            <a:avLst/>
-          </a:prstGeom>
-          <a:ln w="12700">
-            <a:solidFill>
-              <a:srgbClr val="A51C30"/>
-            </a:solidFill>
-            <a:tailEnd type="triangle" w="med" len="med"/>
-          </a:ln>
-        </p:spPr>
-        <p:style>
-          <a:lnRef idx="2">
-            <a:schemeClr val="accent1"/>
-          </a:lnRef>
-          <a:fillRef idx="0">
-            <a:schemeClr val="accent1"/>
-          </a:fillRef>
-          <a:effectRef idx="1">
-            <a:schemeClr val="accent1"/>
-          </a:effectRef>
-          <a:fontRef idx="minor">
-            <a:schemeClr val="tx1"/>
-          </a:fontRef>
-        </p:style>
-      </p:cxnSp>
-      <p:sp>
-        <p:nvSpPr>
-          <p:cNvPr id="69" name="Rounded Rectangle 68"/>
-          <p:cNvSpPr/>
-          <p:nvPr/>
-        </p:nvSpPr>
-        <p:spPr>
-          <a:xfrm>
-            <a:off x="7150607" y="4005072"/>
-            <a:ext cx="667512" cy="201168"/>
-          </a:xfrm>
-          <a:prstGeom prst="roundRect">
-            <a:avLst>
-              <a:gd name="adj" fmla="val 50000"/>
-            </a:avLst>
-          </a:prstGeom>
-          <a:solidFill>
-            <a:srgbClr val="FFFFFF"/>
-          </a:solidFill>
-          <a:ln w="12700">
-            <a:solidFill>
-              <a:srgbClr val="A51C30"/>
-            </a:solidFill>
-          </a:ln>
-          <a:effectLst/>
-        </p:spPr>
-        <p:style>
-          <a:lnRef idx="1">
-            <a:schemeClr val="accent1"/>
-          </a:lnRef>
-          <a:fillRef idx="3">
-            <a:schemeClr val="accent1"/>
-          </a:fillRef>
-          <a:effectRef idx="2">
-            <a:schemeClr val="accent1"/>
-          </a:effectRef>
-          <a:fontRef idx="minor">
-            <a:schemeClr val="lt1"/>
-          </a:fontRef>
-        </p:style>
-        <p:txBody>
-          <a:bodyPr rtlCol="0" anchor="ctr" lIns="18288" rIns="18288" tIns="0" bIns="0" wrap="square"/>
-          <a:lstStyle/>
-          <a:p>
-            <a:pPr algn="ctr"/>
-            <a:r>
-              <a:rPr sz="900" b="1" i="0">
-                <a:solidFill>
-                  <a:srgbClr val="A51C30"/>
-                </a:solidFill>
-              </a:rPr>
-              <a:t>DESIGNED</a:t>
-            </a:r>
-          </a:p>
-        </p:txBody>
-      </p:sp>
-      <p:sp>
-        <p:nvSpPr>
-          <p:cNvPr id="70" name="TextBox 69"/>
-          <p:cNvSpPr txBox="1"/>
-          <p:nvPr/>
-        </p:nvSpPr>
-        <p:spPr>
-          <a:xfrm>
-            <a:off x="8065008" y="3986784"/>
-            <a:ext cx="2194560" cy="237744"/>
-          </a:xfrm>
-          <a:prstGeom prst="rect">
-            <a:avLst/>
-          </a:prstGeom>
-          <a:noFill/>
-        </p:spPr>
-        <p:txBody>
-          <a:bodyPr wrap="square" lIns="0" rIns="0" tIns="0" bIns="0" anchor="ctr">
-            <a:spAutoFit/>
-          </a:bodyPr>
-          <a:lstStyle/>
-          <a:p>
-            <a:pPr algn="l"/>
-            <a:r>
-              <a:rPr sz="1000" b="0" i="1">
-                <a:solidFill>
-                  <a:srgbClr val="4A5058"/>
-                </a:solidFill>
-              </a:rPr>
-              <a:t>map-reduce over vectors</a:t>
-            </a:r>
-          </a:p>
-        </p:txBody>
-      </p:sp>
-      <p:sp>
-        <p:nvSpPr>
-          <p:cNvPr id="71" name="Rectangle 70"/>
-          <p:cNvSpPr/>
-          <p:nvPr/>
-        </p:nvSpPr>
-        <p:spPr>
-          <a:xfrm>
-            <a:off x="10351008" y="2990088"/>
-            <a:ext cx="950976" cy="713232"/>
+            <a:off x="10351008" y="3776472"/>
+            <a:ext cx="950976" cy="749808"/>
           </a:xfrm>
           <a:prstGeom prst="rect">
             <a:avLst/>
@@ -16683,13 +16977,13 @@
       </p:sp>
       <p:sp>
         <p:nvSpPr>
-          <p:cNvPr id="72" name="TextBox 71"/>
+          <p:cNvPr id="78" name="TextBox 77"/>
           <p:cNvSpPr txBox="1"/>
           <p:nvPr/>
         </p:nvSpPr>
         <p:spPr>
           <a:xfrm>
-            <a:off x="10415016" y="3017520"/>
+            <a:off x="10415016" y="3803904"/>
             <a:ext cx="859536" cy="457200"/>
           </a:xfrm>
           <a:prstGeom prst="rect">
@@ -16710,7 +17004,7 @@
                   <a:srgbClr val="8A1626"/>
                 </a:solidFill>
               </a:rPr>
-              <a:t>Read replicas</a:t>
+              <a:t>Official EOD</a:t>
             </a:r>
           </a:p>
           <a:p>
@@ -16721,153 +17015,6 @@
                   <a:srgbClr val="4A5058"/>
                 </a:solidFill>
               </a:rPr>
-              <a:t>whole dates</a:t>
-            </a:r>
-          </a:p>
-        </p:txBody>
-      </p:sp>
-      <p:sp>
-        <p:nvSpPr>
-          <p:cNvPr id="73" name="Rounded Rectangle 72"/>
-          <p:cNvSpPr/>
-          <p:nvPr/>
-        </p:nvSpPr>
-        <p:spPr>
-          <a:xfrm>
-            <a:off x="10415016" y="3474720"/>
-            <a:ext cx="566928" cy="201168"/>
-          </a:xfrm>
-          <a:prstGeom prst="roundRect">
-            <a:avLst>
-              <a:gd name="adj" fmla="val 50000"/>
-            </a:avLst>
-          </a:prstGeom>
-          <a:solidFill>
-            <a:srgbClr val="A51C30"/>
-          </a:solidFill>
-          <a:ln w="12700">
-            <a:solidFill>
-              <a:srgbClr val="A51C30"/>
-            </a:solidFill>
-          </a:ln>
-          <a:effectLst/>
-        </p:spPr>
-        <p:style>
-          <a:lnRef idx="1">
-            <a:schemeClr val="accent1"/>
-          </a:lnRef>
-          <a:fillRef idx="3">
-            <a:schemeClr val="accent1"/>
-          </a:fillRef>
-          <a:effectRef idx="2">
-            <a:schemeClr val="accent1"/>
-          </a:effectRef>
-          <a:fontRef idx="minor">
-            <a:schemeClr val="lt1"/>
-          </a:fontRef>
-        </p:style>
-        <p:txBody>
-          <a:bodyPr rtlCol="0" anchor="ctr" lIns="18288" rIns="18288" tIns="0" bIns="0" wrap="square"/>
-          <a:lstStyle/>
-          <a:p>
-            <a:pPr algn="ctr"/>
-            <a:r>
-              <a:rPr sz="900" b="1" i="0">
-                <a:solidFill>
-                  <a:srgbClr val="FFFFFF"/>
-                </a:solidFill>
-              </a:rPr>
-              <a:t>BUILT</a:t>
-            </a:r>
-          </a:p>
-        </p:txBody>
-      </p:sp>
-      <p:sp>
-        <p:nvSpPr>
-          <p:cNvPr id="74" name="Rectangle 73"/>
-          <p:cNvSpPr/>
-          <p:nvPr/>
-        </p:nvSpPr>
-        <p:spPr>
-          <a:xfrm>
-            <a:off x="10351008" y="3776472"/>
-            <a:ext cx="950976" cy="749808"/>
-          </a:xfrm>
-          <a:prstGeom prst="rect">
-            <a:avLst/>
-          </a:prstGeom>
-          <a:solidFill>
-            <a:srgbClr val="FFFFFF"/>
-          </a:solidFill>
-          <a:ln w="9525">
-            <a:solidFill>
-              <a:srgbClr val="CFC8BE"/>
-            </a:solidFill>
-          </a:ln>
-          <a:effectLst/>
-        </p:spPr>
-        <p:style>
-          <a:lnRef idx="1">
-            <a:schemeClr val="accent1"/>
-          </a:lnRef>
-          <a:fillRef idx="3">
-            <a:schemeClr val="accent1"/>
-          </a:fillRef>
-          <a:effectRef idx="2">
-            <a:schemeClr val="accent1"/>
-          </a:effectRef>
-          <a:fontRef idx="minor">
-            <a:schemeClr val="lt1"/>
-          </a:fontRef>
-        </p:style>
-        <p:txBody>
-          <a:bodyPr rtlCol="0" anchor="ctr" lIns="0" rIns="0" tIns="0" bIns="0"/>
-          <a:lstStyle/>
-          <a:p>
-            <a:pPr algn="ctr"/>
-          </a:p>
-        </p:txBody>
-      </p:sp>
-      <p:sp>
-        <p:nvSpPr>
-          <p:cNvPr id="75" name="TextBox 74"/>
-          <p:cNvSpPr txBox="1"/>
-          <p:nvPr/>
-        </p:nvSpPr>
-        <p:spPr>
-          <a:xfrm>
-            <a:off x="10415016" y="3803904"/>
-            <a:ext cx="859536" cy="457200"/>
-          </a:xfrm>
-          <a:prstGeom prst="rect">
-            <a:avLst/>
-          </a:prstGeom>
-          <a:noFill/>
-        </p:spPr>
-        <p:txBody>
-          <a:bodyPr wrap="square" lIns="0" rIns="0" tIns="0" bIns="0" anchor="t">
-            <a:spAutoFit/>
-          </a:bodyPr>
-          <a:lstStyle/>
-          <a:p>
-            <a:pPr algn="l"/>
-            <a:r>
-              <a:rPr sz="1100" b="1" i="0">
-                <a:solidFill>
-                  <a:srgbClr val="8A1626"/>
-                </a:solidFill>
-              </a:rPr>
-              <a:t>Official EOD</a:t>
-            </a:r>
-          </a:p>
-          <a:p>
-            <a:pPr algn="l"/>
-            <a:r>
-              <a:rPr sz="1000" b="0" i="0">
-                <a:solidFill>
-                  <a:srgbClr val="4A5058"/>
-                </a:solidFill>
-              </a:rPr>
               <a:t>one node writes</a:t>
             </a:r>
           </a:p>
@@ -16875,7 +17022,7 @@
       </p:sp>
       <p:sp>
         <p:nvSpPr>
-          <p:cNvPr id="76" name="Rounded Rectangle 75"/>
+          <p:cNvPr id="79" name="Rounded Rectangle 78"/>
           <p:cNvSpPr/>
           <p:nvPr/>
         </p:nvSpPr>
@@ -16932,7 +17079,7 @@
       </p:sp>
       <p:cxnSp>
         <p:nvCxnSpPr>
-          <p:cNvPr id="77" name="Connector 76"/>
+          <p:cNvPr id="80" name="Connector 79"/>
           <p:cNvCxnSpPr/>
           <p:nvPr/>
         </p:nvCxnSpPr>
@@ -16968,7 +17115,7 @@
       </p:cxnSp>
       <p:sp>
         <p:nvSpPr>
-          <p:cNvPr id="78" name="Rectangle 77"/>
+          <p:cNvPr id="81" name="Rectangle 80"/>
           <p:cNvSpPr/>
           <p:nvPr/>
         </p:nvSpPr>
@@ -17020,7 +17167,7 @@
       </p:sp>
       <p:sp>
         <p:nvSpPr>
-          <p:cNvPr id="79" name="Rectangle 78"/>
+          <p:cNvPr id="82" name="Rectangle 81"/>
           <p:cNvSpPr/>
           <p:nvPr/>
         </p:nvSpPr>
@@ -17064,7 +17211,7 @@
       </p:sp>
       <p:sp>
         <p:nvSpPr>
-          <p:cNvPr id="80" name="Rectangle 79"/>
+          <p:cNvPr id="83" name="Rectangle 82"/>
           <p:cNvSpPr/>
           <p:nvPr/>
         </p:nvSpPr>
@@ -17108,7 +17255,7 @@
       </p:sp>
       <p:sp>
         <p:nvSpPr>
-          <p:cNvPr id="81" name="TextBox 80"/>
+          <p:cNvPr id="84" name="TextBox 83"/>
           <p:cNvSpPr txBox="1"/>
           <p:nvPr/>
         </p:nvSpPr>
@@ -17142,14 +17289,14 @@
       </p:sp>
       <p:sp>
         <p:nvSpPr>
-          <p:cNvPr id="82" name="TextBox 81"/>
+          <p:cNvPr id="85" name="TextBox 84"/>
           <p:cNvSpPr txBox="1"/>
           <p:nvPr/>
         </p:nvSpPr>
         <p:spPr>
           <a:xfrm>
-            <a:off x="978408" y="5522976"/>
-            <a:ext cx="5120640" cy="731520"/>
+            <a:off x="978408" y="5486400"/>
+            <a:ext cx="5120640" cy="768096"/>
           </a:xfrm>
           <a:prstGeom prst="rect">
             <a:avLst/>
@@ -17164,11 +17311,11 @@
           <a:p>
             <a:pPr algn="l">
               <a:spcAft>
-                <a:spcPts val="100"/>
+                <a:spcPts val="0"/>
               </a:spcAft>
             </a:pPr>
             <a:r>
-              <a:rPr sz="1150" b="0" i="0">
+              <a:rPr sz="1100" b="0" i="0">
                 <a:solidFill>
                   <a:srgbClr val="1A1A1A"/>
                 </a:solidFill>
@@ -17179,11 +17326,11 @@
           <a:p>
             <a:pPr algn="l">
               <a:spcAft>
-                <a:spcPts val="100"/>
+                <a:spcPts val="0"/>
               </a:spcAft>
             </a:pPr>
             <a:r>
-              <a:rPr sz="1150" b="0" i="0">
+              <a:rPr sz="1100" b="0" i="0">
                 <a:solidFill>
                   <a:srgbClr val="1A1A1A"/>
                 </a:solidFill>
@@ -17194,11 +17341,11 @@
           <a:p>
             <a:pPr algn="l">
               <a:spcAft>
-                <a:spcPts val="100"/>
+                <a:spcPts val="0"/>
               </a:spcAft>
             </a:pPr>
             <a:r>
-              <a:rPr sz="1150" b="0" i="0">
+              <a:rPr sz="1100" b="0" i="0">
                 <a:solidFill>
                   <a:srgbClr val="1A1A1A"/>
                 </a:solidFill>
@@ -17206,18 +17353,33 @@
               <a:t>3  The lake layout at scale: sort, ZSTD, file sizes</a:t>
             </a:r>
           </a:p>
-        </p:txBody>
-      </p:sp>
-      <p:sp>
-        <p:nvSpPr>
-          <p:cNvPr id="83" name="TextBox 82"/>
+          <a:p>
+            <a:pPr algn="l">
+              <a:spcAft>
+                <a:spcPts val="0"/>
+              </a:spcAft>
+            </a:pPr>
+            <a:r>
+              <a:rPr sz="1100" b="0" i="0">
+                <a:solidFill>
+                  <a:srgbClr val="1A1A1A"/>
+                </a:solidFill>
+              </a:rPr>
+              <a:t>4  Portfolio vectors in a batch; &gt; 100,000 rows read</a:t>
+            </a:r>
+          </a:p>
+        </p:txBody>
+      </p:sp>
+      <p:sp>
+        <p:nvSpPr>
+          <p:cNvPr id="86" name="TextBox 85"/>
           <p:cNvSpPr txBox="1"/>
           <p:nvPr/>
         </p:nvSpPr>
         <p:spPr>
           <a:xfrm>
-            <a:off x="6236208" y="5522976"/>
-            <a:ext cx="5120640" cy="731520"/>
+            <a:off x="6236208" y="5486400"/>
+            <a:ext cx="5120640" cy="768096"/>
           </a:xfrm>
           <a:prstGeom prst="rect">
             <a:avLst/>
@@ -17232,46 +17394,46 @@
           <a:p>
             <a:pPr algn="l">
               <a:spcAft>
-                <a:spcPts val="100"/>
+                <a:spcPts val="0"/>
               </a:spcAft>
             </a:pPr>
             <a:r>
-              <a:rPr sz="1150" b="0" i="0">
+              <a:rPr sz="1100" b="0" i="0">
                 <a:solidFill>
                   <a:srgbClr val="1A1A1A"/>
                 </a:solidFill>
               </a:rPr>
-              <a:t>4  Portfolio vectors in a batch; &gt; 100,000 portfolio rows read</a:t>
+              <a:t>5  Iceberg for VaR inputs (vectors from the Iceberg plugin)</a:t>
             </a:r>
           </a:p>
           <a:p>
             <a:pPr algn="l">
               <a:spcAft>
-                <a:spcPts val="100"/>
+                <a:spcPts val="0"/>
               </a:spcAft>
             </a:pPr>
             <a:r>
-              <a:rPr sz="1150" b="0" i="0">
+              <a:rPr sz="1100" b="0" i="0">
                 <a:solidFill>
                   <a:srgbClr val="1A1A1A"/>
                 </a:solidFill>
               </a:rPr>
-              <a:t>5  Official results published to an s3:// root</a:t>
+              <a:t>6  Official results published to s3:// (local/EFS today)</a:t>
             </a:r>
           </a:p>
           <a:p>
             <a:pPr algn="l">
               <a:spcAft>
-                <a:spcPts val="100"/>
+                <a:spcPts val="0"/>
               </a:spcAft>
             </a:pPr>
             <a:r>
-              <a:rPr sz="1150" b="0" i="0">
+              <a:rPr sz="1100" b="0" i="0">
                 <a:solidFill>
                   <a:srgbClr val="1A1A1A"/>
                 </a:solidFill>
               </a:rPr>
-              <a:t>6  Several consoles without sticky sessions</a:t>
+              <a:t>7  Several consoles without sticky sessions</a:t>
             </a:r>
           </a:p>
         </p:txBody>

</xml_diff>

<commit_message>
The VaR engine deck's summary and title: scenario PVs or path P&L, at trade or position level, any set of trades or positions
</commit_message>
<xml_diff>
--- a/docs/publications/Drishti-VaR-Engine.pptx
+++ b/docs/publications/Drishti-VaR-Engine.pptx
@@ -3156,7 +3156,7 @@
                   <a:srgbClr val="FFFFFF"/>
                 </a:solidFill>
               </a:rPr>
-              <a:t>Any set of trades, any reporting currency, from the bank to a trade</a:t>
+              <a:t>Any set of trades or positions, in any reporting currency</a:t>
             </a:r>
             <a:endParaRPr lang="en-US" sz="2500" dirty="0"/>
           </a:p>
@@ -19526,8 +19526,8 @@
         </p:nvSpPr>
         <p:spPr>
           <a:xfrm>
-            <a:off x="777240" y="2724912"/>
-            <a:ext cx="2331720" cy="676656"/>
+            <a:off x="777240" y="2697480"/>
+            <a:ext cx="2331720" cy="658368"/>
           </a:xfrm>
           <a:prstGeom prst="rect">
             <a:avLst/>
@@ -19570,8 +19570,8 @@
         </p:nvSpPr>
         <p:spPr>
           <a:xfrm>
-            <a:off x="941832" y="2724912"/>
-            <a:ext cx="2103120" cy="676656"/>
+            <a:off x="941832" y="2697480"/>
+            <a:ext cx="2103120" cy="658368"/>
           </a:xfrm>
           <a:prstGeom prst="rect">
             <a:avLst/>
@@ -19604,8 +19604,8 @@
         </p:nvSpPr>
         <p:spPr>
           <a:xfrm>
-            <a:off x="3154680" y="2724912"/>
-            <a:ext cx="8257032" cy="676656"/>
+            <a:off x="3154680" y="2697480"/>
+            <a:ext cx="8257032" cy="658368"/>
           </a:xfrm>
           <a:prstGeom prst="rect">
             <a:avLst/>
@@ -19648,8 +19648,8 @@
         </p:nvSpPr>
         <p:spPr>
           <a:xfrm>
-            <a:off x="3337560" y="2724912"/>
-            <a:ext cx="7936992" cy="676656"/>
+            <a:off x="3337560" y="2697480"/>
+            <a:ext cx="7936992" cy="658368"/>
           </a:xfrm>
           <a:prstGeom prst="rect">
             <a:avLst/>
@@ -19669,7 +19669,7 @@
                   <a:srgbClr val="1A1A1A"/>
                 </a:solidFill>
               </a:rPr>
-              <a:t>A VaR engine inside the Drishti server: historical simulation over 509 scenario days (or a set window), VaR 99% (95% by setting) and ES 97.5% over 1 day, computed on demand for any set of trades: the bank, a legal entity, desk, book, position or trade, a stored portfolio, a rule, or a basket someone built.</a:t>
+              <a:t>A VaR engine in the Drishti server: historical simulation over 509 scenario days (or a set window), VaR 99% (95% by setting) and ES 97.5%, 1 day, on demand for any set of trades or positions: the bank, a legal entity, desk, book, a portfolio, a rule or a basket.</a:t>
             </a:r>
           </a:p>
         </p:txBody>
@@ -19682,8 +19682,8 @@
         </p:nvSpPr>
         <p:spPr>
           <a:xfrm>
-            <a:off x="777240" y="3438144"/>
-            <a:ext cx="2331720" cy="676656"/>
+            <a:off x="777240" y="3392424"/>
+            <a:ext cx="2331720" cy="548640"/>
           </a:xfrm>
           <a:prstGeom prst="rect">
             <a:avLst/>
@@ -19726,8 +19726,8 @@
         </p:nvSpPr>
         <p:spPr>
           <a:xfrm>
-            <a:off x="941832" y="3438144"/>
-            <a:ext cx="2103120" cy="676656"/>
+            <a:off x="941832" y="3392424"/>
+            <a:ext cx="2103120" cy="548640"/>
           </a:xfrm>
           <a:prstGeom prst="rect">
             <a:avLst/>
@@ -19760,8 +19760,8 @@
         </p:nvSpPr>
         <p:spPr>
           <a:xfrm>
-            <a:off x="3154680" y="3438144"/>
-            <a:ext cx="8257032" cy="676656"/>
+            <a:off x="3154680" y="3392424"/>
+            <a:ext cx="8257032" cy="548640"/>
           </a:xfrm>
           <a:prstGeom prst="rect">
             <a:avLst/>
@@ -19804,8 +19804,8 @@
         </p:nvSpPr>
         <p:spPr>
           <a:xfrm>
-            <a:off x="3337560" y="3438144"/>
-            <a:ext cx="7936992" cy="676656"/>
+            <a:off x="3337560" y="3392424"/>
+            <a:ext cx="7936992" cy="548640"/>
           </a:xfrm>
           <a:prstGeom prst="rect">
             <a:avLst/>
@@ -19825,7 +19825,7 @@
                   <a:srgbClr val="8A1626"/>
                 </a:solidFill>
               </a:rPr>
-              <a:t>One engine, every input: scenario PVs or path P&amp;L, by trade or by position, any currency, files or Kafka. Source systems keep their own formats; any reporting currency, five built ahead.</a:t>
+              <a:t>One engine, every input: scenario PVs or path P&amp;L, by trade or by position, any currency, files or Kafka. Source systems keep their own formats.</a:t>
             </a:r>
           </a:p>
         </p:txBody>
@@ -19838,8 +19838,8 @@
         </p:nvSpPr>
         <p:spPr>
           <a:xfrm>
-            <a:off x="777240" y="4151376"/>
-            <a:ext cx="2331720" cy="676656"/>
+            <a:off x="777240" y="3977639"/>
+            <a:ext cx="2331720" cy="932688"/>
           </a:xfrm>
           <a:prstGeom prst="rect">
             <a:avLst/>
@@ -19882,8 +19882,8 @@
         </p:nvSpPr>
         <p:spPr>
           <a:xfrm>
-            <a:off x="941832" y="4151376"/>
-            <a:ext cx="2103120" cy="676656"/>
+            <a:off x="941832" y="3977639"/>
+            <a:ext cx="2103120" cy="932688"/>
           </a:xfrm>
           <a:prstGeom prst="rect">
             <a:avLst/>
@@ -19916,8 +19916,8 @@
         </p:nvSpPr>
         <p:spPr>
           <a:xfrm>
-            <a:off x="3154680" y="4151376"/>
-            <a:ext cx="8257032" cy="676656"/>
+            <a:off x="3154680" y="3977639"/>
+            <a:ext cx="8257032" cy="932688"/>
           </a:xfrm>
           <a:prstGeom prst="rect">
             <a:avLst/>
@@ -19960,8 +19960,8 @@
         </p:nvSpPr>
         <p:spPr>
           <a:xfrm>
-            <a:off x="3337560" y="4151376"/>
-            <a:ext cx="7936992" cy="676656"/>
+            <a:off x="3337560" y="3977639"/>
+            <a:ext cx="7936992" cy="932688"/>
           </a:xfrm>
           <a:prstGeom prst="rect">
             <a:avLst/>
@@ -19981,7 +19981,7 @@
                   <a:srgbClr val="1A1A1A"/>
                 </a:solidFill>
               </a:rPr>
-              <a:t>It never reprices. Every input becomes one internal form, a P&amp;L vector per row; a scope's vector is the sum of its trades' vectors, and VaR, ES and every contribution are read from that one vector.</a:t>
+              <a:t>It never reprices. The pricing systems send scenario PVs (in each trade's or position's own currency) or path P&amp;L, at trade or position level, through files or Kafka. Drishti turns each into one internal form, a P&amp;L vector per trade or position, converting PVs with scenario FX into any reporting currency. A scope's vector is the sum of its trades' or positions' vectors, and VaR, ES and every contribution are read from that one vector.</a:t>
             </a:r>
           </a:p>
         </p:txBody>
@@ -19994,8 +19994,8 @@
         </p:nvSpPr>
         <p:spPr>
           <a:xfrm>
-            <a:off x="777240" y="4864608"/>
-            <a:ext cx="2331720" cy="676656"/>
+            <a:off x="777240" y="4946904"/>
+            <a:ext cx="2331720" cy="548640"/>
           </a:xfrm>
           <a:prstGeom prst="rect">
             <a:avLst/>
@@ -20038,8 +20038,8 @@
         </p:nvSpPr>
         <p:spPr>
           <a:xfrm>
-            <a:off x="941832" y="4864608"/>
-            <a:ext cx="2103120" cy="676656"/>
+            <a:off x="941832" y="4946904"/>
+            <a:ext cx="2103120" cy="548640"/>
           </a:xfrm>
           <a:prstGeom prst="rect">
             <a:avLst/>
@@ -20072,8 +20072,8 @@
         </p:nvSpPr>
         <p:spPr>
           <a:xfrm>
-            <a:off x="3154680" y="4864608"/>
-            <a:ext cx="8257032" cy="676656"/>
+            <a:off x="3154680" y="4946904"/>
+            <a:ext cx="8257032" cy="548640"/>
           </a:xfrm>
           <a:prstGeom prst="rect">
             <a:avLst/>
@@ -20116,8 +20116,8 @@
         </p:nvSpPr>
         <p:spPr>
           <a:xfrm>
-            <a:off x="3337560" y="4864608"/>
-            <a:ext cx="7936992" cy="676656"/>
+            <a:off x="3337560" y="4946904"/>
+            <a:ext cx="7936992" cy="548640"/>
           </a:xfrm>
           <a:prstGeom prst="rect">
             <a:avLst/>
@@ -20150,8 +20150,8 @@
         </p:nvSpPr>
         <p:spPr>
           <a:xfrm>
-            <a:off x="777240" y="5577840"/>
-            <a:ext cx="2331720" cy="676656"/>
+            <a:off x="777240" y="5532120"/>
+            <a:ext cx="2331720" cy="585216"/>
           </a:xfrm>
           <a:prstGeom prst="rect">
             <a:avLst/>
@@ -20194,8 +20194,8 @@
         </p:nvSpPr>
         <p:spPr>
           <a:xfrm>
-            <a:off x="941832" y="5577840"/>
-            <a:ext cx="2103120" cy="676656"/>
+            <a:off x="941832" y="5532120"/>
+            <a:ext cx="2103120" cy="585216"/>
           </a:xfrm>
           <a:prstGeom prst="rect">
             <a:avLst/>
@@ -20228,8 +20228,8 @@
         </p:nvSpPr>
         <p:spPr>
           <a:xfrm>
-            <a:off x="3154680" y="5577840"/>
-            <a:ext cx="8257032" cy="676656"/>
+            <a:off x="3154680" y="5532120"/>
+            <a:ext cx="8257032" cy="585216"/>
           </a:xfrm>
           <a:prstGeom prst="rect">
             <a:avLst/>
@@ -20272,8 +20272,8 @@
         </p:nvSpPr>
         <p:spPr>
           <a:xfrm>
-            <a:off x="3337560" y="5577840"/>
-            <a:ext cx="7936992" cy="676656"/>
+            <a:off x="3337560" y="5532120"/>
+            <a:ext cx="7936992" cy="585216"/>
           </a:xfrm>
           <a:prstGeom prst="rect">
             <a:avLst/>
@@ -20293,7 +20293,7 @@
                   <a:srgbClr val="1A1A1A"/>
                 </a:solidFill>
               </a:rPr>
-              <a:t>Measured: 1 million trades summed in 58 ms (heap tier); 100,000 trades × 5 dates on the tiered store, a node in 0.48 ms. Sized for 1.3M positions and 100,000 portfolios on slides 12-13; sharding is designed, not built.</a:t>
+              <a:t>Measured: 1 million rows summed in 58 ms (heap tier); 100,000 × 5 dates on the tiered store, a node in 0.48 ms. Sized for 1.3M positions and 100,000 portfolios on slides 12-13; sharding is designed, not built.</a:t>
             </a:r>
           </a:p>
         </p:txBody>

</xml_diff>

<commit_message>
The VaR engine deck's executive summary without the figure tiles (the figures stay in the speaker notes)
</commit_message>
<xml_diff>
--- a/docs/publications/Drishti-VaR-Engine.pptx
+++ b/docs/publications/Drishti-VaR-Engine.pptx
@@ -1408,6 +1408,12 @@
           <a:lstStyle/>
           <a:p>
             <a:r>
+              <a:t>Headline figures of the demo bank, for reference (the figure tiles were removed from the slide): VaR 99% 1-day 112,041,646 USD and ES 97.5% 160,143,809 USD on 2026-09-30; 509 scenario days (2024-09-17 to 2026-09-29); 9,572 live trades in 7,984 derived positions, 88 hierarchy nodes, 28 portfolios; a node's VaR in under 1 ms from its float64 aggregate; the date loads in 572 ms.</a:t>
+            </a:r>
+          </a:p>
+          <a:p/>
+          <a:p>
+            <a:r>
               <a:t>Sources: VAR_GUIDE.md section 2.2 (the bank on 2026-09-30: VaR 112,041,646, ES 160,143,809, 9,572 trades in 7,984 positions); section 15.3 (HS-509, 2024-09-17 to 2026-09-29); section 15.4 (88 nodes), 15.5 (28 portfolios); section 26.7 (loadMs 572 for the test date); section 26.2 and 27.3 (a node under 1 ms, 0.48 ms measured); section 27.2 (VarScaleBenchmark: the whole bank of 1 million trades summed in 58 ms on 24 threads); section 27.3 (VarTierBenchmark: 100,000 trades × 5 dates).</a:t>
             </a:r>
           </a:p>
@@ -18746,8 +18752,86 @@
         </p:nvSpPr>
         <p:spPr>
           <a:xfrm>
-            <a:off x="777240" y="1444752"/>
-            <a:ext cx="1965960" cy="1115568"/>
+            <a:off x="777240" y="1481328"/>
+            <a:ext cx="2331720" cy="786384"/>
+          </a:xfrm>
+          <a:prstGeom prst="rect">
+            <a:avLst/>
+          </a:prstGeom>
+          <a:solidFill>
+            <a:srgbClr val="F6E6E9"/>
+          </a:solidFill>
+          <a:ln>
+            <a:noFill/>
+          </a:ln>
+          <a:effectLst/>
+        </p:spPr>
+        <p:style>
+          <a:lnRef idx="1">
+            <a:schemeClr val="accent1"/>
+          </a:lnRef>
+          <a:fillRef idx="3">
+            <a:schemeClr val="accent1"/>
+          </a:fillRef>
+          <a:effectRef idx="2">
+            <a:schemeClr val="accent1"/>
+          </a:effectRef>
+          <a:fontRef idx="minor">
+            <a:schemeClr val="lt1"/>
+          </a:fontRef>
+        </p:style>
+        <p:txBody>
+          <a:bodyPr rtlCol="0" anchor="ctr" lIns="0" rIns="0" tIns="0" bIns="0"/>
+          <a:lstStyle/>
+          <a:p>
+            <a:pPr algn="ctr"/>
+          </a:p>
+        </p:txBody>
+      </p:sp>
+      <p:sp>
+        <p:nvSpPr>
+          <p:cNvPr id="27" name="TextBox 26"/>
+          <p:cNvSpPr txBox="1"/>
+          <p:nvPr/>
+        </p:nvSpPr>
+        <p:spPr>
+          <a:xfrm>
+            <a:off x="941832" y="1481328"/>
+            <a:ext cx="2103120" cy="786384"/>
+          </a:xfrm>
+          <a:prstGeom prst="rect">
+            <a:avLst/>
+          </a:prstGeom>
+          <a:noFill/>
+        </p:spPr>
+        <p:txBody>
+          <a:bodyPr wrap="square" lIns="0" rIns="0" tIns="0" bIns="0" anchor="ctr">
+            <a:spAutoFit/>
+          </a:bodyPr>
+          <a:lstStyle/>
+          <a:p>
+            <a:pPr algn="l"/>
+            <a:r>
+              <a:rPr sz="1400" b="1" i="0">
+                <a:solidFill>
+                  <a:srgbClr val="8A1626"/>
+                </a:solidFill>
+              </a:rPr>
+              <a:t>What is it?</a:t>
+            </a:r>
+          </a:p>
+        </p:txBody>
+      </p:sp>
+      <p:sp>
+        <p:nvSpPr>
+          <p:cNvPr id="28" name="Rectangle 27"/>
+          <p:cNvSpPr/>
+          <p:nvPr/>
+        </p:nvSpPr>
+        <p:spPr>
+          <a:xfrm>
+            <a:off x="3154680" y="1481328"/>
+            <a:ext cx="8257032" cy="786384"/>
           </a:xfrm>
           <a:prstGeom prst="rect">
             <a:avLst/>
@@ -18784,20 +18868,54 @@
       </p:sp>
       <p:sp>
         <p:nvSpPr>
-          <p:cNvPr id="27" name="Rectangle 26"/>
+          <p:cNvPr id="29" name="TextBox 28"/>
+          <p:cNvSpPr txBox="1"/>
+          <p:nvPr/>
+        </p:nvSpPr>
+        <p:spPr>
+          <a:xfrm>
+            <a:off x="3337560" y="1481328"/>
+            <a:ext cx="7936992" cy="786384"/>
+          </a:xfrm>
+          <a:prstGeom prst="rect">
+            <a:avLst/>
+          </a:prstGeom>
+          <a:noFill/>
+        </p:spPr>
+        <p:txBody>
+          <a:bodyPr wrap="square" lIns="0" rIns="0" tIns="0" bIns="0" anchor="ctr">
+            <a:spAutoFit/>
+          </a:bodyPr>
+          <a:lstStyle/>
+          <a:p>
+            <a:pPr algn="l"/>
+            <a:r>
+              <a:rPr sz="1300" b="0" i="0">
+                <a:solidFill>
+                  <a:srgbClr val="1A1A1A"/>
+                </a:solidFill>
+              </a:rPr>
+              <a:t>A VaR engine in the Drishti server: historical simulation over 509 scenario days (or a set window), VaR 99% (95% by setting) and ES 97.5%, 1 day, on demand for any set of trades or positions: the bank, a legal entity, desk, book, a portfolio, a rule or a basket.</a:t>
+            </a:r>
+          </a:p>
+        </p:txBody>
+      </p:sp>
+      <p:sp>
+        <p:nvSpPr>
+          <p:cNvPr id="30" name="Rectangle 29"/>
           <p:cNvSpPr/>
           <p:nvPr/>
         </p:nvSpPr>
         <p:spPr>
           <a:xfrm>
-            <a:off x="777240" y="1444752"/>
-            <a:ext cx="45720" cy="1115568"/>
+            <a:off x="777240" y="2359152"/>
+            <a:ext cx="2331720" cy="676656"/>
           </a:xfrm>
           <a:prstGeom prst="rect">
             <a:avLst/>
           </a:prstGeom>
           <a:solidFill>
-            <a:srgbClr val="A51C30"/>
+            <a:srgbClr val="8A1626"/>
           </a:solidFill>
           <a:ln>
             <a:noFill/>
@@ -18828,14 +18946,14 @@
       </p:sp>
       <p:sp>
         <p:nvSpPr>
-          <p:cNvPr id="28" name="TextBox 27"/>
+          <p:cNvPr id="31" name="TextBox 30"/>
           <p:cNvSpPr txBox="1"/>
           <p:nvPr/>
         </p:nvSpPr>
         <p:spPr>
           <a:xfrm>
-            <a:off x="960120" y="1536192"/>
-            <a:ext cx="1691639" cy="457200"/>
+            <a:off x="941832" y="2359152"/>
+            <a:ext cx="2103120" cy="676656"/>
           </a:xfrm>
           <a:prstGeom prst="rect">
             <a:avLst/>
@@ -18850,26 +18968,70 @@
           <a:p>
             <a:pPr algn="l"/>
             <a:r>
-              <a:rPr sz="2400" b="1" i="0">
-                <a:solidFill>
-                  <a:srgbClr val="8A1626"/>
-                </a:solidFill>
-              </a:rPr>
-              <a:t>112.04m</a:t>
-            </a:r>
-          </a:p>
-        </p:txBody>
-      </p:sp>
-      <p:sp>
-        <p:nvSpPr>
-          <p:cNvPr id="29" name="TextBox 28"/>
+              <a:rPr sz="1400" b="1" i="0">
+                <a:solidFill>
+                  <a:srgbClr val="FFFFFF"/>
+                </a:solidFill>
+              </a:rPr>
+              <a:t>Every input</a:t>
+            </a:r>
+          </a:p>
+        </p:txBody>
+      </p:sp>
+      <p:sp>
+        <p:nvSpPr>
+          <p:cNvPr id="32" name="Rectangle 31"/>
+          <p:cNvSpPr/>
+          <p:nvPr/>
+        </p:nvSpPr>
+        <p:spPr>
+          <a:xfrm>
+            <a:off x="3154680" y="2359152"/>
+            <a:ext cx="8257032" cy="676656"/>
+          </a:xfrm>
+          <a:prstGeom prst="rect">
+            <a:avLst/>
+          </a:prstGeom>
+          <a:solidFill>
+            <a:srgbClr val="F6E6E9"/>
+          </a:solidFill>
+          <a:ln>
+            <a:noFill/>
+          </a:ln>
+          <a:effectLst/>
+        </p:spPr>
+        <p:style>
+          <a:lnRef idx="1">
+            <a:schemeClr val="accent1"/>
+          </a:lnRef>
+          <a:fillRef idx="3">
+            <a:schemeClr val="accent1"/>
+          </a:fillRef>
+          <a:effectRef idx="2">
+            <a:schemeClr val="accent1"/>
+          </a:effectRef>
+          <a:fontRef idx="minor">
+            <a:schemeClr val="lt1"/>
+          </a:fontRef>
+        </p:style>
+        <p:txBody>
+          <a:bodyPr rtlCol="0" anchor="ctr" lIns="0" rIns="0" tIns="0" bIns="0"/>
+          <a:lstStyle/>
+          <a:p>
+            <a:pPr algn="ctr"/>
+          </a:p>
+        </p:txBody>
+      </p:sp>
+      <p:sp>
+        <p:nvSpPr>
+          <p:cNvPr id="33" name="TextBox 32"/>
           <p:cNvSpPr txBox="1"/>
           <p:nvPr/>
         </p:nvSpPr>
         <p:spPr>
           <a:xfrm>
-            <a:off x="960120" y="2011680"/>
-            <a:ext cx="1691639" cy="493775"/>
+            <a:off x="3337560" y="2359152"/>
+            <a:ext cx="7936992" cy="676656"/>
           </a:xfrm>
           <a:prstGeom prst="rect">
             <a:avLst/>
@@ -18877,33 +19039,111 @@
           <a:noFill/>
         </p:spPr>
         <p:txBody>
-          <a:bodyPr wrap="square" lIns="0" rIns="0" tIns="0" bIns="0" anchor="t">
+          <a:bodyPr wrap="square" lIns="0" rIns="0" tIns="0" bIns="0" anchor="ctr">
             <a:spAutoFit/>
           </a:bodyPr>
           <a:lstStyle/>
           <a:p>
             <a:pPr algn="l"/>
             <a:r>
-              <a:rPr sz="1150" b="0" i="0">
-                <a:solidFill>
-                  <a:srgbClr val="4A5058"/>
-                </a:solidFill>
-              </a:rPr>
-              <a:t>VaR 99%, 1 day, USD: the demo bank on 2026-09-30 (the 6th worst of 509)</a:t>
-            </a:r>
-          </a:p>
-        </p:txBody>
-      </p:sp>
-      <p:sp>
-        <p:nvSpPr>
-          <p:cNvPr id="30" name="Rectangle 29"/>
+              <a:rPr sz="1350" b="1" i="0">
+                <a:solidFill>
+                  <a:srgbClr val="8A1626"/>
+                </a:solidFill>
+              </a:rPr>
+              <a:t>One engine, every input: scenario PVs or path P&amp;L, by trade or by position, any currency, files or Kafka. Source systems keep their own formats.</a:t>
+            </a:r>
+          </a:p>
+        </p:txBody>
+      </p:sp>
+      <p:sp>
+        <p:nvSpPr>
+          <p:cNvPr id="34" name="Rectangle 33"/>
           <p:cNvSpPr/>
           <p:nvPr/>
         </p:nvSpPr>
         <p:spPr>
           <a:xfrm>
-            <a:off x="2944368" y="1444752"/>
-            <a:ext cx="1965960" cy="1115568"/>
+            <a:off x="777240" y="3127248"/>
+            <a:ext cx="2331720" cy="1188720"/>
+          </a:xfrm>
+          <a:prstGeom prst="rect">
+            <a:avLst/>
+          </a:prstGeom>
+          <a:solidFill>
+            <a:srgbClr val="F6E6E9"/>
+          </a:solidFill>
+          <a:ln>
+            <a:noFill/>
+          </a:ln>
+          <a:effectLst/>
+        </p:spPr>
+        <p:style>
+          <a:lnRef idx="1">
+            <a:schemeClr val="accent1"/>
+          </a:lnRef>
+          <a:fillRef idx="3">
+            <a:schemeClr val="accent1"/>
+          </a:fillRef>
+          <a:effectRef idx="2">
+            <a:schemeClr val="accent1"/>
+          </a:effectRef>
+          <a:fontRef idx="minor">
+            <a:schemeClr val="lt1"/>
+          </a:fontRef>
+        </p:style>
+        <p:txBody>
+          <a:bodyPr rtlCol="0" anchor="ctr" lIns="0" rIns="0" tIns="0" bIns="0"/>
+          <a:lstStyle/>
+          <a:p>
+            <a:pPr algn="ctr"/>
+          </a:p>
+        </p:txBody>
+      </p:sp>
+      <p:sp>
+        <p:nvSpPr>
+          <p:cNvPr id="35" name="TextBox 34"/>
+          <p:cNvSpPr txBox="1"/>
+          <p:nvPr/>
+        </p:nvSpPr>
+        <p:spPr>
+          <a:xfrm>
+            <a:off x="941832" y="3127248"/>
+            <a:ext cx="2103120" cy="1188720"/>
+          </a:xfrm>
+          <a:prstGeom prst="rect">
+            <a:avLst/>
+          </a:prstGeom>
+          <a:noFill/>
+        </p:spPr>
+        <p:txBody>
+          <a:bodyPr wrap="square" lIns="0" rIns="0" tIns="0" bIns="0" anchor="ctr">
+            <a:spAutoFit/>
+          </a:bodyPr>
+          <a:lstStyle/>
+          <a:p>
+            <a:pPr algn="l"/>
+            <a:r>
+              <a:rPr sz="1400" b="1" i="0">
+                <a:solidFill>
+                  <a:srgbClr val="8A1626"/>
+                </a:solidFill>
+              </a:rPr>
+              <a:t>How does it work?</a:t>
+            </a:r>
+          </a:p>
+        </p:txBody>
+      </p:sp>
+      <p:sp>
+        <p:nvSpPr>
+          <p:cNvPr id="36" name="Rectangle 35"/>
+          <p:cNvSpPr/>
+          <p:nvPr/>
+        </p:nvSpPr>
+        <p:spPr>
+          <a:xfrm>
+            <a:off x="3154680" y="3127248"/>
+            <a:ext cx="8257032" cy="1188720"/>
           </a:xfrm>
           <a:prstGeom prst="rect">
             <a:avLst/>
@@ -18940,20 +19180,54 @@
       </p:sp>
       <p:sp>
         <p:nvSpPr>
-          <p:cNvPr id="31" name="Rectangle 30"/>
+          <p:cNvPr id="37" name="TextBox 36"/>
+          <p:cNvSpPr txBox="1"/>
+          <p:nvPr/>
+        </p:nvSpPr>
+        <p:spPr>
+          <a:xfrm>
+            <a:off x="3337560" y="3127248"/>
+            <a:ext cx="7936992" cy="1188720"/>
+          </a:xfrm>
+          <a:prstGeom prst="rect">
+            <a:avLst/>
+          </a:prstGeom>
+          <a:noFill/>
+        </p:spPr>
+        <p:txBody>
+          <a:bodyPr wrap="square" lIns="0" rIns="0" tIns="0" bIns="0" anchor="ctr">
+            <a:spAutoFit/>
+          </a:bodyPr>
+          <a:lstStyle/>
+          <a:p>
+            <a:pPr algn="l"/>
+            <a:r>
+              <a:rPr sz="1300" b="0" i="0">
+                <a:solidFill>
+                  <a:srgbClr val="1A1A1A"/>
+                </a:solidFill>
+              </a:rPr>
+              <a:t>It never reprices. The pricing systems send scenario PVs (in each trade's or position's own currency) or path P&amp;L, at trade or position level, through files or Kafka. Drishti turns each into one internal form, a P&amp;L vector per trade or position, converting PVs with scenario FX into any reporting currency. A scope's vector is the sum of its trades' or positions' vectors, and VaR, ES and every contribution are read from that one vector.</a:t>
+            </a:r>
+          </a:p>
+        </p:txBody>
+      </p:sp>
+      <p:sp>
+        <p:nvSpPr>
+          <p:cNvPr id="38" name="Rectangle 37"/>
           <p:cNvSpPr/>
           <p:nvPr/>
         </p:nvSpPr>
         <p:spPr>
           <a:xfrm>
-            <a:off x="2944368" y="1444752"/>
-            <a:ext cx="45720" cy="1115568"/>
+            <a:off x="777240" y="4407408"/>
+            <a:ext cx="2331720" cy="786384"/>
           </a:xfrm>
           <a:prstGeom prst="rect">
             <a:avLst/>
           </a:prstGeom>
           <a:solidFill>
-            <a:srgbClr val="A51C30"/>
+            <a:srgbClr val="F6E6E9"/>
           </a:solidFill>
           <a:ln>
             <a:noFill/>
@@ -18984,14 +19258,14 @@
       </p:sp>
       <p:sp>
         <p:nvSpPr>
-          <p:cNvPr id="32" name="TextBox 31"/>
+          <p:cNvPr id="39" name="TextBox 38"/>
           <p:cNvSpPr txBox="1"/>
           <p:nvPr/>
         </p:nvSpPr>
         <p:spPr>
           <a:xfrm>
-            <a:off x="3127248" y="1536192"/>
-            <a:ext cx="1691639" cy="457200"/>
+            <a:off x="941832" y="4407408"/>
+            <a:ext cx="2103120" cy="786384"/>
           </a:xfrm>
           <a:prstGeom prst="rect">
             <a:avLst/>
@@ -19006,60 +19280,26 @@
           <a:p>
             <a:pPr algn="l"/>
             <a:r>
-              <a:rPr sz="2400" b="1" i="0">
+              <a:rPr sz="1400" b="1" i="0">
                 <a:solidFill>
                   <a:srgbClr val="8A1626"/>
                 </a:solidFill>
               </a:rPr>
-              <a:t>160.14m</a:t>
-            </a:r>
-          </a:p>
-        </p:txBody>
-      </p:sp>
-      <p:sp>
-        <p:nvSpPr>
-          <p:cNvPr id="33" name="TextBox 32"/>
-          <p:cNvSpPr txBox="1"/>
-          <p:nvPr/>
-        </p:nvSpPr>
-        <p:spPr>
-          <a:xfrm>
-            <a:off x="3127248" y="2011680"/>
-            <a:ext cx="1691639" cy="493775"/>
-          </a:xfrm>
-          <a:prstGeom prst="rect">
-            <a:avLst/>
-          </a:prstGeom>
-          <a:noFill/>
-        </p:spPr>
-        <p:txBody>
-          <a:bodyPr wrap="square" lIns="0" rIns="0" tIns="0" bIns="0" anchor="t">
-            <a:spAutoFit/>
-          </a:bodyPr>
-          <a:lstStyle/>
-          <a:p>
-            <a:pPr algn="l"/>
-            <a:r>
-              <a:rPr sz="1150" b="0" i="0">
-                <a:solidFill>
-                  <a:srgbClr val="4A5058"/>
-                </a:solidFill>
-              </a:rPr>
-              <a:t>ES 97.5%, USD: the mean of the 13 worst scenario days</a:t>
-            </a:r>
-          </a:p>
-        </p:txBody>
-      </p:sp>
-      <p:sp>
-        <p:nvSpPr>
-          <p:cNvPr id="34" name="Rectangle 33"/>
+              <a:t>Can I trust it?</a:t>
+            </a:r>
+          </a:p>
+        </p:txBody>
+      </p:sp>
+      <p:sp>
+        <p:nvSpPr>
+          <p:cNvPr id="40" name="Rectangle 39"/>
           <p:cNvSpPr/>
           <p:nvPr/>
         </p:nvSpPr>
         <p:spPr>
           <a:xfrm>
-            <a:off x="5111496" y="1444752"/>
-            <a:ext cx="1965960" cy="1115568"/>
+            <a:off x="3154680" y="4407408"/>
+            <a:ext cx="8257032" cy="786384"/>
           </a:xfrm>
           <a:prstGeom prst="rect">
             <a:avLst/>
@@ -19096,20 +19336,54 @@
       </p:sp>
       <p:sp>
         <p:nvSpPr>
-          <p:cNvPr id="35" name="Rectangle 34"/>
+          <p:cNvPr id="41" name="TextBox 40"/>
+          <p:cNvSpPr txBox="1"/>
+          <p:nvPr/>
+        </p:nvSpPr>
+        <p:spPr>
+          <a:xfrm>
+            <a:off x="3337560" y="4407408"/>
+            <a:ext cx="7936992" cy="786384"/>
+          </a:xfrm>
+          <a:prstGeom prst="rect">
+            <a:avLst/>
+          </a:prstGeom>
+          <a:noFill/>
+        </p:spPr>
+        <p:txBody>
+          <a:bodyPr wrap="square" lIns="0" rIns="0" tIns="0" bIns="0" anchor="ctr">
+            <a:spAutoFit/>
+          </a:bodyPr>
+          <a:lstStyle/>
+          <a:p>
+            <a:pPr algn="l"/>
+            <a:r>
+              <a:rPr sz="1300" b="0" i="0">
+                <a:solidFill>
+                  <a:srgbClr val="1A1A1A"/>
+                </a:solidFill>
+              </a:rPr>
+              <a:t>Every answer names its inputs' versions, batch ids, scenario set, method and memory tier; components add up to the VaR exactly; every node gets an official end-of-day record, append-only, kept 7 years.</a:t>
+            </a:r>
+          </a:p>
+        </p:txBody>
+      </p:sp>
+      <p:sp>
+        <p:nvSpPr>
+          <p:cNvPr id="42" name="Rectangle 41"/>
           <p:cNvSpPr/>
           <p:nvPr/>
         </p:nvSpPr>
         <p:spPr>
           <a:xfrm>
-            <a:off x="5111496" y="1444752"/>
-            <a:ext cx="45720" cy="1115568"/>
+            <a:off x="777240" y="5285232"/>
+            <a:ext cx="2331720" cy="786384"/>
           </a:xfrm>
           <a:prstGeom prst="rect">
             <a:avLst/>
           </a:prstGeom>
           <a:solidFill>
-            <a:srgbClr val="A51C30"/>
+            <a:srgbClr val="F6E6E9"/>
           </a:solidFill>
           <a:ln>
             <a:noFill/>
@@ -19140,14 +19414,14 @@
       </p:sp>
       <p:sp>
         <p:nvSpPr>
-          <p:cNvPr id="36" name="TextBox 35"/>
+          <p:cNvPr id="43" name="TextBox 42"/>
           <p:cNvSpPr txBox="1"/>
           <p:nvPr/>
         </p:nvSpPr>
         <p:spPr>
           <a:xfrm>
-            <a:off x="5294376" y="1536192"/>
-            <a:ext cx="1691639" cy="457200"/>
+            <a:off x="941832" y="5285232"/>
+            <a:ext cx="2103120" cy="786384"/>
           </a:xfrm>
           <a:prstGeom prst="rect">
             <a:avLst/>
@@ -19162,60 +19436,26 @@
           <a:p>
             <a:pPr algn="l"/>
             <a:r>
-              <a:rPr sz="2400" b="1" i="0">
+              <a:rPr sz="1400" b="1" i="0">
                 <a:solidFill>
                   <a:srgbClr val="8A1626"/>
                 </a:solidFill>
               </a:rPr>
-              <a:t>509</a:t>
-            </a:r>
-          </a:p>
-        </p:txBody>
-      </p:sp>
-      <p:sp>
-        <p:nvSpPr>
-          <p:cNvPr id="37" name="TextBox 36"/>
-          <p:cNvSpPr txBox="1"/>
-          <p:nvPr/>
-        </p:nvSpPr>
-        <p:spPr>
-          <a:xfrm>
-            <a:off x="5294376" y="2011680"/>
-            <a:ext cx="1691639" cy="493775"/>
-          </a:xfrm>
-          <a:prstGeom prst="rect">
-            <a:avLst/>
-          </a:prstGeom>
-          <a:noFill/>
-        </p:spPr>
-        <p:txBody>
-          <a:bodyPr wrap="square" lIns="0" rIns="0" tIns="0" bIns="0" anchor="t">
-            <a:spAutoFit/>
-          </a:bodyPr>
-          <a:lstStyle/>
-          <a:p>
-            <a:pPr algn="l"/>
-            <a:r>
-              <a:rPr sz="1150" b="0" i="0">
-                <a:solidFill>
-                  <a:srgbClr val="4A5058"/>
-                </a:solidFill>
-              </a:rPr>
-              <a:t>historical scenario days (2024-09-17 to 2026-09-29), equal weights</a:t>
-            </a:r>
-          </a:p>
-        </p:txBody>
-      </p:sp>
-      <p:sp>
-        <p:nvSpPr>
-          <p:cNvPr id="38" name="Rectangle 37"/>
+              <a:t>Does it scale?</a:t>
+            </a:r>
+          </a:p>
+        </p:txBody>
+      </p:sp>
+      <p:sp>
+        <p:nvSpPr>
+          <p:cNvPr id="44" name="Rectangle 43"/>
           <p:cNvSpPr/>
           <p:nvPr/>
         </p:nvSpPr>
         <p:spPr>
           <a:xfrm>
-            <a:off x="7278624" y="1444752"/>
-            <a:ext cx="1965960" cy="1115568"/>
+            <a:off x="3154680" y="5285232"/>
+            <a:ext cx="8257032" cy="786384"/>
           </a:xfrm>
           <a:prstGeom prst="rect">
             <a:avLst/>
@@ -19252,58 +19492,14 @@
       </p:sp>
       <p:sp>
         <p:nvSpPr>
-          <p:cNvPr id="39" name="Rectangle 38"/>
-          <p:cNvSpPr/>
-          <p:nvPr/>
-        </p:nvSpPr>
-        <p:spPr>
-          <a:xfrm>
-            <a:off x="7278624" y="1444752"/>
-            <a:ext cx="45720" cy="1115568"/>
-          </a:xfrm>
-          <a:prstGeom prst="rect">
-            <a:avLst/>
-          </a:prstGeom>
-          <a:solidFill>
-            <a:srgbClr val="A51C30"/>
-          </a:solidFill>
-          <a:ln>
-            <a:noFill/>
-          </a:ln>
-          <a:effectLst/>
-        </p:spPr>
-        <p:style>
-          <a:lnRef idx="1">
-            <a:schemeClr val="accent1"/>
-          </a:lnRef>
-          <a:fillRef idx="3">
-            <a:schemeClr val="accent1"/>
-          </a:fillRef>
-          <a:effectRef idx="2">
-            <a:schemeClr val="accent1"/>
-          </a:effectRef>
-          <a:fontRef idx="minor">
-            <a:schemeClr val="lt1"/>
-          </a:fontRef>
-        </p:style>
-        <p:txBody>
-          <a:bodyPr rtlCol="0" anchor="ctr" lIns="0" rIns="0" tIns="0" bIns="0"/>
-          <a:lstStyle/>
-          <a:p>
-            <a:pPr algn="ctr"/>
-          </a:p>
-        </p:txBody>
-      </p:sp>
-      <p:sp>
-        <p:nvSpPr>
-          <p:cNvPr id="40" name="TextBox 39"/>
+          <p:cNvPr id="45" name="TextBox 44"/>
           <p:cNvSpPr txBox="1"/>
           <p:nvPr/>
         </p:nvSpPr>
         <p:spPr>
           <a:xfrm>
-            <a:off x="7461504" y="1536192"/>
-            <a:ext cx="1691639" cy="457200"/>
+            <a:off x="3337560" y="5285232"/>
+            <a:ext cx="7936992" cy="786384"/>
           </a:xfrm>
           <a:prstGeom prst="rect">
             <a:avLst/>
@@ -19318,977 +19514,7 @@
           <a:p>
             <a:pPr algn="l"/>
             <a:r>
-              <a:rPr sz="2400" b="1" i="0">
-                <a:solidFill>
-                  <a:srgbClr val="8A1626"/>
-                </a:solidFill>
-              </a:rPr>
-              <a:t>9,572</a:t>
-            </a:r>
-          </a:p>
-        </p:txBody>
-      </p:sp>
-      <p:sp>
-        <p:nvSpPr>
-          <p:cNvPr id="41" name="TextBox 40"/>
-          <p:cNvSpPr txBox="1"/>
-          <p:nvPr/>
-        </p:nvSpPr>
-        <p:spPr>
-          <a:xfrm>
-            <a:off x="7461504" y="2011680"/>
-            <a:ext cx="1691639" cy="493775"/>
-          </a:xfrm>
-          <a:prstGeom prst="rect">
-            <a:avLst/>
-          </a:prstGeom>
-          <a:noFill/>
-        </p:spPr>
-        <p:txBody>
-          <a:bodyPr wrap="square" lIns="0" rIns="0" tIns="0" bIns="0" anchor="t">
-            <a:spAutoFit/>
-          </a:bodyPr>
-          <a:lstStyle/>
-          <a:p>
-            <a:pPr algn="l"/>
-            <a:r>
-              <a:rPr sz="1150" b="0" i="0">
-                <a:solidFill>
-                  <a:srgbClr val="4A5058"/>
-                </a:solidFill>
-              </a:rPr>
-              <a:t>live trades in 7,984 derived positions, 88 nodes, 28 portfolios</a:t>
-            </a:r>
-          </a:p>
-        </p:txBody>
-      </p:sp>
-      <p:sp>
-        <p:nvSpPr>
-          <p:cNvPr id="42" name="Rectangle 41"/>
-          <p:cNvSpPr/>
-          <p:nvPr/>
-        </p:nvSpPr>
-        <p:spPr>
-          <a:xfrm>
-            <a:off x="9445752" y="1444752"/>
-            <a:ext cx="1965960" cy="1115568"/>
-          </a:xfrm>
-          <a:prstGeom prst="rect">
-            <a:avLst/>
-          </a:prstGeom>
-          <a:solidFill>
-            <a:srgbClr val="F7F5F2"/>
-          </a:solidFill>
-          <a:ln>
-            <a:noFill/>
-          </a:ln>
-          <a:effectLst/>
-        </p:spPr>
-        <p:style>
-          <a:lnRef idx="1">
-            <a:schemeClr val="accent1"/>
-          </a:lnRef>
-          <a:fillRef idx="3">
-            <a:schemeClr val="accent1"/>
-          </a:fillRef>
-          <a:effectRef idx="2">
-            <a:schemeClr val="accent1"/>
-          </a:effectRef>
-          <a:fontRef idx="minor">
-            <a:schemeClr val="lt1"/>
-          </a:fontRef>
-        </p:style>
-        <p:txBody>
-          <a:bodyPr rtlCol="0" anchor="ctr" lIns="0" rIns="0" tIns="0" bIns="0"/>
-          <a:lstStyle/>
-          <a:p>
-            <a:pPr algn="ctr"/>
-          </a:p>
-        </p:txBody>
-      </p:sp>
-      <p:sp>
-        <p:nvSpPr>
-          <p:cNvPr id="43" name="Rectangle 42"/>
-          <p:cNvSpPr/>
-          <p:nvPr/>
-        </p:nvSpPr>
-        <p:spPr>
-          <a:xfrm>
-            <a:off x="9445752" y="1444752"/>
-            <a:ext cx="45720" cy="1115568"/>
-          </a:xfrm>
-          <a:prstGeom prst="rect">
-            <a:avLst/>
-          </a:prstGeom>
-          <a:solidFill>
-            <a:srgbClr val="A51C30"/>
-          </a:solidFill>
-          <a:ln>
-            <a:noFill/>
-          </a:ln>
-          <a:effectLst/>
-        </p:spPr>
-        <p:style>
-          <a:lnRef idx="1">
-            <a:schemeClr val="accent1"/>
-          </a:lnRef>
-          <a:fillRef idx="3">
-            <a:schemeClr val="accent1"/>
-          </a:fillRef>
-          <a:effectRef idx="2">
-            <a:schemeClr val="accent1"/>
-          </a:effectRef>
-          <a:fontRef idx="minor">
-            <a:schemeClr val="lt1"/>
-          </a:fontRef>
-        </p:style>
-        <p:txBody>
-          <a:bodyPr rtlCol="0" anchor="ctr" lIns="0" rIns="0" tIns="0" bIns="0"/>
-          <a:lstStyle/>
-          <a:p>
-            <a:pPr algn="ctr"/>
-          </a:p>
-        </p:txBody>
-      </p:sp>
-      <p:sp>
-        <p:nvSpPr>
-          <p:cNvPr id="44" name="TextBox 43"/>
-          <p:cNvSpPr txBox="1"/>
-          <p:nvPr/>
-        </p:nvSpPr>
-        <p:spPr>
-          <a:xfrm>
-            <a:off x="9628632" y="1536192"/>
-            <a:ext cx="1691639" cy="457200"/>
-          </a:xfrm>
-          <a:prstGeom prst="rect">
-            <a:avLst/>
-          </a:prstGeom>
-          <a:noFill/>
-        </p:spPr>
-        <p:txBody>
-          <a:bodyPr wrap="square" lIns="0" rIns="0" tIns="0" bIns="0" anchor="ctr">
-            <a:spAutoFit/>
-          </a:bodyPr>
-          <a:lstStyle/>
-          <a:p>
-            <a:pPr algn="l"/>
-            <a:r>
-              <a:rPr sz="2400" b="1" i="0">
-                <a:solidFill>
-                  <a:srgbClr val="8A1626"/>
-                </a:solidFill>
-              </a:rPr>
-              <a:t>&lt; 1 ms</a:t>
-            </a:r>
-          </a:p>
-        </p:txBody>
-      </p:sp>
-      <p:sp>
-        <p:nvSpPr>
-          <p:cNvPr id="45" name="TextBox 44"/>
-          <p:cNvSpPr txBox="1"/>
-          <p:nvPr/>
-        </p:nvSpPr>
-        <p:spPr>
-          <a:xfrm>
-            <a:off x="9628632" y="2011680"/>
-            <a:ext cx="1691639" cy="493775"/>
-          </a:xfrm>
-          <a:prstGeom prst="rect">
-            <a:avLst/>
-          </a:prstGeom>
-          <a:noFill/>
-        </p:spPr>
-        <p:txBody>
-          <a:bodyPr wrap="square" lIns="0" rIns="0" tIns="0" bIns="0" anchor="t">
-            <a:spAutoFit/>
-          </a:bodyPr>
-          <a:lstStyle/>
-          <a:p>
-            <a:pPr algn="l"/>
-            <a:r>
-              <a:rPr sz="1150" b="0" i="0">
-                <a:solidFill>
-                  <a:srgbClr val="4A5058"/>
-                </a:solidFill>
-              </a:rPr>
-              <a:t>a node's VaR from its float64 aggregate; 572 ms to load the date</a:t>
-            </a:r>
-          </a:p>
-        </p:txBody>
-      </p:sp>
-      <p:sp>
-        <p:nvSpPr>
-          <p:cNvPr id="46" name="Rectangle 45"/>
-          <p:cNvSpPr/>
-          <p:nvPr/>
-        </p:nvSpPr>
-        <p:spPr>
-          <a:xfrm>
-            <a:off x="777240" y="2697480"/>
-            <a:ext cx="2331720" cy="658368"/>
-          </a:xfrm>
-          <a:prstGeom prst="rect">
-            <a:avLst/>
-          </a:prstGeom>
-          <a:solidFill>
-            <a:srgbClr val="F6E6E9"/>
-          </a:solidFill>
-          <a:ln>
-            <a:noFill/>
-          </a:ln>
-          <a:effectLst/>
-        </p:spPr>
-        <p:style>
-          <a:lnRef idx="1">
-            <a:schemeClr val="accent1"/>
-          </a:lnRef>
-          <a:fillRef idx="3">
-            <a:schemeClr val="accent1"/>
-          </a:fillRef>
-          <a:effectRef idx="2">
-            <a:schemeClr val="accent1"/>
-          </a:effectRef>
-          <a:fontRef idx="minor">
-            <a:schemeClr val="lt1"/>
-          </a:fontRef>
-        </p:style>
-        <p:txBody>
-          <a:bodyPr rtlCol="0" anchor="ctr" lIns="0" rIns="0" tIns="0" bIns="0"/>
-          <a:lstStyle/>
-          <a:p>
-            <a:pPr algn="ctr"/>
-          </a:p>
-        </p:txBody>
-      </p:sp>
-      <p:sp>
-        <p:nvSpPr>
-          <p:cNvPr id="47" name="TextBox 46"/>
-          <p:cNvSpPr txBox="1"/>
-          <p:nvPr/>
-        </p:nvSpPr>
-        <p:spPr>
-          <a:xfrm>
-            <a:off x="941832" y="2697480"/>
-            <a:ext cx="2103120" cy="658368"/>
-          </a:xfrm>
-          <a:prstGeom prst="rect">
-            <a:avLst/>
-          </a:prstGeom>
-          <a:noFill/>
-        </p:spPr>
-        <p:txBody>
-          <a:bodyPr wrap="square" lIns="0" rIns="0" tIns="0" bIns="0" anchor="ctr">
-            <a:spAutoFit/>
-          </a:bodyPr>
-          <a:lstStyle/>
-          <a:p>
-            <a:pPr algn="l"/>
-            <a:r>
-              <a:rPr sz="1300" b="1" i="0">
-                <a:solidFill>
-                  <a:srgbClr val="8A1626"/>
-                </a:solidFill>
-              </a:rPr>
-              <a:t>What is it?</a:t>
-            </a:r>
-          </a:p>
-        </p:txBody>
-      </p:sp>
-      <p:sp>
-        <p:nvSpPr>
-          <p:cNvPr id="48" name="Rectangle 47"/>
-          <p:cNvSpPr/>
-          <p:nvPr/>
-        </p:nvSpPr>
-        <p:spPr>
-          <a:xfrm>
-            <a:off x="3154680" y="2697480"/>
-            <a:ext cx="8257032" cy="658368"/>
-          </a:xfrm>
-          <a:prstGeom prst="rect">
-            <a:avLst/>
-          </a:prstGeom>
-          <a:solidFill>
-            <a:srgbClr val="F7F5F2"/>
-          </a:solidFill>
-          <a:ln>
-            <a:noFill/>
-          </a:ln>
-          <a:effectLst/>
-        </p:spPr>
-        <p:style>
-          <a:lnRef idx="1">
-            <a:schemeClr val="accent1"/>
-          </a:lnRef>
-          <a:fillRef idx="3">
-            <a:schemeClr val="accent1"/>
-          </a:fillRef>
-          <a:effectRef idx="2">
-            <a:schemeClr val="accent1"/>
-          </a:effectRef>
-          <a:fontRef idx="minor">
-            <a:schemeClr val="lt1"/>
-          </a:fontRef>
-        </p:style>
-        <p:txBody>
-          <a:bodyPr rtlCol="0" anchor="ctr" lIns="0" rIns="0" tIns="0" bIns="0"/>
-          <a:lstStyle/>
-          <a:p>
-            <a:pPr algn="ctr"/>
-          </a:p>
-        </p:txBody>
-      </p:sp>
-      <p:sp>
-        <p:nvSpPr>
-          <p:cNvPr id="49" name="TextBox 48"/>
-          <p:cNvSpPr txBox="1"/>
-          <p:nvPr/>
-        </p:nvSpPr>
-        <p:spPr>
-          <a:xfrm>
-            <a:off x="3337560" y="2697480"/>
-            <a:ext cx="7936992" cy="658368"/>
-          </a:xfrm>
-          <a:prstGeom prst="rect">
-            <a:avLst/>
-          </a:prstGeom>
-          <a:noFill/>
-        </p:spPr>
-        <p:txBody>
-          <a:bodyPr wrap="square" lIns="0" rIns="0" tIns="0" bIns="0" anchor="ctr">
-            <a:spAutoFit/>
-          </a:bodyPr>
-          <a:lstStyle/>
-          <a:p>
-            <a:pPr algn="l"/>
-            <a:r>
-              <a:rPr sz="1200" b="0" i="0">
-                <a:solidFill>
-                  <a:srgbClr val="1A1A1A"/>
-                </a:solidFill>
-              </a:rPr>
-              <a:t>A VaR engine in the Drishti server: historical simulation over 509 scenario days (or a set window), VaR 99% (95% by setting) and ES 97.5%, 1 day, on demand for any set of trades or positions: the bank, a legal entity, desk, book, a portfolio, a rule or a basket.</a:t>
-            </a:r>
-          </a:p>
-        </p:txBody>
-      </p:sp>
-      <p:sp>
-        <p:nvSpPr>
-          <p:cNvPr id="50" name="Rectangle 49"/>
-          <p:cNvSpPr/>
-          <p:nvPr/>
-        </p:nvSpPr>
-        <p:spPr>
-          <a:xfrm>
-            <a:off x="777240" y="3392424"/>
-            <a:ext cx="2331720" cy="548640"/>
-          </a:xfrm>
-          <a:prstGeom prst="rect">
-            <a:avLst/>
-          </a:prstGeom>
-          <a:solidFill>
-            <a:srgbClr val="8A1626"/>
-          </a:solidFill>
-          <a:ln>
-            <a:noFill/>
-          </a:ln>
-          <a:effectLst/>
-        </p:spPr>
-        <p:style>
-          <a:lnRef idx="1">
-            <a:schemeClr val="accent1"/>
-          </a:lnRef>
-          <a:fillRef idx="3">
-            <a:schemeClr val="accent1"/>
-          </a:fillRef>
-          <a:effectRef idx="2">
-            <a:schemeClr val="accent1"/>
-          </a:effectRef>
-          <a:fontRef idx="minor">
-            <a:schemeClr val="lt1"/>
-          </a:fontRef>
-        </p:style>
-        <p:txBody>
-          <a:bodyPr rtlCol="0" anchor="ctr" lIns="0" rIns="0" tIns="0" bIns="0"/>
-          <a:lstStyle/>
-          <a:p>
-            <a:pPr algn="ctr"/>
-          </a:p>
-        </p:txBody>
-      </p:sp>
-      <p:sp>
-        <p:nvSpPr>
-          <p:cNvPr id="51" name="TextBox 50"/>
-          <p:cNvSpPr txBox="1"/>
-          <p:nvPr/>
-        </p:nvSpPr>
-        <p:spPr>
-          <a:xfrm>
-            <a:off x="941832" y="3392424"/>
-            <a:ext cx="2103120" cy="548640"/>
-          </a:xfrm>
-          <a:prstGeom prst="rect">
-            <a:avLst/>
-          </a:prstGeom>
-          <a:noFill/>
-        </p:spPr>
-        <p:txBody>
-          <a:bodyPr wrap="square" lIns="0" rIns="0" tIns="0" bIns="0" anchor="ctr">
-            <a:spAutoFit/>
-          </a:bodyPr>
-          <a:lstStyle/>
-          <a:p>
-            <a:pPr algn="l"/>
-            <a:r>
-              <a:rPr sz="1300" b="1" i="0">
-                <a:solidFill>
-                  <a:srgbClr val="FFFFFF"/>
-                </a:solidFill>
-              </a:rPr>
-              <a:t>Every input</a:t>
-            </a:r>
-          </a:p>
-        </p:txBody>
-      </p:sp>
-      <p:sp>
-        <p:nvSpPr>
-          <p:cNvPr id="52" name="Rectangle 51"/>
-          <p:cNvSpPr/>
-          <p:nvPr/>
-        </p:nvSpPr>
-        <p:spPr>
-          <a:xfrm>
-            <a:off x="3154680" y="3392424"/>
-            <a:ext cx="8257032" cy="548640"/>
-          </a:xfrm>
-          <a:prstGeom prst="rect">
-            <a:avLst/>
-          </a:prstGeom>
-          <a:solidFill>
-            <a:srgbClr val="F6E6E9"/>
-          </a:solidFill>
-          <a:ln>
-            <a:noFill/>
-          </a:ln>
-          <a:effectLst/>
-        </p:spPr>
-        <p:style>
-          <a:lnRef idx="1">
-            <a:schemeClr val="accent1"/>
-          </a:lnRef>
-          <a:fillRef idx="3">
-            <a:schemeClr val="accent1"/>
-          </a:fillRef>
-          <a:effectRef idx="2">
-            <a:schemeClr val="accent1"/>
-          </a:effectRef>
-          <a:fontRef idx="minor">
-            <a:schemeClr val="lt1"/>
-          </a:fontRef>
-        </p:style>
-        <p:txBody>
-          <a:bodyPr rtlCol="0" anchor="ctr" lIns="0" rIns="0" tIns="0" bIns="0"/>
-          <a:lstStyle/>
-          <a:p>
-            <a:pPr algn="ctr"/>
-          </a:p>
-        </p:txBody>
-      </p:sp>
-      <p:sp>
-        <p:nvSpPr>
-          <p:cNvPr id="53" name="TextBox 52"/>
-          <p:cNvSpPr txBox="1"/>
-          <p:nvPr/>
-        </p:nvSpPr>
-        <p:spPr>
-          <a:xfrm>
-            <a:off x="3337560" y="3392424"/>
-            <a:ext cx="7936992" cy="548640"/>
-          </a:xfrm>
-          <a:prstGeom prst="rect">
-            <a:avLst/>
-          </a:prstGeom>
-          <a:noFill/>
-        </p:spPr>
-        <p:txBody>
-          <a:bodyPr wrap="square" lIns="0" rIns="0" tIns="0" bIns="0" anchor="ctr">
-            <a:spAutoFit/>
-          </a:bodyPr>
-          <a:lstStyle/>
-          <a:p>
-            <a:pPr algn="l"/>
-            <a:r>
-              <a:rPr sz="1250" b="1" i="0">
-                <a:solidFill>
-                  <a:srgbClr val="8A1626"/>
-                </a:solidFill>
-              </a:rPr>
-              <a:t>One engine, every input: scenario PVs or path P&amp;L, by trade or by position, any currency, files or Kafka. Source systems keep their own formats.</a:t>
-            </a:r>
-          </a:p>
-        </p:txBody>
-      </p:sp>
-      <p:sp>
-        <p:nvSpPr>
-          <p:cNvPr id="54" name="Rectangle 53"/>
-          <p:cNvSpPr/>
-          <p:nvPr/>
-        </p:nvSpPr>
-        <p:spPr>
-          <a:xfrm>
-            <a:off x="777240" y="3977639"/>
-            <a:ext cx="2331720" cy="932688"/>
-          </a:xfrm>
-          <a:prstGeom prst="rect">
-            <a:avLst/>
-          </a:prstGeom>
-          <a:solidFill>
-            <a:srgbClr val="F6E6E9"/>
-          </a:solidFill>
-          <a:ln>
-            <a:noFill/>
-          </a:ln>
-          <a:effectLst/>
-        </p:spPr>
-        <p:style>
-          <a:lnRef idx="1">
-            <a:schemeClr val="accent1"/>
-          </a:lnRef>
-          <a:fillRef idx="3">
-            <a:schemeClr val="accent1"/>
-          </a:fillRef>
-          <a:effectRef idx="2">
-            <a:schemeClr val="accent1"/>
-          </a:effectRef>
-          <a:fontRef idx="minor">
-            <a:schemeClr val="lt1"/>
-          </a:fontRef>
-        </p:style>
-        <p:txBody>
-          <a:bodyPr rtlCol="0" anchor="ctr" lIns="0" rIns="0" tIns="0" bIns="0"/>
-          <a:lstStyle/>
-          <a:p>
-            <a:pPr algn="ctr"/>
-          </a:p>
-        </p:txBody>
-      </p:sp>
-      <p:sp>
-        <p:nvSpPr>
-          <p:cNvPr id="55" name="TextBox 54"/>
-          <p:cNvSpPr txBox="1"/>
-          <p:nvPr/>
-        </p:nvSpPr>
-        <p:spPr>
-          <a:xfrm>
-            <a:off x="941832" y="3977639"/>
-            <a:ext cx="2103120" cy="932688"/>
-          </a:xfrm>
-          <a:prstGeom prst="rect">
-            <a:avLst/>
-          </a:prstGeom>
-          <a:noFill/>
-        </p:spPr>
-        <p:txBody>
-          <a:bodyPr wrap="square" lIns="0" rIns="0" tIns="0" bIns="0" anchor="ctr">
-            <a:spAutoFit/>
-          </a:bodyPr>
-          <a:lstStyle/>
-          <a:p>
-            <a:pPr algn="l"/>
-            <a:r>
-              <a:rPr sz="1300" b="1" i="0">
-                <a:solidFill>
-                  <a:srgbClr val="8A1626"/>
-                </a:solidFill>
-              </a:rPr>
-              <a:t>How does it work?</a:t>
-            </a:r>
-          </a:p>
-        </p:txBody>
-      </p:sp>
-      <p:sp>
-        <p:nvSpPr>
-          <p:cNvPr id="56" name="Rectangle 55"/>
-          <p:cNvSpPr/>
-          <p:nvPr/>
-        </p:nvSpPr>
-        <p:spPr>
-          <a:xfrm>
-            <a:off x="3154680" y="3977639"/>
-            <a:ext cx="8257032" cy="932688"/>
-          </a:xfrm>
-          <a:prstGeom prst="rect">
-            <a:avLst/>
-          </a:prstGeom>
-          <a:solidFill>
-            <a:srgbClr val="F7F5F2"/>
-          </a:solidFill>
-          <a:ln>
-            <a:noFill/>
-          </a:ln>
-          <a:effectLst/>
-        </p:spPr>
-        <p:style>
-          <a:lnRef idx="1">
-            <a:schemeClr val="accent1"/>
-          </a:lnRef>
-          <a:fillRef idx="3">
-            <a:schemeClr val="accent1"/>
-          </a:fillRef>
-          <a:effectRef idx="2">
-            <a:schemeClr val="accent1"/>
-          </a:effectRef>
-          <a:fontRef idx="minor">
-            <a:schemeClr val="lt1"/>
-          </a:fontRef>
-        </p:style>
-        <p:txBody>
-          <a:bodyPr rtlCol="0" anchor="ctr" lIns="0" rIns="0" tIns="0" bIns="0"/>
-          <a:lstStyle/>
-          <a:p>
-            <a:pPr algn="ctr"/>
-          </a:p>
-        </p:txBody>
-      </p:sp>
-      <p:sp>
-        <p:nvSpPr>
-          <p:cNvPr id="57" name="TextBox 56"/>
-          <p:cNvSpPr txBox="1"/>
-          <p:nvPr/>
-        </p:nvSpPr>
-        <p:spPr>
-          <a:xfrm>
-            <a:off x="3337560" y="3977639"/>
-            <a:ext cx="7936992" cy="932688"/>
-          </a:xfrm>
-          <a:prstGeom prst="rect">
-            <a:avLst/>
-          </a:prstGeom>
-          <a:noFill/>
-        </p:spPr>
-        <p:txBody>
-          <a:bodyPr wrap="square" lIns="0" rIns="0" tIns="0" bIns="0" anchor="ctr">
-            <a:spAutoFit/>
-          </a:bodyPr>
-          <a:lstStyle/>
-          <a:p>
-            <a:pPr algn="l"/>
-            <a:r>
-              <a:rPr sz="1200" b="0" i="0">
-                <a:solidFill>
-                  <a:srgbClr val="1A1A1A"/>
-                </a:solidFill>
-              </a:rPr>
-              <a:t>It never reprices. The pricing systems send scenario PVs (in each trade's or position's own currency) or path P&amp;L, at trade or position level, through files or Kafka. Drishti turns each into one internal form, a P&amp;L vector per trade or position, converting PVs with scenario FX into any reporting currency. A scope's vector is the sum of its trades' or positions' vectors, and VaR, ES and every contribution are read from that one vector.</a:t>
-            </a:r>
-          </a:p>
-        </p:txBody>
-      </p:sp>
-      <p:sp>
-        <p:nvSpPr>
-          <p:cNvPr id="58" name="Rectangle 57"/>
-          <p:cNvSpPr/>
-          <p:nvPr/>
-        </p:nvSpPr>
-        <p:spPr>
-          <a:xfrm>
-            <a:off x="777240" y="4946904"/>
-            <a:ext cx="2331720" cy="548640"/>
-          </a:xfrm>
-          <a:prstGeom prst="rect">
-            <a:avLst/>
-          </a:prstGeom>
-          <a:solidFill>
-            <a:srgbClr val="F6E6E9"/>
-          </a:solidFill>
-          <a:ln>
-            <a:noFill/>
-          </a:ln>
-          <a:effectLst/>
-        </p:spPr>
-        <p:style>
-          <a:lnRef idx="1">
-            <a:schemeClr val="accent1"/>
-          </a:lnRef>
-          <a:fillRef idx="3">
-            <a:schemeClr val="accent1"/>
-          </a:fillRef>
-          <a:effectRef idx="2">
-            <a:schemeClr val="accent1"/>
-          </a:effectRef>
-          <a:fontRef idx="minor">
-            <a:schemeClr val="lt1"/>
-          </a:fontRef>
-        </p:style>
-        <p:txBody>
-          <a:bodyPr rtlCol="0" anchor="ctr" lIns="0" rIns="0" tIns="0" bIns="0"/>
-          <a:lstStyle/>
-          <a:p>
-            <a:pPr algn="ctr"/>
-          </a:p>
-        </p:txBody>
-      </p:sp>
-      <p:sp>
-        <p:nvSpPr>
-          <p:cNvPr id="59" name="TextBox 58"/>
-          <p:cNvSpPr txBox="1"/>
-          <p:nvPr/>
-        </p:nvSpPr>
-        <p:spPr>
-          <a:xfrm>
-            <a:off x="941832" y="4946904"/>
-            <a:ext cx="2103120" cy="548640"/>
-          </a:xfrm>
-          <a:prstGeom prst="rect">
-            <a:avLst/>
-          </a:prstGeom>
-          <a:noFill/>
-        </p:spPr>
-        <p:txBody>
-          <a:bodyPr wrap="square" lIns="0" rIns="0" tIns="0" bIns="0" anchor="ctr">
-            <a:spAutoFit/>
-          </a:bodyPr>
-          <a:lstStyle/>
-          <a:p>
-            <a:pPr algn="l"/>
-            <a:r>
-              <a:rPr sz="1300" b="1" i="0">
-                <a:solidFill>
-                  <a:srgbClr val="8A1626"/>
-                </a:solidFill>
-              </a:rPr>
-              <a:t>Can I trust it?</a:t>
-            </a:r>
-          </a:p>
-        </p:txBody>
-      </p:sp>
-      <p:sp>
-        <p:nvSpPr>
-          <p:cNvPr id="60" name="Rectangle 59"/>
-          <p:cNvSpPr/>
-          <p:nvPr/>
-        </p:nvSpPr>
-        <p:spPr>
-          <a:xfrm>
-            <a:off x="3154680" y="4946904"/>
-            <a:ext cx="8257032" cy="548640"/>
-          </a:xfrm>
-          <a:prstGeom prst="rect">
-            <a:avLst/>
-          </a:prstGeom>
-          <a:solidFill>
-            <a:srgbClr val="F7F5F2"/>
-          </a:solidFill>
-          <a:ln>
-            <a:noFill/>
-          </a:ln>
-          <a:effectLst/>
-        </p:spPr>
-        <p:style>
-          <a:lnRef idx="1">
-            <a:schemeClr val="accent1"/>
-          </a:lnRef>
-          <a:fillRef idx="3">
-            <a:schemeClr val="accent1"/>
-          </a:fillRef>
-          <a:effectRef idx="2">
-            <a:schemeClr val="accent1"/>
-          </a:effectRef>
-          <a:fontRef idx="minor">
-            <a:schemeClr val="lt1"/>
-          </a:fontRef>
-        </p:style>
-        <p:txBody>
-          <a:bodyPr rtlCol="0" anchor="ctr" lIns="0" rIns="0" tIns="0" bIns="0"/>
-          <a:lstStyle/>
-          <a:p>
-            <a:pPr algn="ctr"/>
-          </a:p>
-        </p:txBody>
-      </p:sp>
-      <p:sp>
-        <p:nvSpPr>
-          <p:cNvPr id="61" name="TextBox 60"/>
-          <p:cNvSpPr txBox="1"/>
-          <p:nvPr/>
-        </p:nvSpPr>
-        <p:spPr>
-          <a:xfrm>
-            <a:off x="3337560" y="4946904"/>
-            <a:ext cx="7936992" cy="548640"/>
-          </a:xfrm>
-          <a:prstGeom prst="rect">
-            <a:avLst/>
-          </a:prstGeom>
-          <a:noFill/>
-        </p:spPr>
-        <p:txBody>
-          <a:bodyPr wrap="square" lIns="0" rIns="0" tIns="0" bIns="0" anchor="ctr">
-            <a:spAutoFit/>
-          </a:bodyPr>
-          <a:lstStyle/>
-          <a:p>
-            <a:pPr algn="l"/>
-            <a:r>
-              <a:rPr sz="1200" b="0" i="0">
-                <a:solidFill>
-                  <a:srgbClr val="1A1A1A"/>
-                </a:solidFill>
-              </a:rPr>
-              <a:t>Every answer names its inputs' versions, batch ids, scenario set, method and memory tier; components add up to the VaR exactly; every node gets an official end-of-day record, append-only, kept 7 years.</a:t>
-            </a:r>
-          </a:p>
-        </p:txBody>
-      </p:sp>
-      <p:sp>
-        <p:nvSpPr>
-          <p:cNvPr id="62" name="Rectangle 61"/>
-          <p:cNvSpPr/>
-          <p:nvPr/>
-        </p:nvSpPr>
-        <p:spPr>
-          <a:xfrm>
-            <a:off x="777240" y="5532120"/>
-            <a:ext cx="2331720" cy="585216"/>
-          </a:xfrm>
-          <a:prstGeom prst="rect">
-            <a:avLst/>
-          </a:prstGeom>
-          <a:solidFill>
-            <a:srgbClr val="F6E6E9"/>
-          </a:solidFill>
-          <a:ln>
-            <a:noFill/>
-          </a:ln>
-          <a:effectLst/>
-        </p:spPr>
-        <p:style>
-          <a:lnRef idx="1">
-            <a:schemeClr val="accent1"/>
-          </a:lnRef>
-          <a:fillRef idx="3">
-            <a:schemeClr val="accent1"/>
-          </a:fillRef>
-          <a:effectRef idx="2">
-            <a:schemeClr val="accent1"/>
-          </a:effectRef>
-          <a:fontRef idx="minor">
-            <a:schemeClr val="lt1"/>
-          </a:fontRef>
-        </p:style>
-        <p:txBody>
-          <a:bodyPr rtlCol="0" anchor="ctr" lIns="0" rIns="0" tIns="0" bIns="0"/>
-          <a:lstStyle/>
-          <a:p>
-            <a:pPr algn="ctr"/>
-          </a:p>
-        </p:txBody>
-      </p:sp>
-      <p:sp>
-        <p:nvSpPr>
-          <p:cNvPr id="63" name="TextBox 62"/>
-          <p:cNvSpPr txBox="1"/>
-          <p:nvPr/>
-        </p:nvSpPr>
-        <p:spPr>
-          <a:xfrm>
-            <a:off x="941832" y="5532120"/>
-            <a:ext cx="2103120" cy="585216"/>
-          </a:xfrm>
-          <a:prstGeom prst="rect">
-            <a:avLst/>
-          </a:prstGeom>
-          <a:noFill/>
-        </p:spPr>
-        <p:txBody>
-          <a:bodyPr wrap="square" lIns="0" rIns="0" tIns="0" bIns="0" anchor="ctr">
-            <a:spAutoFit/>
-          </a:bodyPr>
-          <a:lstStyle/>
-          <a:p>
-            <a:pPr algn="l"/>
-            <a:r>
-              <a:rPr sz="1300" b="1" i="0">
-                <a:solidFill>
-                  <a:srgbClr val="8A1626"/>
-                </a:solidFill>
-              </a:rPr>
-              <a:t>Does it scale?</a:t>
-            </a:r>
-          </a:p>
-        </p:txBody>
-      </p:sp>
-      <p:sp>
-        <p:nvSpPr>
-          <p:cNvPr id="64" name="Rectangle 63"/>
-          <p:cNvSpPr/>
-          <p:nvPr/>
-        </p:nvSpPr>
-        <p:spPr>
-          <a:xfrm>
-            <a:off x="3154680" y="5532120"/>
-            <a:ext cx="8257032" cy="585216"/>
-          </a:xfrm>
-          <a:prstGeom prst="rect">
-            <a:avLst/>
-          </a:prstGeom>
-          <a:solidFill>
-            <a:srgbClr val="F7F5F2"/>
-          </a:solidFill>
-          <a:ln>
-            <a:noFill/>
-          </a:ln>
-          <a:effectLst/>
-        </p:spPr>
-        <p:style>
-          <a:lnRef idx="1">
-            <a:schemeClr val="accent1"/>
-          </a:lnRef>
-          <a:fillRef idx="3">
-            <a:schemeClr val="accent1"/>
-          </a:fillRef>
-          <a:effectRef idx="2">
-            <a:schemeClr val="accent1"/>
-          </a:effectRef>
-          <a:fontRef idx="minor">
-            <a:schemeClr val="lt1"/>
-          </a:fontRef>
-        </p:style>
-        <p:txBody>
-          <a:bodyPr rtlCol="0" anchor="ctr" lIns="0" rIns="0" tIns="0" bIns="0"/>
-          <a:lstStyle/>
-          <a:p>
-            <a:pPr algn="ctr"/>
-          </a:p>
-        </p:txBody>
-      </p:sp>
-      <p:sp>
-        <p:nvSpPr>
-          <p:cNvPr id="65" name="TextBox 64"/>
-          <p:cNvSpPr txBox="1"/>
-          <p:nvPr/>
-        </p:nvSpPr>
-        <p:spPr>
-          <a:xfrm>
-            <a:off x="3337560" y="5532120"/>
-            <a:ext cx="7936992" cy="585216"/>
-          </a:xfrm>
-          <a:prstGeom prst="rect">
-            <a:avLst/>
-          </a:prstGeom>
-          <a:noFill/>
-        </p:spPr>
-        <p:txBody>
-          <a:bodyPr wrap="square" lIns="0" rIns="0" tIns="0" bIns="0" anchor="ctr">
-            <a:spAutoFit/>
-          </a:bodyPr>
-          <a:lstStyle/>
-          <a:p>
-            <a:pPr algn="l"/>
-            <a:r>
-              <a:rPr sz="1200" b="0" i="0">
+              <a:rPr sz="1300" b="0" i="0">
                 <a:solidFill>
                   <a:srgbClr val="1A1A1A"/>
                 </a:solidFill>

</xml_diff>

<commit_message>
The VaR engine deck explains its backtests: a footnote naming the Kupiec test, the Christoffersen test and the Basel traffic light
</commit_message>
<xml_diff>
--- a/docs/publications/Drishti-VaR-Engine.pptx
+++ b/docs/publications/Drishti-VaR-Engine.pptx
@@ -1502,7 +1502,7 @@
           <a:lstStyle/>
           <a:p>
             <a:r>
-              <a:t>Sources: VAR_GUIDE.md section 1 (the question, methodology: historical simulation, equal weights, 1-day; ES at 97.5% as in FRTB IMA without liquidity horizons), section 2 (the measures table), section 2.1 (the worked example: every number on this slide), section 18 (formulas: k = clamp(ceil(N(1−α) − 1e-9), 1, N); component tail = ranks k−h..k+h with window 5; scale c = VaR / smoothed VaR), section 7 (backtest: green 0–4, amber 5–9, red 10+ exceptions in 250 days), section 3.2 (limit bars: amber at 75%, red at 90%).</a:t>
+              <a:t>Sources: VAR_GUIDE.md section 1 (the question, methodology: historical simulation, equal weights, 1-day; ES at 97.5% as in FRTB IMA without liquidity horizons), section 2 (the measures table), section 2.1 (the worked example: every number on this slide), section 18 (formulas: k = clamp(ceil(N(1−α) − 1e-9), 1, N); component tail = ranks k−h..k+h with window 5; scale c = VaR / smoothed VaR), section 7 (backtest: the Basel traffic light counts breaches, losses bigger than VaR, in 250 days at 99%: 0–4 green, 5–9 amber, 10+ red; the Kupiec test (Paul Kupiec, 1995) asks whether the number of breaches is consistent with 99%, about 2–3 in 250 days; the Christoffersen test (Peter Christoffersen, 1998) asks whether breaches cluster together, a sign the model reacts too slowly when markets turn. Both are standard statistical tests named after the researchers who published them. Drishti reports their p-values), section 3.2 (limit bars: amber at 75%, red at 90%).</a:t>
             </a:r>
           </a:p>
           <a:p/>
@@ -1706,7 +1706,7 @@
           <a:p/>
           <a:p>
             <a:r>
-              <a:t>Confidence (2.9.4): VaR 99% by default, 95% by configuration (DRISHTI_VAR_CONFIDENCE, the setting drishti.var.confidence); ES 97.5% by default (DRISHTI_VAR_ES_CONFIDENCE); both may also be set per request, and every label on the screens follows the answer. The backtest (exceptions, Basel light, Kupiec and Christoffersen) stays at 99%.</a:t>
+              <a:t>Confidence (2.9.4): VaR 99% by default, 95% by configuration (DRISHTI_VAR_CONFIDENCE, the setting drishti.var.confidence); ES 97.5% by default (DRISHTI_VAR_ES_CONFIDENCE); both may also be set per request, and every label on the screens follows the answer. The backtest stays at 99%: the Basel traffic light (breaches in 250 days at 99%: 0–4 green, 5–9 amber, 10+ red), the Kupiec test (Paul Kupiec, 1995: is the number of breaches consistent with 99%, about 2–3 in 250 days?) and the Christoffersen test (Peter Christoffersen, 1998: do breaches cluster together, a sign the model reacts too slowly when markets turn?). Both are standard statistical tests named after the researchers who published them. Drishti reports their p-values.</a:t>
             </a:r>
           </a:p>
           <a:p/>
@@ -8581,7 +8581,7 @@
                   <a:srgbClr val="1A1A1A"/>
                 </a:solidFill>
               </a:rPr>
-              <a:t>MGMT or LEGAL tree with VaR, ES and limit bars; VaR, ES, sum of standalone, diversification, limit use, backtest light.</a:t>
+              <a:t>MGMT or LEGAL tree with VaR, ES and limit bars; VaR, ES, sum of standalone, diversification, limit use, backtest exceptions.</a:t>
             </a:r>
           </a:p>
           <a:p>
@@ -23513,7 +23513,7 @@
         <p:spPr>
           <a:xfrm>
             <a:off x="777240" y="4526280"/>
-            <a:ext cx="1207008" cy="1051560"/>
+            <a:ext cx="1207008" cy="987552"/>
           </a:xfrm>
           <a:prstGeom prst="rect">
             <a:avLst/>
@@ -23624,8 +23624,8 @@
         </p:nvSpPr>
         <p:spPr>
           <a:xfrm>
-            <a:off x="868680" y="5120640"/>
-            <a:ext cx="1069848" cy="457200"/>
+            <a:off x="868680" y="5102352"/>
+            <a:ext cx="1069848" cy="411480"/>
           </a:xfrm>
           <a:prstGeom prst="rect">
             <a:avLst/>
@@ -23659,7 +23659,7 @@
         <p:spPr>
           <a:xfrm>
             <a:off x="2066544" y="4526280"/>
-            <a:ext cx="1207008" cy="1051560"/>
+            <a:ext cx="1207008" cy="987552"/>
           </a:xfrm>
           <a:prstGeom prst="rect">
             <a:avLst/>
@@ -23770,8 +23770,8 @@
         </p:nvSpPr>
         <p:spPr>
           <a:xfrm>
-            <a:off x="2157984" y="5120640"/>
-            <a:ext cx="1069848" cy="457200"/>
+            <a:off x="2157984" y="5102352"/>
+            <a:ext cx="1069848" cy="411480"/>
           </a:xfrm>
           <a:prstGeom prst="rect">
             <a:avLst/>
@@ -23805,7 +23805,7 @@
         <p:spPr>
           <a:xfrm>
             <a:off x="3355848" y="4526280"/>
-            <a:ext cx="1207008" cy="1051560"/>
+            <a:ext cx="1207008" cy="987552"/>
           </a:xfrm>
           <a:prstGeom prst="rect">
             <a:avLst/>
@@ -23916,8 +23916,8 @@
         </p:nvSpPr>
         <p:spPr>
           <a:xfrm>
-            <a:off x="3447288" y="5120640"/>
-            <a:ext cx="1069848" cy="457200"/>
+            <a:off x="3447288" y="5102352"/>
+            <a:ext cx="1069848" cy="411480"/>
           </a:xfrm>
           <a:prstGeom prst="rect">
             <a:avLst/>
@@ -23951,7 +23951,7 @@
         <p:spPr>
           <a:xfrm>
             <a:off x="4645152" y="4526280"/>
-            <a:ext cx="1207008" cy="1051560"/>
+            <a:ext cx="1207008" cy="987552"/>
           </a:xfrm>
           <a:prstGeom prst="rect">
             <a:avLst/>
@@ -24062,8 +24062,8 @@
         </p:nvSpPr>
         <p:spPr>
           <a:xfrm>
-            <a:off x="4736592" y="5120640"/>
-            <a:ext cx="1069848" cy="457200"/>
+            <a:off x="4736592" y="5102352"/>
+            <a:ext cx="1069848" cy="411480"/>
           </a:xfrm>
           <a:prstGeom prst="rect">
             <a:avLst/>
@@ -24097,7 +24097,7 @@
         <p:spPr>
           <a:xfrm>
             <a:off x="5934456" y="4526280"/>
-            <a:ext cx="1207008" cy="1051560"/>
+            <a:ext cx="1207008" cy="987552"/>
           </a:xfrm>
           <a:prstGeom prst="rect">
             <a:avLst/>
@@ -24208,8 +24208,8 @@
         </p:nvSpPr>
         <p:spPr>
           <a:xfrm>
-            <a:off x="6025896" y="5120640"/>
-            <a:ext cx="1069848" cy="457200"/>
+            <a:off x="6025896" y="5102352"/>
+            <a:ext cx="1069848" cy="411480"/>
           </a:xfrm>
           <a:prstGeom prst="rect">
             <a:avLst/>
@@ -24242,8 +24242,8 @@
         </p:nvSpPr>
         <p:spPr>
           <a:xfrm>
-            <a:off x="777240" y="5669280"/>
-            <a:ext cx="6400800" cy="502920"/>
+            <a:off x="777240" y="5815584"/>
+            <a:ext cx="10634472" cy="493776"/>
           </a:xfrm>
           <a:prstGeom prst="rect">
             <a:avLst/>
@@ -24251,19 +24251,41 @@
           <a:noFill/>
         </p:spPr>
         <p:txBody>
-          <a:bodyPr wrap="square" lIns="0" rIns="0" tIns="0" bIns="0" anchor="t">
+          <a:bodyPr wrap="square" lIns="0" rIns="0" tIns="0" bIns="0" anchor="b">
             <a:spAutoFit/>
           </a:bodyPr>
           <a:lstStyle/>
           <a:p>
             <a:pPr algn="l"/>
             <a:r>
-              <a:rPr sz="1100" b="0" i="1">
+              <a:rPr sz="1000" b="0" i="0">
                 <a:solidFill>
                   <a:srgbClr val="4A5058"/>
                 </a:solidFill>
               </a:rPr>
-              <a:t>At N = 509 the same steps use the 6th worst for VaR, the 13 worst for ES and ranks 4 to 8 for components. Defaults shown: window and confidence are settings (next slide).</a:t>
+              <a:t>Kupiec test (Paul Kupiec, 1995): is the number of VaR breaches (losses bigger than VaR) consistent with 99%, about 2–3 in 250 days?</a:t>
+            </a:r>
+          </a:p>
+          <a:p>
+            <a:pPr algn="l"/>
+            <a:r>
+              <a:rPr sz="1000" b="0" i="0">
+                <a:solidFill>
+                  <a:srgbClr val="4A5058"/>
+                </a:solidFill>
+              </a:rPr>
+              <a:t>Christoffersen test (Peter Christoffersen, 1998): do breaches cluster together, a sign the model reacts too slowly when markets turn?</a:t>
+            </a:r>
+          </a:p>
+          <a:p>
+            <a:pPr algn="l"/>
+            <a:r>
+              <a:rPr sz="1000" b="0" i="0">
+                <a:solidFill>
+                  <a:srgbClr val="4A5058"/>
+                </a:solidFill>
+              </a:rPr>
+              <a:t>Basel traffic light: breaches in 250 days at 99%: 0–4 green, 5–9 amber, 10+ red.</a:t>
             </a:r>
           </a:p>
         </p:txBody>
@@ -24312,7 +24334,7 @@
         </p:nvGraphicFramePr>
         <p:xfrm>
           <a:off x="7452360" y="2862072"/>
-          <a:ext cx="3959352" cy="3017520"/>
+          <a:ext cx="3959352" cy="2551176"/>
         </p:xfrm>
         <a:graphic>
           <a:graphicData uri="http://schemas.openxmlformats.org/drawingml/2006/table">
@@ -24324,7 +24346,7 @@
                 <a:gridCol w="1298448"/>
                 <a:gridCol w="2660904"/>
               </a:tblGrid>
-              <a:tr h="301752">
+              <a:tr h="283464">
                 <a:tc>
                   <a:txBody>
                     <a:bodyPr wrap="square"/>
@@ -24416,7 +24438,7 @@
                   </a:tcPr>
                 </a:tc>
               </a:tr>
-              <a:tr h="301752">
+              <a:tr h="283464">
                 <a:tc>
                   <a:txBody>
                     <a:bodyPr wrap="square"/>
@@ -24508,7 +24530,7 @@
                   </a:tcPr>
                 </a:tc>
               </a:tr>
-              <a:tr h="301752">
+              <a:tr h="283464">
                 <a:tc>
                   <a:txBody>
                     <a:bodyPr wrap="square"/>
@@ -24600,7 +24622,7 @@
                   </a:tcPr>
                 </a:tc>
               </a:tr>
-              <a:tr h="301752">
+              <a:tr h="283464">
                 <a:tc>
                   <a:txBody>
                     <a:bodyPr wrap="square"/>
@@ -24692,7 +24714,7 @@
                   </a:tcPr>
                 </a:tc>
               </a:tr>
-              <a:tr h="301752">
+              <a:tr h="283464">
                 <a:tc>
                   <a:txBody>
                     <a:bodyPr wrap="square"/>
@@ -24784,7 +24806,7 @@
                   </a:tcPr>
                 </a:tc>
               </a:tr>
-              <a:tr h="301752">
+              <a:tr h="283464">
                 <a:tc>
                   <a:txBody>
                     <a:bodyPr wrap="square"/>
@@ -24876,7 +24898,7 @@
                   </a:tcPr>
                 </a:tc>
               </a:tr>
-              <a:tr h="301752">
+              <a:tr h="283464">
                 <a:tc>
                   <a:txBody>
                     <a:bodyPr wrap="square"/>
@@ -24968,7 +24990,7 @@
                   </a:tcPr>
                 </a:tc>
               </a:tr>
-              <a:tr h="301752">
+              <a:tr h="283464">
                 <a:tc>
                   <a:txBody>
                     <a:bodyPr wrap="square"/>
@@ -25060,7 +25082,7 @@
                   </a:tcPr>
                 </a:tc>
               </a:tr>
-              <a:tr h="301752">
+              <a:tr h="283464">
                 <a:tc>
                   <a:txBody>
                     <a:bodyPr wrap="square"/>
@@ -25148,98 +25170,6 @@
                     </a:lnB>
                     <a:solidFill>
                       <a:srgbClr val="FFFFFF"/>
-                    </a:solidFill>
-                  </a:tcPr>
-                </a:tc>
-              </a:tr>
-              <a:tr h="301752">
-                <a:tc>
-                  <a:txBody>
-                    <a:bodyPr wrap="square"/>
-                    <a:lstStyle/>
-                    <a:p>
-                      <a:r>
-                        <a:rPr sz="1100" b="1" i="0">
-                          <a:solidFill>
-                            <a:srgbClr val="8A1626"/>
-                          </a:solidFill>
-                        </a:rPr>
-                        <a:t>Backtest</a:t>
-                      </a:r>
-                    </a:p>
-                  </a:txBody>
-                  <a:tcPr marL="64008" marR="64008" marT="27432" marB="27432" anchor="ctr">
-                    <a:lnL w="6350" cap="flat" cmpd="sng" algn="ctr">
-                      <a:solidFill>
-                        <a:srgbClr val="E3DED7"/>
-                      </a:solidFill>
-                      <a:prstDash val="solid"/>
-                    </a:lnL>
-                    <a:lnR w="6350" cap="flat" cmpd="sng" algn="ctr">
-                      <a:solidFill>
-                        <a:srgbClr val="E3DED7"/>
-                      </a:solidFill>
-                      <a:prstDash val="solid"/>
-                    </a:lnR>
-                    <a:lnT w="6350" cap="flat" cmpd="sng" algn="ctr">
-                      <a:solidFill>
-                        <a:srgbClr val="E3DED7"/>
-                      </a:solidFill>
-                      <a:prstDash val="solid"/>
-                    </a:lnT>
-                    <a:lnB w="6350" cap="flat" cmpd="sng" algn="ctr">
-                      <a:solidFill>
-                        <a:srgbClr val="E3DED7"/>
-                      </a:solidFill>
-                      <a:prstDash val="solid"/>
-                    </a:lnB>
-                    <a:solidFill>
-                      <a:srgbClr val="F7F5F2"/>
-                    </a:solidFill>
-                  </a:tcPr>
-                </a:tc>
-                <a:tc>
-                  <a:txBody>
-                    <a:bodyPr wrap="square"/>
-                    <a:lstStyle/>
-                    <a:p>
-                      <a:r>
-                        <a:rPr sz="1100" b="0" i="0">
-                          <a:solidFill>
-                            <a:srgbClr val="1A1A1A"/>
-                          </a:solidFill>
-                        </a:rPr>
-                        <a:t>250 days, Basel light, Kupiec, Christoffersen</a:t>
-                      </a:r>
-                    </a:p>
-                  </a:txBody>
-                  <a:tcPr marL="64008" marR="64008" marT="27432" marB="27432" anchor="ctr">
-                    <a:lnL w="6350" cap="flat" cmpd="sng" algn="ctr">
-                      <a:solidFill>
-                        <a:srgbClr val="E3DED7"/>
-                      </a:solidFill>
-                      <a:prstDash val="solid"/>
-                    </a:lnL>
-                    <a:lnR w="6350" cap="flat" cmpd="sng" algn="ctr">
-                      <a:solidFill>
-                        <a:srgbClr val="E3DED7"/>
-                      </a:solidFill>
-                      <a:prstDash val="solid"/>
-                    </a:lnR>
-                    <a:lnT w="6350" cap="flat" cmpd="sng" algn="ctr">
-                      <a:solidFill>
-                        <a:srgbClr val="E3DED7"/>
-                      </a:solidFill>
-                      <a:prstDash val="solid"/>
-                    </a:lnT>
-                    <a:lnB w="6350" cap="flat" cmpd="sng" algn="ctr">
-                      <a:solidFill>
-                        <a:srgbClr val="E3DED7"/>
-                      </a:solidFill>
-                      <a:prstDash val="solid"/>
-                    </a:lnB>
-                    <a:solidFill>
-                      <a:srgbClr val="F7F5F2"/>
                     </a:solidFill>
                   </a:tcPr>
                 </a:tc>

</xml_diff>

<commit_message>
The VaR engine deck says trades or positions wherever both apply
</commit_message>
<xml_diff>
--- a/docs/publications/Drishti-VaR-Engine.pptx
+++ b/docs/publications/Drishti-VaR-Engine.pptx
@@ -8668,7 +8668,7 @@
                   <a:srgbClr val="1A1A1A"/>
                 </a:solidFill>
               </a:rPr>
-              <a:t>the scope as resolved, trades, hidden and unknown ids, batch, data versions, method, tier, timing.</a:t>
+              <a:t>the scope as resolved, its trades and positions, hidden and unknown ids, batch, data versions, method, tier, timing.</a:t>
             </a:r>
           </a:p>
           <a:p>
@@ -8697,7 +8697,7 @@
                   <a:srgbClr val="1A1A1A"/>
                 </a:solidFill>
               </a:rPr>
-              <a:t>any mix of portfolios, trades, counterparties and rules, live; a booked trade's vector × a factor through the Python engine.</a:t>
+              <a:t>any mix of portfolios, positions, trades, counterparties and rules, live; a booked trade's vector × a factor through the Python engine.</a:t>
             </a:r>
           </a:p>
           <a:p>
@@ -9645,7 +9645,7 @@
                   <a:srgbClr val="4A5058"/>
                 </a:solidFill>
               </a:rPr>
-              <a:t>509 doubles = 4,072 B a trade; hot rows float32 (2,036 B); every sum in float64</a:t>
+              <a:t>509 doubles = 4,072 B a trade or position; hot rows float32 (2,036 B); sums in float64</a:t>
             </a:r>
           </a:p>
         </p:txBody>
@@ -10203,7 +10203,7 @@
                   <a:srgbClr val="4A5058"/>
                 </a:solidFill>
               </a:rPr>
-              <a:t>cost ∝ trades changed; Kafka: one commit and one apply per window</a:t>
+              <a:t>cost ∝ rows changed; Kafka: one commit and one apply per window</a:t>
             </a:r>
           </a:p>
         </p:txBody>
@@ -14296,7 +14296,7 @@
                   <a:srgbClr val="1A1A1A"/>
                 </a:solidFill>
               </a:rPr>
-              <a:t>Per changed trade: ≈ 9 node vectors × 5 currency books ≈ 45 additions of 509: microseconds; the lake append dominates (≈ 1 s a batch).</a:t>
+              <a:t>Per changed trade or position: ≈ 9 node vectors × 5 currency books ≈ 45 additions of 509: microseconds; the lake append dominates (≈ 1 s a batch).</a:t>
             </a:r>
           </a:p>
           <a:p>
@@ -19682,7 +19682,7 @@
         <p:spPr>
           <a:xfrm>
             <a:off x="777240" y="1444752"/>
-            <a:ext cx="2432304" cy="987552"/>
+            <a:ext cx="2432304" cy="1024128"/>
           </a:xfrm>
           <a:prstGeom prst="rect">
             <a:avLst/>
@@ -19779,8 +19779,8 @@
         </p:nvSpPr>
         <p:spPr>
           <a:xfrm>
-            <a:off x="1307592" y="1536192"/>
-            <a:ext cx="1828800" cy="365760"/>
+            <a:off x="1307592" y="1499616"/>
+            <a:ext cx="1828800" cy="438912"/>
           </a:xfrm>
           <a:prstGeom prst="rect">
             <a:avLst/>
@@ -19795,12 +19795,12 @@
           <a:p>
             <a:pPr algn="l"/>
             <a:r>
-              <a:rPr sz="1300" b="1" i="0">
+              <a:rPr sz="1250" b="1" i="0">
                 <a:solidFill>
                   <a:srgbClr val="8A1626"/>
                 </a:solidFill>
               </a:rPr>
-              <a:t>A P&amp;L vector per trade</a:t>
+              <a:t>A P&amp;L vector per trade or position</a:t>
             </a:r>
           </a:p>
         </p:txBody>
@@ -19813,8 +19813,8 @@
         </p:nvSpPr>
         <p:spPr>
           <a:xfrm>
-            <a:off x="905256" y="1901952"/>
-            <a:ext cx="2231136" cy="512064"/>
+            <a:off x="905256" y="1975104"/>
+            <a:ext cx="2231136" cy="475488"/>
           </a:xfrm>
           <a:prstGeom prst="rect">
             <a:avLst/>
@@ -19884,7 +19884,7 @@
         <p:spPr>
           <a:xfrm>
             <a:off x="3511296" y="1444752"/>
-            <a:ext cx="2432304" cy="987552"/>
+            <a:ext cx="2432304" cy="1024128"/>
           </a:xfrm>
           <a:prstGeom prst="rect">
             <a:avLst/>
@@ -19981,8 +19981,8 @@
         </p:nvSpPr>
         <p:spPr>
           <a:xfrm>
-            <a:off x="4041648" y="1536192"/>
-            <a:ext cx="1828800" cy="365760"/>
+            <a:off x="4041648" y="1499616"/>
+            <a:ext cx="1828800" cy="438912"/>
           </a:xfrm>
           <a:prstGeom prst="rect">
             <a:avLst/>
@@ -19997,7 +19997,7 @@
           <a:p>
             <a:pPr algn="l"/>
             <a:r>
-              <a:rPr sz="1300" b="1" i="0">
+              <a:rPr sz="1250" b="1" i="0">
                 <a:solidFill>
                   <a:srgbClr val="8A1626"/>
                 </a:solidFill>
@@ -20015,8 +20015,8 @@
         </p:nvSpPr>
         <p:spPr>
           <a:xfrm>
-            <a:off x="3639312" y="1901952"/>
-            <a:ext cx="2231136" cy="512064"/>
+            <a:off x="3639312" y="1975104"/>
+            <a:ext cx="2231136" cy="475488"/>
           </a:xfrm>
           <a:prstGeom prst="rect">
             <a:avLst/>
@@ -20036,7 +20036,7 @@
                   <a:srgbClr val="4A5058"/>
                 </a:solidFill>
               </a:rPr>
-              <a:t>any scope is a set of trades; overlaps count once, longs and shorts net</a:t>
+              <a:t>a set of trades or positions; overlaps once; longs and shorts net</a:t>
             </a:r>
           </a:p>
         </p:txBody>
@@ -20086,7 +20086,7 @@
         <p:spPr>
           <a:xfrm>
             <a:off x="6245352" y="1444752"/>
-            <a:ext cx="2432304" cy="987552"/>
+            <a:ext cx="2432304" cy="1024128"/>
           </a:xfrm>
           <a:prstGeom prst="rect">
             <a:avLst/>
@@ -20183,8 +20183,8 @@
         </p:nvSpPr>
         <p:spPr>
           <a:xfrm>
-            <a:off x="6775704" y="1536192"/>
-            <a:ext cx="1828800" cy="365760"/>
+            <a:off x="6775704" y="1499616"/>
+            <a:ext cx="1828800" cy="438912"/>
           </a:xfrm>
           <a:prstGeom prst="rect">
             <a:avLst/>
@@ -20199,7 +20199,7 @@
           <a:p>
             <a:pPr algn="l"/>
             <a:r>
-              <a:rPr sz="1300" b="1" i="0">
+              <a:rPr sz="1250" b="1" i="0">
                 <a:solidFill>
                   <a:srgbClr val="8A1626"/>
                 </a:solidFill>
@@ -20217,8 +20217,8 @@
         </p:nvSpPr>
         <p:spPr>
           <a:xfrm>
-            <a:off x="6373368" y="1901952"/>
-            <a:ext cx="2231136" cy="512064"/>
+            <a:off x="6373368" y="1975104"/>
+            <a:ext cx="2231136" cy="475488"/>
           </a:xfrm>
           <a:prstGeom prst="rect">
             <a:avLst/>
@@ -20288,7 +20288,7 @@
         <p:spPr>
           <a:xfrm>
             <a:off x="8979408" y="1444752"/>
-            <a:ext cx="2432304" cy="987552"/>
+            <a:ext cx="2432304" cy="1024128"/>
           </a:xfrm>
           <a:prstGeom prst="rect">
             <a:avLst/>
@@ -20385,8 +20385,8 @@
         </p:nvSpPr>
         <p:spPr>
           <a:xfrm>
-            <a:off x="9509760" y="1536192"/>
-            <a:ext cx="1828800" cy="365760"/>
+            <a:off x="9509760" y="1499616"/>
+            <a:ext cx="1828800" cy="438912"/>
           </a:xfrm>
           <a:prstGeom prst="rect">
             <a:avLst/>
@@ -20401,7 +20401,7 @@
           <a:p>
             <a:pPr algn="l"/>
             <a:r>
-              <a:rPr sz="1300" b="1" i="0">
+              <a:rPr sz="1250" b="1" i="0">
                 <a:solidFill>
                   <a:srgbClr val="8A1626"/>
                 </a:solidFill>
@@ -20419,8 +20419,8 @@
         </p:nvSpPr>
         <p:spPr>
           <a:xfrm>
-            <a:off x="9107424" y="1901952"/>
-            <a:ext cx="2231136" cy="512064"/>
+            <a:off x="9107424" y="1975104"/>
+            <a:ext cx="2231136" cy="475488"/>
           </a:xfrm>
           <a:prstGeom prst="rect">
             <a:avLst/>
@@ -28237,7 +28237,7 @@
                   <a:srgbClr val="4A5058"/>
                 </a:solidFill>
               </a:rPr>
-              <a:t>Changed trades only (RUN_KIND INTRADAY): small JSONL files, or a Kafka PV topic, 5-min micro-batches</a:t>
+              <a:t>Changed trades or positions only (RUN_KIND INTRADAY): small JSONL files, or a Kafka PV topic, 5-min micro-batches</a:t>
             </a:r>
           </a:p>
         </p:txBody>
@@ -29164,7 +29164,7 @@
                   <a:srgbClr val="4A5058"/>
                 </a:solidFill>
               </a:rPr>
-              <a:t>Latest COMPUTED_AT per trade wins; no reload of the date</a:t>
+              <a:t>Latest COMPUTED_AT per trade or position wins; no reload</a:t>
             </a:r>
           </a:p>
         </p:txBody>
@@ -32355,7 +32355,7 @@
                   <a:srgbClr val="4A5058"/>
                 </a:solidFill>
               </a:rPr>
-              <a:t>changed trades only, as new − old; latest wins</a:t>
+              <a:t>changed trades or positions, as new − old; latest wins</a:t>
             </a:r>
           </a:p>
         </p:txBody>
@@ -33101,7 +33101,7 @@
           <a:lstStyle/>
           <a:p>
             <a:r>
-              <a:t>From scenario PVs in each trade's currency to VaR in any currency</a:t>
+              <a:t>From scenario PVs in their own currency to VaR in any currency</a:t>
             </a:r>
           </a:p>
         </p:txBody>
@@ -33249,7 +33249,7 @@
                   <a:srgbClr val="1A1A1A"/>
                 </a:solidFill>
               </a:rPr>
-              <a:t>Pricing systems send each trade's 509 scenario PVs and base PV in the trade's own currency (</a:t>
+              <a:t>Pricing systems send each trade's or position's 509 scenario PVs and base PV in its own currency (</a:t>
             </a:r>
             <a:r>
               <a:rPr sz="1100" b="0" i="0">
@@ -33266,7 +33266,7 @@
                   <a:srgbClr val="1A1A1A"/>
                 </a:solidFill>
               </a:rPr>
-              <a:t>). The USD P&amp;L-vector form stays supported; a date may mix both, a trade in one form.</a:t>
+              <a:t>). The USD P&amp;L-vector form stays supported; a date may mix both, each row in one form.</a:t>
             </a:r>
           </a:p>
           <a:p>
@@ -33322,7 +33322,7 @@
                   <a:srgbClr val="1A1A1A"/>
                 </a:solidFill>
               </a:rPr>
-              <a:t>Converted when the date loads; positions, nodes, captures and official records do not know which form a trade came in.</a:t>
+              <a:t>Converted when the date loads; positions, nodes, captures and official records do not know which form a row came in.</a:t>
             </a:r>
           </a:p>
         </p:txBody>
@@ -34740,7 +34740,7 @@
           <a:lstStyle/>
           <a:p>
             <a:r>
-              <a:t>Intraday: only the changed trades, applied as new − old up the tree</a:t>
+              <a:t>Intraday: only what changed, applied as new − old up the tree</a:t>
             </a:r>
           </a:p>
         </p:txBody>
@@ -34924,7 +34924,7 @@
                   <a:srgbClr val="4A5058"/>
                 </a:solidFill>
               </a:rPr>
-              <a:t>RUN_KIND FULL: every live trade; the date loads, hot file built; official records taken from it</a:t>
+              <a:t>RUN_KIND FULL: every live trade or position; the date loads; official records taken from it</a:t>
             </a:r>
           </a:p>
         </p:txBody>
@@ -35044,7 +35044,7 @@
                   <a:srgbClr val="8A1626"/>
                 </a:solidFill>
               </a:rPr>
-              <a:t>Changed trades</a:t>
+              <a:t>Changed rows</a:t>
             </a:r>
           </a:p>
           <a:p>
@@ -35055,7 +35055,7 @@
                   <a:srgbClr val="4A5058"/>
                 </a:solidFill>
               </a:rPr>
-              <a:t>Amended, new, cancelled; same scenario set; own BATCH_ID, later COMPUTED_AT</a:t>
+              <a:t>Trades or positions amended, new, cancelled; same scenario set; own BATCH_ID, later COMPUTED_AT</a:t>
             </a:r>
           </a:p>
         </p:txBody>
@@ -35759,7 +35759,7 @@
                             <a:srgbClr val="8A1626"/>
                           </a:solidFill>
                         </a:rPr>
-                        <a:t>Same trade in several batches</a:t>
+                        <a:t>Same trade or position, several batches</a:t>
                       </a:r>
                     </a:p>
                   </a:txBody>
@@ -35988,7 +35988,7 @@
                             <a:srgbClr val="1A1A1A"/>
                           </a:solidFill>
                         </a:rPr>
-                        <a:t>trade removed from every scope</a:t>
+                        <a:t>removed from every scope</a:t>
                       </a:r>
                     </a:p>
                   </a:txBody>
@@ -36734,7 +36734,7 @@
                   <a:srgbClr val="4A5058"/>
                 </a:solidFill>
               </a:rPr>
-              <a:t>Cost of a batch ∝ trades changed × nodes above × currencies built, never the size of the book.</a:t>
+              <a:t>Cost of a batch ∝ rows changed × nodes above × currencies built, never the size of the book.</a:t>
             </a:r>
           </a:p>
         </p:txBody>

</xml_diff>

<commit_message>
The VaR engine deck sized for 2.3 million positions and 15,000 portfolios (every derived figure recomputed; estimates scaled from the 100,000-trade measurements)
</commit_message>
<xml_diff>
--- a/docs/publications/Drishti-VaR-Engine.pptx
+++ b/docs/publications/Drishti-VaR-Engine.pptx
@@ -764,7 +764,7 @@
           <a:p/>
           <a:p>
             <a:r>
-              <a:t>Talk track: this deck explains the VaR engine that sits inside the Drishti server: what it computes, how the data reaches it, what the 2.9.4 release adds (scenario PVs in each trade's own currency, any reporting currency, intraday updates, JSONL as the delivery standard), what the console shows, and how it scales to a bank of 1.3 million positions and 100,000 portfolios.</a:t>
+              <a:t>Talk track: this deck explains the VaR engine that sits inside the Drishti server: what it computes, how the data reaches it, what the 2.9.4 release adds (scenario PVs in each trade's own currency, any reporting currency, intraday updates, JSONL as the delivery standard), what the console shows, and how it scales to a bank of 2.3 million positions and 15,000 portfolios.</a:t>
             </a:r>
           </a:p>
           <a:p/>
@@ -1132,37 +1132,37 @@
           <a:lstStyle/>
           <a:p>
             <a:r>
-              <a:t>Arithmetic and bases (all decimal GB). Vectors: 1,300,000 × 509 × 8 bytes = 5,293,600,000 B = 5.29 GB per date per currency in float64; float32 halves it to 2.65 GB. Hot file: VarTierBenchmark measured 237.7 MB per date for 100,000 trades (203.6 MB of float32 rows plus aggregates of 2,100 books and nodes, columns and ids), scaled × 13. Heap: about 80 MB per open date per 100,000 trades measured, × 13 ≈ 1.0 GB; with hot-dates 2 about 2.1 GB. First load: 0.8–1.2 s per 100,000 measured (the sort is n log n, so slightly more than linear), plus the lake read: the guide estimates 10 to 40 s for a cold whole-bank read of about 4 GB of Parquet on one server. Reopening: 23 ms per 100,000. Whole bank resident: 3.4 ms for 203.6 MB measured (≈ 60 GB/s), so 2.65 GB ≈ 45 ms; cold from NVMe at about 3 GB/s ≈ 0.9 s (the guide's own basis). A node: 0.48 ms measured, independent of size.</a:t>
+              <a:t>Arithmetic and bases (all decimal GB; scale factor 2,300,000 / 100,000 = 23). Vectors: 2,300,000 × 509 × 8 bytes = 9,365,600,000 B = 9.37 GB per date per currency in float64; float32 halves it to 4.68 GB. Hot file: VarTierBenchmark measured 237.7 MB per date for 100,000 trades (203.6 MB of float32 rows plus aggregates of 2,100 books and nodes, columns and ids), × 23 ≈ 5,467 MB ≈ 5.5 GB. Heap: about 80 MB per open date per 100,000 trades measured, × 23 ≈ 1.8 GB; with hot-dates 2 about 3.7 GB. First load: 0.8–1.2 s per 100,000 measured, × 23 ≈ 18–28 s (the sort is n log n, so slightly more than linear), plus the lake read: the guide estimates 10 to 40 s for a cold whole-bank read of about 4 GB of Parquet on one server, so about 18 to 70 s for the 7 GB here. Reopening: 23 ms per 100,000, × 23 ≈ 0.5 s. Whole bank resident: 3.4 ms for 203.6 MB measured (≈ 60 GB/s), so 4.68 GB ≈ 78 ms; cold from NVMe at about 3 GB/s ≈ 1.6 s (the guide's own basis). A node: 0.48 ms measured, independent of size.</a:t>
             </a:r>
           </a:p>
           <a:p/>
           <a:p>
             <a:r>
-              <a:t>Currencies built ahead (VAR_GUIDE 15.11, measured on the demo lake 2026-10-27): 21.4 MB a currency a date for 8,566 trades; the guide's linear extrapolation is 250 MB a currency per 100,000 trades, 1.0 GB for four, 5.0 GB for the 5 retained dates, and about 4.3 s to build the four in the background. Scaled × 13: ≈ 3.25 GB a currency, ≈ 13 GB a date for four, ≈ 65 GB for five dates, ≈ 56 s background build. (A figure of 1.6 GB per 100,000 trades for four currencies was mentioned in the brief; the guide says 1.0 GB per date, 5.0 GB over the 5 retained dates, so the guide's numbers are used.) USD hot files: disk-dates 60 × ≈ 3.1 GB ≈ 185 GB of local disk (lower disk-dates to need less). Lake: Parquet ≈ 0.75 × raw (the design's estimate), × 252 business dates ≈ 1.0 TB a year, ≈ 7 TB for the 7 years kept.</a:t>
+              <a:t>Currencies built ahead (VAR_GUIDE 15.11, measured on the demo lake 2026-10-27): 21.4 MB a currency a date for 8,566 trades; the guide's linear extrapolation is 250 MB a currency per 100,000 trades, 1.0 GB for four, 5.0 GB for the 5 retained dates, and about 4.3 s to build the four in the background. × 23: ≈ 5.75 GB a currency, ≈ 23 GB a date for four, ≈ 115 GB for the five retained dates, ≈ 99 s background build. USD hot files: disk-dates 60 × ≈ 5.5 GB ≈ 330 GB of local disk (lower disk-dates to need less). Lake: Parquet ≈ 0.75 × raw (the design's estimate): 9.37 GB × 0.75 ≈ 7.0 GB a date, × 252 business dates ≈ 1.8 TB a year, ≈ 12.4 TB for the 7 years kept.</a:t>
             </a:r>
           </a:p>
           <a:p/>
           <a:p>
             <a:r>
-              <a:t>100,000 portfolios: the cost of computing every portfolio's vector is the sum over portfolios of their position counts × 509. The average size is not known, so 130 positions is an assumption for illustration (13 million row reads, 26.5 GB of float32 rows). Sequential reads at the measured 60 GB/s give ≈ 0.45 s; scattered reads at the design's 5 GB/s effective give ≈ 5 s; both per currency, both estimated. Roll-ups save most of it: a HIERARCHY portfolio is a node, answered from its aggregate; a portfolio covering whole books costs one addition per book; the planner takes a node's aggregate minus the missing rows when at most max(16, covered/8) are missing (built). Sharing sub-sums across portfolios (sum each book or common sleeve once and reuse it) beyond the hierarchy aggregates is a proposal. Storing every portfolio vector: 100,000 × 509 × 8 B = 407 MB a date a currency, ≈ 2.0 GB for five currencies, half in float32 (proposed; today only captures keep a vector).</a:t>
+              <a:t>15,000 portfolios: the cost of computing every portfolio's vector is the sum over portfolios of their position counts × 509. The average size is not known, so 300 positions is an assumption for illustration (portfolios overlap, so together they reference about twice the bank's positions): 4.5 million row reads, 9.2 GB of float32 rows (4.5M × 2,036 B). Sequential reads at the measured 60 GB/s give ≈ 0.15 s; scattered reads at the design's 5 GB/s effective give ≈ 1.8 s; both per currency, both estimated. Roll-ups save most of it: a HIERARCHY portfolio is a node, answered from its aggregate; a portfolio covering whole books costs one addition per book; the planner takes a node's aggregate minus the missing rows when at most max(16, covered/8) are missing (built). Sharing sub-sums across portfolios (sum each book or common sleeve once and reuse it) beyond the hierarchy aggregates is a proposal. Storing every portfolio vector: 15,000 × 509 × 8 B ≈ 61 MB a date a currency, ≈ 305 MB for five currencies, about 31 MB a currency in float32 (proposed; today only captures keep a vector). 15,000 portfolio rows are within the loader's 100,000-row read limit for a connector that cannot list a date whole.</a:t>
             </a:r>
           </a:p>
           <a:p/>
           <a:p>
             <a:r>
-              <a:t>Per-trade-currency totals: each node keeps, per trade currency, the 509 scenario PV sums and today's sum (510 float64 = 4 KB). With an assumed 5,000 nodes × 10 currencies on average: ≈ 204 MB. A headline in any currency is then a sum over the node's trade currencies of 509 multiply-adds: microseconds.</a:t>
+              <a:t>Per-trade-currency totals: each node keeps, per trade currency, the 509 scenario PV sums and today's sum (510 float64 = 4 KB). With an assumed 5,000 nodes × 10 currencies on average: ≈ 204 MB, independent of the position count. A headline in any currency is then a sum over the node's trade currencies of 509 multiply-adds: microseconds.</a:t>
             </a:r>
           </a:p>
           <a:p/>
           <a:p>
             <a:r>
-              <a:t>Intraday per changed trade, in a four-level tree: its book aggregate and the nodes above it in MGMT and LEGAL (about 9 vectors), in USD and the 4 built currencies (≈ 45 vector additions of 509 numbers, plus the trade-currency totals): microseconds. The measured cost of a batch is dominated by the lake (its 1-second refresh in VarIntradayApiTest); with tiered memory the old row is read back from the lake by its id for an exact subtraction.</a:t>
+              <a:t>Intraday per changed trade or position, in a four-level tree: its book aggregate and the nodes above it in MGMT and LEGAL (about 9 vectors), in USD and the 4 built currencies (≈ 45 vector additions of 509 numbers, plus the trade-currency totals): microseconds. The measured cost of a batch is dominated by the lake (its 1-second refresh in VarIntradayApiTest); with tiered memory the old row is read back from the lake by its id for an exact subtraction.</a:t>
             </a:r>
           </a:p>
           <a:p/>
           <a:p>
             <a:r>
-              <a:t>Position grain: if the bank sends 1.3M positions, rows equal positions, so no trade matrix (TMAT) is needed and the vector count is bounded by positions, not trades.</a:t>
+              <a:t>Position grain: if the bank sends 2.3M positions, rows equal positions, so no trade matrix (TMAT) is needed and the vector count is bounded by positions, not trades.</a:t>
             </a:r>
           </a:p>
         </p:txBody>
@@ -1250,13 +1250,13 @@
           <a:p/>
           <a:p>
             <a:r>
-              <a:t>Proposed by this deck (not in the docs): Z-order or liquid clustering by book and portfolio; a published Delta table of node and portfolio vectors per currency (BI and other servers read sums instead of 1.3M rows); the change data feed on the input tables for downstream followers; one designated node computing the official end-of-day records (drishti.var.official.enabled true there, DRISHTI_VAR_OFFICIAL=false elsewhere) while read replicas serve the UI.</a:t>
+              <a:t>Proposed by this deck (not in the docs): Z-order or liquid clustering by book and portfolio; a published Delta table of node and portfolio vectors per currency (BI and other servers read sums instead of 2.3M rows); the change data feed on the input tables for downstream followers; one designated node computing the official end-of-day records (drishti.var.official.enabled true there, DRISHTI_VAR_OFFICIAL=false elsewhere) while read replicas serve the UI.</a:t>
             </a:r>
           </a:p>
           <a:p/>
           <a:p>
             <a:r>
-              <a:t>The gap list in full: (1) run the 1M × 50 benchmark (and 1.3M × 60) on a real server, including a cold first touch of a history date; (2) build VaR sharding across Drishti*net; (3) the lake layout at bank scale (sort by hierarchy, partition by scenario set, file and row-group sizes, BYTE_STREAM_SPLIT + ZSTD); (4) a batch that builds every portfolio vector (the designed overnight precomputation), raise the 100,000-row read limit for portfolios and nodes, and size max-parts (5,000) for contribution tables; (5) Iceberg for VaR and exposure inputs (SourcePlugin.vectors() in the Iceberg plugin); (6) official results published to an s3:// root (today a local or EFS Delta root only; an s3:// root fails and is recorded as publishError); (7) several consoles without sticky sessions. Position grain and Kafka micro-batching are built in 2.9.4 and no longer gaps.</a:t>
+              <a:t>The gap list in full: (1) run the 1M × 50 benchmark (and 2.3M × 60) on a real server, including a cold first touch of a history date; (2) build VaR sharding across Drishti*net; (3) the lake layout at bank scale (sort by hierarchy, partition by scenario set, file and row-group sizes, BYTE_STREAM_SPLIT + ZSTD); (4) a batch that builds every portfolio vector (the designed overnight precomputation), 15,000 portfolios are within the 100,000-row read limit; size max-parts (5,000) for contribution tables; (5) Iceberg for VaR and exposure inputs (SourcePlugin.vectors() in the Iceberg plugin); (6) official results published to an s3:// root (today a local or EFS Delta root only; an s3:// root fails and is recorded as publishError); (7) several consoles without sticky sessions. Position grain and Kafka micro-batching are built in 2.9.4 and no longer gaps.</a:t>
             </a:r>
           </a:p>
         </p:txBody>
@@ -11321,7 +11321,7 @@
           <a:lstStyle/>
           <a:p>
             <a:r>
-              <a:t>SIZING · 1.3 MILLION POSITIONS, 100,000 PORTFOLIOS</a:t>
+              <a:t>SIZING · 2.3 MILLION POSITIONS, 15,000 PORTFOLIOS</a:t>
             </a:r>
           </a:p>
         </p:txBody>
@@ -11455,9 +11455,9 @@
                 <a:tableStyleId>{5940675A-B579-460E-94D1-54222C63F5DA}</a:tableStyleId>
               </a:tblPr>
               <a:tblGrid>
-                <a:gridCol w="2377440"/>
+                <a:gridCol w="2286000"/>
                 <a:gridCol w="2194560"/>
-                <a:gridCol w="1417320"/>
+                <a:gridCol w="1508760"/>
                 <a:gridCol w="914400"/>
               </a:tblGrid>
               <a:tr h="292608">
@@ -11699,7 +11699,7 @@
                             <a:srgbClr val="1A1A1A"/>
                           </a:solidFill>
                         </a:rPr>
-                        <a:t>1.3M × 509 × 8 B</a:t>
+                        <a:t>2.3M × 509 × 8 B</a:t>
                       </a:r>
                     </a:p>
                   </a:txBody>
@@ -11744,7 +11744,7 @@
                             <a:srgbClr val="1A1A1A"/>
                           </a:solidFill>
                         </a:rPr>
-                        <a:t>5.29 GB</a:t>
+                        <a:t>9.37 GB</a:t>
                       </a:r>
                     </a:p>
                   </a:txBody>
@@ -11881,7 +11881,7 @@
                             <a:srgbClr val="1A1A1A"/>
                           </a:solidFill>
                         </a:rPr>
-                        <a:t>1.3M × 509 × 4 B</a:t>
+                        <a:t>2.3M × 509 × 4 B</a:t>
                       </a:r>
                     </a:p>
                   </a:txBody>
@@ -11926,7 +11926,7 @@
                             <a:srgbClr val="1A1A1A"/>
                           </a:solidFill>
                         </a:rPr>
-                        <a:t>2.65 GB</a:t>
+                        <a:t>4.68 GB</a:t>
                       </a:r>
                     </a:p>
                   </a:txBody>
@@ -12063,7 +12063,7 @@
                             <a:srgbClr val="1A1A1A"/>
                           </a:solidFill>
                         </a:rPr>
-                        <a:t>237.7 MB per 100k × 13</a:t>
+                        <a:t>237.7 MB per 100k × 23</a:t>
                       </a:r>
                     </a:p>
                   </a:txBody>
@@ -12108,7 +12108,7 @@
                             <a:srgbClr val="1A1A1A"/>
                           </a:solidFill>
                         </a:rPr>
-                        <a:t>≈ 3.1 GB</a:t>
+                        <a:t>≈ 5.5 GB</a:t>
                       </a:r>
                     </a:p>
                   </a:txBody>
@@ -12245,7 +12245,7 @@
                             <a:srgbClr val="1A1A1A"/>
                           </a:solidFill>
                         </a:rPr>
-                        <a:t>≈ 80 MB per 100k × 13</a:t>
+                        <a:t>≈ 80 MB per 100k × 23</a:t>
                       </a:r>
                     </a:p>
                   </a:txBody>
@@ -12290,7 +12290,7 @@
                             <a:srgbClr val="1A1A1A"/>
                           </a:solidFill>
                         </a:rPr>
-                        <a:t>≈ 1.0 GB</a:t>
+                        <a:t>≈ 1.8 GB</a:t>
                       </a:r>
                     </a:p>
                   </a:txBody>
@@ -12427,7 +12427,7 @@
                             <a:srgbClr val="1A1A1A"/>
                           </a:solidFill>
                         </a:rPr>
-                        <a:t>0.8–1.2 s per 100k × 13</a:t>
+                        <a:t>0.8–1.2 s per 100k × 23</a:t>
                       </a:r>
                     </a:p>
                   </a:txBody>
@@ -12472,7 +12472,7 @@
                             <a:srgbClr val="1A1A1A"/>
                           </a:solidFill>
                         </a:rPr>
-                        <a:t>≈ 10–16 s</a:t>
+                        <a:t>≈ 18–28 s</a:t>
                       </a:r>
                     </a:p>
                   </a:txBody>
@@ -12609,7 +12609,7 @@
                             <a:srgbClr val="1A1A1A"/>
                           </a:solidFill>
                         </a:rPr>
-                        <a:t>23 ms per 100k × 13</a:t>
+                        <a:t>23 ms per 100k × 23</a:t>
                       </a:r>
                     </a:p>
                   </a:txBody>
@@ -12654,7 +12654,7 @@
                             <a:srgbClr val="1A1A1A"/>
                           </a:solidFill>
                         </a:rPr>
-                        <a:t>≈ 0.3 s</a:t>
+                        <a:t>≈ 0.5 s</a:t>
                       </a:r>
                     </a:p>
                   </a:txBody>
@@ -12791,7 +12791,7 @@
                             <a:srgbClr val="1A1A1A"/>
                           </a:solidFill>
                         </a:rPr>
-                        <a:t>2.65 GB at ≈ 60 GB/s</a:t>
+                        <a:t>4.68 GB at ≈ 60 GB/s</a:t>
                       </a:r>
                     </a:p>
                   </a:txBody>
@@ -12836,7 +12836,7 @@
                             <a:srgbClr val="1A1A1A"/>
                           </a:solidFill>
                         </a:rPr>
-                        <a:t>≈ 45 ms</a:t>
+                        <a:t>≈ 80 ms</a:t>
                       </a:r>
                     </a:p>
                   </a:txBody>
@@ -12973,7 +12973,7 @@
                             <a:srgbClr val="1A1A1A"/>
                           </a:solidFill>
                         </a:rPr>
-                        <a:t>2.65 GB at ≈ 3 GB/s</a:t>
+                        <a:t>4.68 GB at ≈ 3 GB/s</a:t>
                       </a:r>
                     </a:p>
                   </a:txBody>
@@ -13018,7 +13018,7 @@
                             <a:srgbClr val="1A1A1A"/>
                           </a:solidFill>
                         </a:rPr>
-                        <a:t>≈ 0.9 s</a:t>
+                        <a:t>≈ 1.6 s</a:t>
                       </a:r>
                     </a:p>
                   </a:txBody>
@@ -13337,7 +13337,7 @@
                             <a:srgbClr val="1A1A1A"/>
                           </a:solidFill>
                         </a:rPr>
-                        <a:t>250 MB × 4 per 100k × 13</a:t>
+                        <a:t>250 MB × 4 per 100k × 23</a:t>
                       </a:r>
                     </a:p>
                   </a:txBody>
@@ -13382,7 +13382,7 @@
                             <a:srgbClr val="1A1A1A"/>
                           </a:solidFill>
                         </a:rPr>
-                        <a:t>≈ 13 GB a date</a:t>
+                        <a:t>≈ 23 GB a date</a:t>
                       </a:r>
                     </a:p>
                   </a:txBody>
@@ -13519,7 +13519,7 @@
                             <a:srgbClr val="1A1A1A"/>
                           </a:solidFill>
                         </a:rPr>
-                        <a:t>13 GB × 5; 4.3 s per 100k × 13</a:t>
+                        <a:t>23 GB × 5; 4.3 s per 100k × 23</a:t>
                       </a:r>
                     </a:p>
                   </a:txBody>
@@ -13564,7 +13564,7 @@
                             <a:srgbClr val="1A1A1A"/>
                           </a:solidFill>
                         </a:rPr>
-                        <a:t>≈ 65 GB; ≈ 56 s</a:t>
+                        <a:t>≈ 115 GB; ≈ 99 s</a:t>
                       </a:r>
                     </a:p>
                   </a:txBody>
@@ -13701,7 +13701,7 @@
                             <a:srgbClr val="1A1A1A"/>
                           </a:solidFill>
                         </a:rPr>
-                        <a:t>3.1 GB × 60</a:t>
+                        <a:t>5.5 GB × 60</a:t>
                       </a:r>
                     </a:p>
                   </a:txBody>
@@ -13746,7 +13746,7 @@
                             <a:srgbClr val="1A1A1A"/>
                           </a:solidFill>
                         </a:rPr>
-                        <a:t>≈ 185 GB disk</a:t>
+                        <a:t>≈ 330 GB disk</a:t>
                       </a:r>
                     </a:p>
                   </a:txBody>
@@ -13883,7 +13883,7 @@
                             <a:srgbClr val="1A1A1A"/>
                           </a:solidFill>
                         </a:rPr>
-                        <a:t>5.29 GB × 0.75 × 252</a:t>
+                        <a:t>9.37 GB × 0.75 × 252</a:t>
                       </a:r>
                     </a:p>
                   </a:txBody>
@@ -13928,7 +13928,7 @@
                             <a:srgbClr val="1A1A1A"/>
                           </a:solidFill>
                         </a:rPr>
-                        <a:t>≈ 1 TB; ≈ 7 TB in 7 y</a:t>
+                        <a:t>≈ 1.8 TB; ≈ 12 TB in 7 y</a:t>
                       </a:r>
                     </a:p>
                   </a:txBody>
@@ -14091,7 +14091,7 @@
                   <a:srgbClr val="A51C30"/>
                 </a:solidFill>
               </a:rPr>
-              <a:t>100,000 portfolios</a:t>
+              <a:t>15,000 portfolios</a:t>
             </a:r>
           </a:p>
           <a:p>
@@ -14133,7 +14133,7 @@
                   <a:srgbClr val="1A1A1A"/>
                 </a:solidFill>
               </a:rPr>
-              <a:t>At 130 positions each (assumed): 13M rows, 26.5 GB of float32 → ≈ 0.45 s at 60 GB/s, ≈ 5 s scattered; per currency, estimated.</a:t>
+              <a:t>At 300 positions each (assumed): 4.5M rows, 9.2 GB of float32 → ≈ 0.15 s at 60 GB/s, ≈ 1.8 s scattered; per currency, estimated.</a:t>
             </a:r>
           </a:p>
           <a:p>
@@ -14172,7 +14172,7 @@
                   <a:srgbClr val="1A1A1A"/>
                 </a:solidFill>
               </a:rPr>
-              <a:t>Store them: 100k × 509 × 8 B = 407 MB a date a currency; float32 halves it (proposed).</a:t>
+              <a:t>Store them: 15k × 509 × 8 B ≈ 61 MB a date a currency; float32 halves it (proposed).</a:t>
             </a:r>
           </a:p>
         </p:txBody>
@@ -14356,7 +14356,7 @@
                   <a:srgbClr val="4A5058"/>
                 </a:solidFill>
               </a:rPr>
-              <a:t>Estimated = scaled linearly from the measured 100,000-trade figures (VAR_GUIDE 27.3, 15.11); not measured at 1.3M.</a:t>
+              <a:t>Estimated = scaled linearly (× 23) from the measured 100,000-trade figures (VAR_GUIDE 27.3, 15.11); not measured at 2.3M.</a:t>
             </a:r>
           </a:p>
         </p:txBody>
@@ -15332,7 +15332,7 @@
                   <a:srgbClr val="4A5058"/>
                 </a:solidFill>
               </a:rPr>
-              <a:t>BI and peers read sums, not 1.3M rows</a:t>
+              <a:t>BI and peers read sums, not 2.3M rows</a:t>
             </a:r>
           </a:p>
         </p:txBody>
@@ -17288,7 +17288,7 @@
                   <a:srgbClr val="A51C30"/>
                 </a:solidFill>
               </a:rPr>
-              <a:t>To reach 1.3M positions and 100,000 portfolios, still to build</a:t>
+              <a:t>To reach 2.3M positions and 15,000 portfolios, still to build</a:t>
             </a:r>
           </a:p>
         </p:txBody>
@@ -17326,7 +17326,7 @@
                   <a:srgbClr val="1A1A1A"/>
                 </a:solidFill>
               </a:rPr>
-              <a:t>1  The 1M × 50 benchmark (and 1.3M) on a real server</a:t>
+              <a:t>1  The 1M × 50 benchmark (and 2.3M) on a real server</a:t>
             </a:r>
           </a:p>
           <a:p>
@@ -17371,7 +17371,7 @@
                   <a:srgbClr val="1A1A1A"/>
                 </a:solidFill>
               </a:rPr>
-              <a:t>4  Portfolio vectors in a batch; &gt; 100,000 rows read</a:t>
+              <a:t>4  The 15,000 portfolio vectors built in a batch</a:t>
             </a:r>
           </a:p>
         </p:txBody>
@@ -19519,7 +19519,7 @@
                   <a:srgbClr val="1A1A1A"/>
                 </a:solidFill>
               </a:rPr>
-              <a:t>Measured: 1 million rows summed in 58 ms (heap tier); 100,000 × 5 dates on the tiered store, a node in 0.48 ms. Sized for 1.3M positions and 100,000 portfolios on slides 12-13; sharding is designed, not built.</a:t>
+              <a:t>Measured: 1 million rows summed in 58 ms (heap tier); 100,000 × 5 dates on the tiered store, a node in 0.48 ms. Sized for 2.3M positions and 15,000 portfolios on slides 12-13; sharding is designed, not built.</a:t>
             </a:r>
           </a:p>
         </p:txBody>

</xml_diff>

<commit_message>
The VaR engine deck's portfolio cost assumes 130 positions a portfolio, as the companion deck
</commit_message>
<xml_diff>
--- a/docs/publications/Drishti-VaR-Engine.pptx
+++ b/docs/publications/Drishti-VaR-Engine.pptx
@@ -1144,7 +1144,7 @@
           <a:p/>
           <a:p>
             <a:r>
-              <a:t>15,000 portfolios: the cost of computing every portfolio's vector is the sum over portfolios of their position counts × 509. The average size is not known, so 300 positions is an assumption for illustration (portfolios overlap, so together they reference about twice the bank's positions): 4.5 million row reads, 9.2 GB of float32 rows (4.5M × 2,036 B). Sequential reads at the measured 60 GB/s give ≈ 0.15 s; scattered reads at the design's 5 GB/s effective give ≈ 1.8 s; both per currency, both estimated. Roll-ups save most of it: a HIERARCHY portfolio is a node, answered from its aggregate; a portfolio covering whole books costs one addition per book; the planner takes a node's aggregate minus the missing rows when at most max(16, covered/8) are missing (built). Sharing sub-sums across portfolios (sum each book or common sleeve once and reuse it) beyond the hierarchy aggregates is a proposal. Storing every portfolio vector: 15,000 × 509 × 8 B ≈ 61 MB a date a currency, ≈ 305 MB for five currencies, about 31 MB a currency in float32 (proposed; today only captures keep a vector). 15,000 portfolio rows are within the loader's 100,000-row read limit for a connector that cannot list a date whole.</a:t>
+              <a:t>15,000 portfolios: the cost of computing every portfolio's vector is the sum over portfolios of their position counts × 509. The average size is not known: 130 positions per portfolio is an assumption (it roughly matches 2.3M positions each sitting in about one portfolio, and the same assumption as the companion deck): 15,000 × 130 = 1.95 million row reads, 1.95M × 2,036 B ≈ 3.97 GB of float32 rows. Sequential reads at the measured 60 GB/s give ≈ 0.07 s; scattered reads at the design's 5 GB/s effective give ≈ 0.8 s; both per currency, both estimated. Roll-ups save most of it: a HIERARCHY portfolio is a node, answered from its aggregate; a portfolio covering whole books costs one addition per book; the planner takes a node's aggregate minus the missing rows when at most max(16, covered/8) are missing (built). Sharing sub-sums across portfolios (sum each book or common sleeve once and reuse it) beyond the hierarchy aggregates is a proposal. Storing every portfolio vector: 15,000 × 509 × 8 B ≈ 61 MB a date a currency, ≈ 305 MB for five currencies, about 31 MB a currency in float32 (proposed; today only captures keep a vector). 15,000 portfolio rows are within the loader's 100,000-row read limit for a connector that cannot list a date whole.</a:t>
             </a:r>
           </a:p>
           <a:p/>
@@ -14133,7 +14133,7 @@
                   <a:srgbClr val="1A1A1A"/>
                 </a:solidFill>
               </a:rPr>
-              <a:t>At 300 positions each (assumed): 4.5M rows, 9.2 GB of float32 → ≈ 0.15 s at 60 GB/s, ≈ 1.8 s scattered; per currency, estimated.</a:t>
+              <a:t>Assumed 130 positions each: 1.95M rows, 3.97 GB of float32 → ≈ 0.07 s at 60 GB/s, ≈ 0.8 s scattered; per currency, estimated.</a:t>
             </a:r>
           </a:p>
           <a:p>

</xml_diff>